<commit_message>
articles: NemotronH on vLLM Neuron plugin: who calls whom at startup and every step
</commit_message>
<xml_diff>
--- a/diagrams/articles/162e5225ba1c9b-figures.pptx
+++ b/diagrams/articles/162e5225ba1c9b-figures.pptx
@@ -21,6 +21,8 @@
     <p:sldId id="263" r:id="rId5"/>
     <p:sldId id="264" r:id="rId4"/>
     <p:sldId id="265" r:id="rId3"/>
+    <p:sldId id="266" r:id="rId2"/>
+    <p:sldId id="267" r:id="rId20"/>
   </p:sldIdLst>
   <p:sldSz cx="12192000" cy="6858000"/>
   <p:notesSz cx="6858000" cy="9144000"/>
@@ -4721,6 +4723,3312 @@
                 <a:cs typeface="メイリオ"/>
               </a:rPr>
               <a:t>decode 10.0 -&gt; 9.0 ms</a:t>
+            </a:r>
+          </a:p>
+        </p:txBody>
+      </p:sp>
+    </p:spTree>
+  </p:cSld>
+  <p:clrMapOvr>
+    <a:masterClrMapping/>
+  </p:clrMapOvr>
+</p:sld>
+</file>
+
+<file path=ppt/slides/slide11.xml><?xml version="1.0" encoding="utf-8"?>
+<p:sld xmlns:a="http://schemas.openxmlformats.org/drawingml/2006/main" xmlns:p="http://schemas.openxmlformats.org/presentationml/2006/main" xmlns:r="http://schemas.openxmlformats.org/officeDocument/2006/relationships" showMasterSp="0">
+  <p:cSld>
+    <p:spTree>
+      <p:nvGrpSpPr>
+        <p:cNvPr id="1" name=""/>
+        <p:cNvGrpSpPr/>
+        <p:nvPr/>
+      </p:nvGrpSpPr>
+      <p:grpSpPr/>
+      <p:sp>
+        <p:nvSpPr>
+          <p:cNvPr id="2" name="TextBox 1"/>
+          <p:cNvSpPr txBox="1"/>
+          <p:nvPr/>
+        </p:nvSpPr>
+        <p:spPr>
+          <a:xfrm>
+            <a:off x="409575" y="247650"/>
+            <a:ext cx="11334750" cy="438150"/>
+          </a:xfrm>
+          <a:prstGeom prst="rect">
+            <a:avLst/>
+          </a:prstGeom>
+          <a:noFill/>
+        </p:spPr>
+        <p:txBody>
+          <a:bodyPr wrap="square" lIns="0" rIns="0" tIns="0" bIns="0" anchor="ctr">
+            <a:spAutoFit/>
+          </a:bodyPr>
+          <a:lstStyle/>
+          <a:p>
+            <a:pPr algn="l">
+              <a:lnSpc>
+                <a:spcPct val="122000"/>
+              </a:lnSpc>
+            </a:pPr>
+            <a:r>
+              <a:rPr sz="3000" b="1">
+                <a:solidFill>
+                  <a:srgbClr val="F5F5F8"/>
+                </a:solidFill>
+                <a:latin typeface="Amazon Ember"/>
+                <a:ea typeface="メイリオ"/>
+                <a:cs typeface="メイリオ"/>
+              </a:rPr>
+              <a:t>At startup: the plugin builds your model and wires KV</a:t>
+            </a:r>
+          </a:p>
+        </p:txBody>
+      </p:sp>
+      <p:sp>
+        <p:nvSpPr>
+          <p:cNvPr id="3" name="TextBox 2"/>
+          <p:cNvSpPr txBox="1"/>
+          <p:nvPr/>
+        </p:nvSpPr>
+        <p:spPr>
+          <a:xfrm>
+            <a:off x="409575" y="685800"/>
+            <a:ext cx="11334750" cy="247650"/>
+          </a:xfrm>
+          <a:prstGeom prst="rect">
+            <a:avLst/>
+          </a:prstGeom>
+          <a:noFill/>
+        </p:spPr>
+        <p:txBody>
+          <a:bodyPr wrap="square" lIns="0" rIns="0" tIns="0" bIns="0" anchor="ctr">
+            <a:spAutoFit/>
+          </a:bodyPr>
+          <a:lstStyle/>
+          <a:p>
+            <a:pPr algn="l">
+              <a:lnSpc>
+                <a:spcPct val="122000"/>
+              </a:lnSpc>
+            </a:pPr>
+            <a:r>
+              <a:rPr sz="1600" b="0">
+                <a:solidFill>
+                  <a:srgbClr val="96969E"/>
+                </a:solidFill>
+                <a:latin typeface="Amazon Ember"/>
+                <a:ea typeface="メイリオ"/>
+                <a:cs typeface="メイリオ"/>
+              </a:rPr>
+              <a:t>Numbers: order of calls.  The plugin calls 4 of your 5 methods here; forward comes every step</a:t>
+            </a:r>
+          </a:p>
+        </p:txBody>
+      </p:sp>
+      <p:sp>
+        <p:nvSpPr>
+          <p:cNvPr id="4" name="Rectangle 3"/>
+          <p:cNvSpPr/>
+          <p:nvPr/>
+        </p:nvSpPr>
+        <p:spPr>
+          <a:xfrm>
+            <a:off x="409575" y="1066800"/>
+            <a:ext cx="11372850" cy="1295400"/>
+          </a:xfrm>
+          <a:prstGeom prst="rect">
+            <a:avLst/>
+          </a:prstGeom>
+          <a:solidFill>
+            <a:srgbClr val="161A1E"/>
+          </a:solidFill>
+          <a:ln w="9525">
+            <a:solidFill>
+              <a:srgbClr val="464A50"/>
+            </a:solidFill>
+          </a:ln>
+          <a:effectLst/>
+        </p:spPr>
+        <p:style>
+          <a:lnRef idx="1">
+            <a:schemeClr val="accent1"/>
+          </a:lnRef>
+          <a:fillRef idx="3">
+            <a:schemeClr val="accent1"/>
+          </a:fillRef>
+          <a:effectRef idx="2">
+            <a:schemeClr val="accent1"/>
+          </a:effectRef>
+          <a:fontRef idx="minor">
+            <a:schemeClr val="lt1"/>
+          </a:fontRef>
+        </p:style>
+        <p:txBody>
+          <a:bodyPr rtlCol="0" anchor="ctr"/>
+          <a:lstStyle/>
+          <a:p>
+            <a:pPr algn="ctr"/>
+          </a:p>
+        </p:txBody>
+      </p:sp>
+      <p:sp>
+        <p:nvSpPr>
+          <p:cNvPr id="5" name="TextBox 4"/>
+          <p:cNvSpPr txBox="1"/>
+          <p:nvPr/>
+        </p:nvSpPr>
+        <p:spPr>
+          <a:xfrm>
+            <a:off x="485775" y="1066800"/>
+            <a:ext cx="1238250" cy="1295400"/>
+          </a:xfrm>
+          <a:prstGeom prst="rect">
+            <a:avLst/>
+          </a:prstGeom>
+          <a:noFill/>
+        </p:spPr>
+        <p:txBody>
+          <a:bodyPr wrap="square" lIns="0" rIns="0" tIns="0" bIns="0" anchor="ctr">
+            <a:spAutoFit/>
+          </a:bodyPr>
+          <a:lstStyle/>
+          <a:p>
+            <a:pPr algn="l">
+              <a:lnSpc>
+                <a:spcPct val="122000"/>
+              </a:lnSpc>
+            </a:pPr>
+            <a:r>
+              <a:rPr sz="1600" b="1">
+                <a:solidFill>
+                  <a:srgbClr val="96969E"/>
+                </a:solidFill>
+                <a:latin typeface="Amazon Ember"/>
+                <a:ea typeface="メイリオ"/>
+                <a:cs typeface="メイリオ"/>
+              </a:rPr>
+              <a:t>vLLM</a:t>
+            </a:r>
+          </a:p>
+        </p:txBody>
+      </p:sp>
+      <p:sp>
+        <p:nvSpPr>
+          <p:cNvPr id="6" name="Rectangle 5"/>
+          <p:cNvSpPr/>
+          <p:nvPr/>
+        </p:nvSpPr>
+        <p:spPr>
+          <a:xfrm>
+            <a:off x="409575" y="2495550"/>
+            <a:ext cx="11372850" cy="1295400"/>
+          </a:xfrm>
+          <a:prstGeom prst="rect">
+            <a:avLst/>
+          </a:prstGeom>
+          <a:solidFill>
+            <a:srgbClr val="161A1E"/>
+          </a:solidFill>
+          <a:ln w="9525">
+            <a:solidFill>
+              <a:srgbClr val="464A50"/>
+            </a:solidFill>
+          </a:ln>
+          <a:effectLst/>
+        </p:spPr>
+        <p:style>
+          <a:lnRef idx="1">
+            <a:schemeClr val="accent1"/>
+          </a:lnRef>
+          <a:fillRef idx="3">
+            <a:schemeClr val="accent1"/>
+          </a:fillRef>
+          <a:effectRef idx="2">
+            <a:schemeClr val="accent1"/>
+          </a:effectRef>
+          <a:fontRef idx="minor">
+            <a:schemeClr val="lt1"/>
+          </a:fontRef>
+        </p:style>
+        <p:txBody>
+          <a:bodyPr rtlCol="0" anchor="ctr"/>
+          <a:lstStyle/>
+          <a:p>
+            <a:pPr algn="ctr"/>
+          </a:p>
+        </p:txBody>
+      </p:sp>
+      <p:sp>
+        <p:nvSpPr>
+          <p:cNvPr id="7" name="TextBox 6"/>
+          <p:cNvSpPr txBox="1"/>
+          <p:nvPr/>
+        </p:nvSpPr>
+        <p:spPr>
+          <a:xfrm>
+            <a:off x="485775" y="2495550"/>
+            <a:ext cx="1238250" cy="1295400"/>
+          </a:xfrm>
+          <a:prstGeom prst="rect">
+            <a:avLst/>
+          </a:prstGeom>
+          <a:noFill/>
+        </p:spPr>
+        <p:txBody>
+          <a:bodyPr wrap="square" lIns="0" rIns="0" tIns="0" bIns="0" anchor="ctr">
+            <a:spAutoFit/>
+          </a:bodyPr>
+          <a:lstStyle/>
+          <a:p>
+            <a:pPr algn="l">
+              <a:lnSpc>
+                <a:spcPct val="122000"/>
+              </a:lnSpc>
+            </a:pPr>
+            <a:r>
+              <a:rPr sz="1600" b="1">
+                <a:solidFill>
+                  <a:srgbClr val="2896F0"/>
+                </a:solidFill>
+                <a:latin typeface="Amazon Ember"/>
+                <a:ea typeface="メイリオ"/>
+                <a:cs typeface="メイリオ"/>
+              </a:rPr>
+              <a:t>Neuron plugin</a:t>
+            </a:r>
+          </a:p>
+        </p:txBody>
+      </p:sp>
+      <p:sp>
+        <p:nvSpPr>
+          <p:cNvPr id="8" name="Rectangle 7"/>
+          <p:cNvSpPr/>
+          <p:nvPr/>
+        </p:nvSpPr>
+        <p:spPr>
+          <a:xfrm>
+            <a:off x="409575" y="3924300"/>
+            <a:ext cx="11372850" cy="1295400"/>
+          </a:xfrm>
+          <a:prstGeom prst="rect">
+            <a:avLst/>
+          </a:prstGeom>
+          <a:solidFill>
+            <a:srgbClr val="161A1E"/>
+          </a:solidFill>
+          <a:ln w="9525">
+            <a:solidFill>
+              <a:srgbClr val="464A50"/>
+            </a:solidFill>
+          </a:ln>
+          <a:effectLst/>
+        </p:spPr>
+        <p:style>
+          <a:lnRef idx="1">
+            <a:schemeClr val="accent1"/>
+          </a:lnRef>
+          <a:fillRef idx="3">
+            <a:schemeClr val="accent1"/>
+          </a:fillRef>
+          <a:effectRef idx="2">
+            <a:schemeClr val="accent1"/>
+          </a:effectRef>
+          <a:fontRef idx="minor">
+            <a:schemeClr val="lt1"/>
+          </a:fontRef>
+        </p:style>
+        <p:txBody>
+          <a:bodyPr rtlCol="0" anchor="ctr"/>
+          <a:lstStyle/>
+          <a:p>
+            <a:pPr algn="ctr"/>
+          </a:p>
+        </p:txBody>
+      </p:sp>
+      <p:sp>
+        <p:nvSpPr>
+          <p:cNvPr id="9" name="TextBox 8"/>
+          <p:cNvSpPr txBox="1"/>
+          <p:nvPr/>
+        </p:nvSpPr>
+        <p:spPr>
+          <a:xfrm>
+            <a:off x="485775" y="3924300"/>
+            <a:ext cx="1238250" cy="1295400"/>
+          </a:xfrm>
+          <a:prstGeom prst="rect">
+            <a:avLst/>
+          </a:prstGeom>
+          <a:noFill/>
+        </p:spPr>
+        <p:txBody>
+          <a:bodyPr wrap="square" lIns="0" rIns="0" tIns="0" bIns="0" anchor="ctr">
+            <a:spAutoFit/>
+          </a:bodyPr>
+          <a:lstStyle/>
+          <a:p>
+            <a:pPr algn="l">
+              <a:lnSpc>
+                <a:spcPct val="122000"/>
+              </a:lnSpc>
+            </a:pPr>
+            <a:r>
+              <a:rPr sz="1600" b="1">
+                <a:solidFill>
+                  <a:srgbClr val="3BD16F"/>
+                </a:solidFill>
+                <a:latin typeface="Amazon Ember"/>
+                <a:ea typeface="メイリオ"/>
+                <a:cs typeface="メイリオ"/>
+              </a:rPr>
+              <a:t>your model</a:t>
+            </a:r>
+          </a:p>
+          <a:p>
+            <a:pPr algn="l">
+              <a:lnSpc>
+                <a:spcPct val="122000"/>
+              </a:lnSpc>
+            </a:pPr>
+            <a:r>
+              <a:rPr sz="1600" b="1">
+                <a:solidFill>
+                  <a:srgbClr val="3BD16F"/>
+                </a:solidFill>
+                <a:latin typeface="Amazon Ember"/>
+                <a:ea typeface="メイリオ"/>
+                <a:cs typeface="メイリオ"/>
+              </a:rPr>
+              <a:t>(BYOM)</a:t>
+            </a:r>
+          </a:p>
+        </p:txBody>
+      </p:sp>
+      <p:sp>
+        <p:nvSpPr>
+          <p:cNvPr id="10" name="Rounded Rectangle 9"/>
+          <p:cNvSpPr/>
+          <p:nvPr/>
+        </p:nvSpPr>
+        <p:spPr>
+          <a:xfrm>
+            <a:off x="1905000" y="1257300"/>
+            <a:ext cx="1619250" cy="914400"/>
+          </a:xfrm>
+          <a:prstGeom prst="roundRect">
+            <a:avLst>
+              <a:gd name="adj" fmla="val 10000"/>
+            </a:avLst>
+          </a:prstGeom>
+          <a:solidFill>
+            <a:srgbClr val="343840"/>
+          </a:solidFill>
+          <a:ln w="15875">
+            <a:solidFill>
+              <a:srgbClr val="464A50"/>
+            </a:solidFill>
+          </a:ln>
+          <a:effectLst/>
+        </p:spPr>
+        <p:style>
+          <a:lnRef idx="1">
+            <a:schemeClr val="accent1"/>
+          </a:lnRef>
+          <a:fillRef idx="3">
+            <a:schemeClr val="accent1"/>
+          </a:fillRef>
+          <a:effectRef idx="2">
+            <a:schemeClr val="accent1"/>
+          </a:effectRef>
+          <a:fontRef idx="minor">
+            <a:schemeClr val="lt1"/>
+          </a:fontRef>
+        </p:style>
+        <p:txBody>
+          <a:bodyPr rtlCol="0" anchor="ctr" wrap="square" lIns="19050" rIns="19050" tIns="19050" bIns="19050"/>
+          <a:lstStyle/>
+          <a:p>
+            <a:pPr algn="ctr">
+              <a:lnSpc>
+                <a:spcPct val="122000"/>
+              </a:lnSpc>
+            </a:pPr>
+            <a:r>
+              <a:rPr sz="1400" b="1">
+                <a:solidFill>
+                  <a:srgbClr val="F5F5F8"/>
+                </a:solidFill>
+                <a:latin typeface="Amazon Ember"/>
+                <a:ea typeface="メイリオ"/>
+                <a:cs typeface="メイリオ"/>
+              </a:rPr>
+              <a:t>vllm serve</a:t>
+            </a:r>
+          </a:p>
+          <a:p>
+            <a:pPr algn="ctr">
+              <a:lnSpc>
+                <a:spcPct val="122000"/>
+              </a:lnSpc>
+            </a:pPr>
+            <a:r>
+              <a:rPr sz="1400" b="1">
+                <a:solidFill>
+                  <a:srgbClr val="F5F5F8"/>
+                </a:solidFill>
+                <a:latin typeface="Amazon Ember"/>
+                <a:ea typeface="メイリオ"/>
+                <a:cs typeface="メイリオ"/>
+              </a:rPr>
+              <a:t>loads the plugin</a:t>
+            </a:r>
+          </a:p>
+        </p:txBody>
+      </p:sp>
+      <p:sp>
+        <p:nvSpPr>
+          <p:cNvPr id="11" name="Oval 10"/>
+          <p:cNvSpPr/>
+          <p:nvPr/>
+        </p:nvSpPr>
+        <p:spPr>
+          <a:xfrm>
+            <a:off x="1790700" y="1143000"/>
+            <a:ext cx="247650" cy="247650"/>
+          </a:xfrm>
+          <a:prstGeom prst="ellipse">
+            <a:avLst/>
+          </a:prstGeom>
+          <a:solidFill>
+            <a:srgbClr val="FBD332"/>
+          </a:solidFill>
+          <a:ln>
+            <a:noFill/>
+          </a:ln>
+          <a:effectLst/>
+        </p:spPr>
+        <p:style>
+          <a:lnRef idx="1">
+            <a:schemeClr val="accent1"/>
+          </a:lnRef>
+          <a:fillRef idx="3">
+            <a:schemeClr val="accent1"/>
+          </a:fillRef>
+          <a:effectRef idx="2">
+            <a:schemeClr val="accent1"/>
+          </a:effectRef>
+          <a:fontRef idx="minor">
+            <a:schemeClr val="lt1"/>
+          </a:fontRef>
+        </p:style>
+        <p:txBody>
+          <a:bodyPr rtlCol="0" anchor="ctr" wrap="square"/>
+          <a:lstStyle/>
+          <a:p>
+            <a:pPr algn="ctr">
+              <a:lnSpc>
+                <a:spcPct val="122000"/>
+              </a:lnSpc>
+            </a:pPr>
+            <a:r>
+              <a:rPr sz="1200" b="1">
+                <a:solidFill>
+                  <a:srgbClr val="000000"/>
+                </a:solidFill>
+                <a:latin typeface="Amazon Ember"/>
+                <a:ea typeface="メイリオ"/>
+                <a:cs typeface="メイリオ"/>
+              </a:rPr>
+              <a:t>1</a:t>
+            </a:r>
+          </a:p>
+        </p:txBody>
+      </p:sp>
+      <p:sp>
+        <p:nvSpPr>
+          <p:cNvPr id="12" name="Rounded Rectangle 11"/>
+          <p:cNvSpPr/>
+          <p:nvPr/>
+        </p:nvSpPr>
+        <p:spPr>
+          <a:xfrm>
+            <a:off x="1905000" y="2686050"/>
+            <a:ext cx="1619250" cy="914400"/>
+          </a:xfrm>
+          <a:prstGeom prst="roundRect">
+            <a:avLst>
+              <a:gd name="adj" fmla="val 10000"/>
+            </a:avLst>
+          </a:prstGeom>
+          <a:solidFill>
+            <a:srgbClr val="102C48"/>
+          </a:solidFill>
+          <a:ln w="15875">
+            <a:solidFill>
+              <a:srgbClr val="2896F0"/>
+            </a:solidFill>
+          </a:ln>
+          <a:effectLst/>
+        </p:spPr>
+        <p:style>
+          <a:lnRef idx="1">
+            <a:schemeClr val="accent1"/>
+          </a:lnRef>
+          <a:fillRef idx="3">
+            <a:schemeClr val="accent1"/>
+          </a:fillRef>
+          <a:effectRef idx="2">
+            <a:schemeClr val="accent1"/>
+          </a:effectRef>
+          <a:fontRef idx="minor">
+            <a:schemeClr val="lt1"/>
+          </a:fontRef>
+        </p:style>
+        <p:txBody>
+          <a:bodyPr rtlCol="0" anchor="ctr" wrap="square" lIns="19050" rIns="19050" tIns="19050" bIns="19050"/>
+          <a:lstStyle/>
+          <a:p>
+            <a:pPr algn="ctr">
+              <a:lnSpc>
+                <a:spcPct val="122000"/>
+              </a:lnSpc>
+            </a:pPr>
+            <a:r>
+              <a:rPr sz="1400" b="1">
+                <a:solidFill>
+                  <a:srgbClr val="F5F5F8"/>
+                </a:solidFill>
+                <a:latin typeface="Amazon Ember"/>
+                <a:ea typeface="メイリオ"/>
+                <a:cs typeface="メイリオ"/>
+              </a:rPr>
+              <a:t>swap in worker</a:t>
+            </a:r>
+          </a:p>
+          <a:p>
+            <a:pPr algn="ctr">
+              <a:lnSpc>
+                <a:spcPct val="122000"/>
+              </a:lnSpc>
+            </a:pPr>
+            <a:r>
+              <a:rPr sz="1400" b="1">
+                <a:solidFill>
+                  <a:srgbClr val="F5F5F8"/>
+                </a:solidFill>
+                <a:latin typeface="Amazon Ember"/>
+                <a:ea typeface="メイリオ"/>
+                <a:cs typeface="メイリオ"/>
+              </a:rPr>
+              <a:t>and scheduler</a:t>
+            </a:r>
+          </a:p>
+        </p:txBody>
+      </p:sp>
+      <p:sp>
+        <p:nvSpPr>
+          <p:cNvPr id="13" name="Oval 12"/>
+          <p:cNvSpPr/>
+          <p:nvPr/>
+        </p:nvSpPr>
+        <p:spPr>
+          <a:xfrm>
+            <a:off x="1790700" y="2571750"/>
+            <a:ext cx="247650" cy="247650"/>
+          </a:xfrm>
+          <a:prstGeom prst="ellipse">
+            <a:avLst/>
+          </a:prstGeom>
+          <a:solidFill>
+            <a:srgbClr val="FBD332"/>
+          </a:solidFill>
+          <a:ln>
+            <a:noFill/>
+          </a:ln>
+          <a:effectLst/>
+        </p:spPr>
+        <p:style>
+          <a:lnRef idx="1">
+            <a:schemeClr val="accent1"/>
+          </a:lnRef>
+          <a:fillRef idx="3">
+            <a:schemeClr val="accent1"/>
+          </a:fillRef>
+          <a:effectRef idx="2">
+            <a:schemeClr val="accent1"/>
+          </a:effectRef>
+          <a:fontRef idx="minor">
+            <a:schemeClr val="lt1"/>
+          </a:fontRef>
+        </p:style>
+        <p:txBody>
+          <a:bodyPr rtlCol="0" anchor="ctr" wrap="square"/>
+          <a:lstStyle/>
+          <a:p>
+            <a:pPr algn="ctr">
+              <a:lnSpc>
+                <a:spcPct val="122000"/>
+              </a:lnSpc>
+            </a:pPr>
+            <a:r>
+              <a:rPr sz="1200" b="1">
+                <a:solidFill>
+                  <a:srgbClr val="000000"/>
+                </a:solidFill>
+                <a:latin typeface="Amazon Ember"/>
+                <a:ea typeface="メイリオ"/>
+                <a:cs typeface="メイリオ"/>
+              </a:rPr>
+              <a:t>2</a:t>
+            </a:r>
+          </a:p>
+        </p:txBody>
+      </p:sp>
+      <p:sp>
+        <p:nvSpPr>
+          <p:cNvPr id="14" name="Rounded Rectangle 13"/>
+          <p:cNvSpPr/>
+          <p:nvPr/>
+        </p:nvSpPr>
+        <p:spPr>
+          <a:xfrm>
+            <a:off x="3762375" y="4114800"/>
+            <a:ext cx="1619250" cy="914400"/>
+          </a:xfrm>
+          <a:prstGeom prst="roundRect">
+            <a:avLst>
+              <a:gd name="adj" fmla="val 10000"/>
+            </a:avLst>
+          </a:prstGeom>
+          <a:solidFill>
+            <a:srgbClr val="124022"/>
+          </a:solidFill>
+          <a:ln w="15875">
+            <a:solidFill>
+              <a:srgbClr val="24A046"/>
+            </a:solidFill>
+          </a:ln>
+          <a:effectLst/>
+        </p:spPr>
+        <p:style>
+          <a:lnRef idx="1">
+            <a:schemeClr val="accent1"/>
+          </a:lnRef>
+          <a:fillRef idx="3">
+            <a:schemeClr val="accent1"/>
+          </a:fillRef>
+          <a:effectRef idx="2">
+            <a:schemeClr val="accent1"/>
+          </a:effectRef>
+          <a:fontRef idx="minor">
+            <a:schemeClr val="lt1"/>
+          </a:fontRef>
+        </p:style>
+        <p:txBody>
+          <a:bodyPr rtlCol="0" anchor="ctr" wrap="square" lIns="19050" rIns="19050" tIns="19050" bIns="19050"/>
+          <a:lstStyle/>
+          <a:p>
+            <a:pPr algn="ctr">
+              <a:lnSpc>
+                <a:spcPct val="122000"/>
+              </a:lnSpc>
+            </a:pPr>
+            <a:r>
+              <a:rPr sz="1400" b="1">
+                <a:solidFill>
+                  <a:srgbClr val="F5F5F8"/>
+                </a:solidFill>
+                <a:latin typeface="Amazon Ember"/>
+                <a:ea typeface="メイリオ"/>
+                <a:cs typeface="メイリオ"/>
+              </a:rPr>
+              <a:t>from_configs</a:t>
+            </a:r>
+          </a:p>
+          <a:p>
+            <a:pPr algn="ctr">
+              <a:lnSpc>
+                <a:spcPct val="122000"/>
+              </a:lnSpc>
+            </a:pPr>
+            <a:r>
+              <a:rPr sz="1400" b="1">
+                <a:solidFill>
+                  <a:srgbClr val="F5F5F8"/>
+                </a:solidFill>
+                <a:latin typeface="Amazon Ember"/>
+                <a:ea typeface="メイリオ"/>
+                <a:cs typeface="メイリオ"/>
+              </a:rPr>
+              <a:t>build the model</a:t>
+            </a:r>
+          </a:p>
+        </p:txBody>
+      </p:sp>
+      <p:sp>
+        <p:nvSpPr>
+          <p:cNvPr id="15" name="Oval 14"/>
+          <p:cNvSpPr/>
+          <p:nvPr/>
+        </p:nvSpPr>
+        <p:spPr>
+          <a:xfrm>
+            <a:off x="3648075" y="4000500"/>
+            <a:ext cx="247650" cy="247650"/>
+          </a:xfrm>
+          <a:prstGeom prst="ellipse">
+            <a:avLst/>
+          </a:prstGeom>
+          <a:solidFill>
+            <a:srgbClr val="FBD332"/>
+          </a:solidFill>
+          <a:ln>
+            <a:noFill/>
+          </a:ln>
+          <a:effectLst/>
+        </p:spPr>
+        <p:style>
+          <a:lnRef idx="1">
+            <a:schemeClr val="accent1"/>
+          </a:lnRef>
+          <a:fillRef idx="3">
+            <a:schemeClr val="accent1"/>
+          </a:fillRef>
+          <a:effectRef idx="2">
+            <a:schemeClr val="accent1"/>
+          </a:effectRef>
+          <a:fontRef idx="minor">
+            <a:schemeClr val="lt1"/>
+          </a:fontRef>
+        </p:style>
+        <p:txBody>
+          <a:bodyPr rtlCol="0" anchor="ctr" wrap="square"/>
+          <a:lstStyle/>
+          <a:p>
+            <a:pPr algn="ctr">
+              <a:lnSpc>
+                <a:spcPct val="122000"/>
+              </a:lnSpc>
+            </a:pPr>
+            <a:r>
+              <a:rPr sz="1200" b="1">
+                <a:solidFill>
+                  <a:srgbClr val="000000"/>
+                </a:solidFill>
+                <a:latin typeface="Amazon Ember"/>
+                <a:ea typeface="メイリオ"/>
+                <a:cs typeface="メイリオ"/>
+              </a:rPr>
+              <a:t>3</a:t>
+            </a:r>
+          </a:p>
+        </p:txBody>
+      </p:sp>
+      <p:sp>
+        <p:nvSpPr>
+          <p:cNvPr id="16" name="Rounded Rectangle 15"/>
+          <p:cNvSpPr/>
+          <p:nvPr/>
+        </p:nvSpPr>
+        <p:spPr>
+          <a:xfrm>
+            <a:off x="5619750" y="4114800"/>
+            <a:ext cx="1619250" cy="914400"/>
+          </a:xfrm>
+          <a:prstGeom prst="roundRect">
+            <a:avLst>
+              <a:gd name="adj" fmla="val 10000"/>
+            </a:avLst>
+          </a:prstGeom>
+          <a:solidFill>
+            <a:srgbClr val="124022"/>
+          </a:solidFill>
+          <a:ln w="15875">
+            <a:solidFill>
+              <a:srgbClr val="24A046"/>
+            </a:solidFill>
+          </a:ln>
+          <a:effectLst/>
+        </p:spPr>
+        <p:style>
+          <a:lnRef idx="1">
+            <a:schemeClr val="accent1"/>
+          </a:lnRef>
+          <a:fillRef idx="3">
+            <a:schemeClr val="accent1"/>
+          </a:fillRef>
+          <a:effectRef idx="2">
+            <a:schemeClr val="accent1"/>
+          </a:effectRef>
+          <a:fontRef idx="minor">
+            <a:schemeClr val="lt1"/>
+          </a:fontRef>
+        </p:style>
+        <p:txBody>
+          <a:bodyPr rtlCol="0" anchor="ctr" wrap="square" lIns="19050" rIns="19050" tIns="19050" bIns="19050"/>
+          <a:lstStyle/>
+          <a:p>
+            <a:pPr algn="ctr">
+              <a:lnSpc>
+                <a:spcPct val="122000"/>
+              </a:lnSpc>
+            </a:pPr>
+            <a:r>
+              <a:rPr sz="1400" b="1">
+                <a:solidFill>
+                  <a:srgbClr val="F5F5F8"/>
+                </a:solidFill>
+                <a:latin typeface="Amazon Ember"/>
+                <a:ea typeface="メイリオ"/>
+                <a:cs typeface="メイリオ"/>
+              </a:rPr>
+              <a:t>load_weights</a:t>
+            </a:r>
+          </a:p>
+          <a:p>
+            <a:pPr algn="ctr">
+              <a:lnSpc>
+                <a:spcPct val="122000"/>
+              </a:lnSpc>
+            </a:pPr>
+            <a:r>
+              <a:rPr sz="1400" b="1">
+                <a:solidFill>
+                  <a:srgbClr val="F5F5F8"/>
+                </a:solidFill>
+                <a:latin typeface="Amazon Ember"/>
+                <a:ea typeface="メイリオ"/>
+                <a:cs typeface="メイリオ"/>
+              </a:rPr>
+              <a:t>shard to 4 ranks</a:t>
+            </a:r>
+          </a:p>
+        </p:txBody>
+      </p:sp>
+      <p:sp>
+        <p:nvSpPr>
+          <p:cNvPr id="17" name="Oval 16"/>
+          <p:cNvSpPr/>
+          <p:nvPr/>
+        </p:nvSpPr>
+        <p:spPr>
+          <a:xfrm>
+            <a:off x="5505450" y="4000500"/>
+            <a:ext cx="247650" cy="247650"/>
+          </a:xfrm>
+          <a:prstGeom prst="ellipse">
+            <a:avLst/>
+          </a:prstGeom>
+          <a:solidFill>
+            <a:srgbClr val="FBD332"/>
+          </a:solidFill>
+          <a:ln>
+            <a:noFill/>
+          </a:ln>
+          <a:effectLst/>
+        </p:spPr>
+        <p:style>
+          <a:lnRef idx="1">
+            <a:schemeClr val="accent1"/>
+          </a:lnRef>
+          <a:fillRef idx="3">
+            <a:schemeClr val="accent1"/>
+          </a:fillRef>
+          <a:effectRef idx="2">
+            <a:schemeClr val="accent1"/>
+          </a:effectRef>
+          <a:fontRef idx="minor">
+            <a:schemeClr val="lt1"/>
+          </a:fontRef>
+        </p:style>
+        <p:txBody>
+          <a:bodyPr rtlCol="0" anchor="ctr" wrap="square"/>
+          <a:lstStyle/>
+          <a:p>
+            <a:pPr algn="ctr">
+              <a:lnSpc>
+                <a:spcPct val="122000"/>
+              </a:lnSpc>
+            </a:pPr>
+            <a:r>
+              <a:rPr sz="1200" b="1">
+                <a:solidFill>
+                  <a:srgbClr val="000000"/>
+                </a:solidFill>
+                <a:latin typeface="Amazon Ember"/>
+                <a:ea typeface="メイリオ"/>
+                <a:cs typeface="メイリオ"/>
+              </a:rPr>
+              <a:t>4</a:t>
+            </a:r>
+          </a:p>
+        </p:txBody>
+      </p:sp>
+      <p:sp>
+        <p:nvSpPr>
+          <p:cNvPr id="18" name="Rounded Rectangle 17"/>
+          <p:cNvSpPr/>
+          <p:nvPr/>
+        </p:nvSpPr>
+        <p:spPr>
+          <a:xfrm>
+            <a:off x="7477125" y="4114800"/>
+            <a:ext cx="1619250" cy="914400"/>
+          </a:xfrm>
+          <a:prstGeom prst="roundRect">
+            <a:avLst>
+              <a:gd name="adj" fmla="val 10000"/>
+            </a:avLst>
+          </a:prstGeom>
+          <a:solidFill>
+            <a:srgbClr val="124022"/>
+          </a:solidFill>
+          <a:ln w="15875">
+            <a:solidFill>
+              <a:srgbClr val="24A046"/>
+            </a:solidFill>
+          </a:ln>
+          <a:effectLst/>
+        </p:spPr>
+        <p:style>
+          <a:lnRef idx="1">
+            <a:schemeClr val="accent1"/>
+          </a:lnRef>
+          <a:fillRef idx="3">
+            <a:schemeClr val="accent1"/>
+          </a:fillRef>
+          <a:effectRef idx="2">
+            <a:schemeClr val="accent1"/>
+          </a:effectRef>
+          <a:fontRef idx="minor">
+            <a:schemeClr val="lt1"/>
+          </a:fontRef>
+        </p:style>
+        <p:txBody>
+          <a:bodyPr rtlCol="0" anchor="ctr" wrap="square" lIns="19050" rIns="19050" tIns="19050" bIns="19050"/>
+          <a:lstStyle/>
+          <a:p>
+            <a:pPr algn="ctr">
+              <a:lnSpc>
+                <a:spcPct val="122000"/>
+              </a:lnSpc>
+            </a:pPr>
+            <a:r>
+              <a:rPr sz="1400" b="1">
+                <a:solidFill>
+                  <a:srgbClr val="F5F5F8"/>
+                </a:solidFill>
+                <a:latin typeface="Amazon Ember"/>
+                <a:ea typeface="メイリオ"/>
+                <a:cs typeface="メイリオ"/>
+              </a:rPr>
+              <a:t>get_kv_spec</a:t>
+            </a:r>
+          </a:p>
+          <a:p>
+            <a:pPr algn="ctr">
+              <a:lnSpc>
+                <a:spcPct val="122000"/>
+              </a:lnSpc>
+            </a:pPr>
+            <a:r>
+              <a:rPr sz="1400" b="1">
+                <a:solidFill>
+                  <a:srgbClr val="F5F5F8"/>
+                </a:solidFill>
+                <a:latin typeface="Amazon Ember"/>
+                <a:ea typeface="メイリオ"/>
+                <a:cs typeface="メイリオ"/>
+              </a:rPr>
+              <a:t>6 attention layers</a:t>
+            </a:r>
+          </a:p>
+        </p:txBody>
+      </p:sp>
+      <p:sp>
+        <p:nvSpPr>
+          <p:cNvPr id="19" name="Oval 18"/>
+          <p:cNvSpPr/>
+          <p:nvPr/>
+        </p:nvSpPr>
+        <p:spPr>
+          <a:xfrm>
+            <a:off x="7362825" y="4000500"/>
+            <a:ext cx="247650" cy="247650"/>
+          </a:xfrm>
+          <a:prstGeom prst="ellipse">
+            <a:avLst/>
+          </a:prstGeom>
+          <a:solidFill>
+            <a:srgbClr val="FBD332"/>
+          </a:solidFill>
+          <a:ln>
+            <a:noFill/>
+          </a:ln>
+          <a:effectLst/>
+        </p:spPr>
+        <p:style>
+          <a:lnRef idx="1">
+            <a:schemeClr val="accent1"/>
+          </a:lnRef>
+          <a:fillRef idx="3">
+            <a:schemeClr val="accent1"/>
+          </a:fillRef>
+          <a:effectRef idx="2">
+            <a:schemeClr val="accent1"/>
+          </a:effectRef>
+          <a:fontRef idx="minor">
+            <a:schemeClr val="lt1"/>
+          </a:fontRef>
+        </p:style>
+        <p:txBody>
+          <a:bodyPr rtlCol="0" anchor="ctr" wrap="square"/>
+          <a:lstStyle/>
+          <a:p>
+            <a:pPr algn="ctr">
+              <a:lnSpc>
+                <a:spcPct val="122000"/>
+              </a:lnSpc>
+            </a:pPr>
+            <a:r>
+              <a:rPr sz="1200" b="1">
+                <a:solidFill>
+                  <a:srgbClr val="000000"/>
+                </a:solidFill>
+                <a:latin typeface="Amazon Ember"/>
+                <a:ea typeface="メイリオ"/>
+                <a:cs typeface="メイリオ"/>
+              </a:rPr>
+              <a:t>5</a:t>
+            </a:r>
+          </a:p>
+        </p:txBody>
+      </p:sp>
+      <p:sp>
+        <p:nvSpPr>
+          <p:cNvPr id="20" name="Rounded Rectangle 19"/>
+          <p:cNvSpPr/>
+          <p:nvPr/>
+        </p:nvSpPr>
+        <p:spPr>
+          <a:xfrm>
+            <a:off x="7477125" y="2686050"/>
+            <a:ext cx="1619250" cy="914400"/>
+          </a:xfrm>
+          <a:prstGeom prst="roundRect">
+            <a:avLst>
+              <a:gd name="adj" fmla="val 10000"/>
+            </a:avLst>
+          </a:prstGeom>
+          <a:solidFill>
+            <a:srgbClr val="102C48"/>
+          </a:solidFill>
+          <a:ln w="15875">
+            <a:solidFill>
+              <a:srgbClr val="2896F0"/>
+            </a:solidFill>
+          </a:ln>
+          <a:effectLst/>
+        </p:spPr>
+        <p:style>
+          <a:lnRef idx="1">
+            <a:schemeClr val="accent1"/>
+          </a:lnRef>
+          <a:fillRef idx="3">
+            <a:schemeClr val="accent1"/>
+          </a:fillRef>
+          <a:effectRef idx="2">
+            <a:schemeClr val="accent1"/>
+          </a:effectRef>
+          <a:fontRef idx="minor">
+            <a:schemeClr val="lt1"/>
+          </a:fontRef>
+        </p:style>
+        <p:txBody>
+          <a:bodyPr rtlCol="0" anchor="ctr" wrap="square" lIns="19050" rIns="19050" tIns="19050" bIns="19050"/>
+          <a:lstStyle/>
+          <a:p>
+            <a:pPr algn="ctr">
+              <a:lnSpc>
+                <a:spcPct val="122000"/>
+              </a:lnSpc>
+            </a:pPr>
+            <a:r>
+              <a:rPr sz="1400" b="1">
+                <a:solidFill>
+                  <a:srgbClr val="F5F5F8"/>
+                </a:solidFill>
+                <a:latin typeface="Amazon Ember"/>
+                <a:ea typeface="メイリオ"/>
+                <a:cs typeface="メイリオ"/>
+              </a:rPr>
+              <a:t>allocate KV</a:t>
+            </a:r>
+          </a:p>
+          <a:p>
+            <a:pPr algn="ctr">
+              <a:lnSpc>
+                <a:spcPct val="122000"/>
+              </a:lnSpc>
+            </a:pPr>
+            <a:r>
+              <a:rPr sz="1400" b="1">
+                <a:solidFill>
+                  <a:srgbClr val="F5F5F8"/>
+                </a:solidFill>
+                <a:latin typeface="Amazon Ember"/>
+                <a:ea typeface="メイリオ"/>
+                <a:cs typeface="メイリオ"/>
+              </a:rPr>
+              <a:t>from free memory</a:t>
+            </a:r>
+          </a:p>
+        </p:txBody>
+      </p:sp>
+      <p:sp>
+        <p:nvSpPr>
+          <p:cNvPr id="21" name="Oval 20"/>
+          <p:cNvSpPr/>
+          <p:nvPr/>
+        </p:nvSpPr>
+        <p:spPr>
+          <a:xfrm>
+            <a:off x="7362825" y="2571750"/>
+            <a:ext cx="247650" cy="247650"/>
+          </a:xfrm>
+          <a:prstGeom prst="ellipse">
+            <a:avLst/>
+          </a:prstGeom>
+          <a:solidFill>
+            <a:srgbClr val="FBD332"/>
+          </a:solidFill>
+          <a:ln>
+            <a:noFill/>
+          </a:ln>
+          <a:effectLst/>
+        </p:spPr>
+        <p:style>
+          <a:lnRef idx="1">
+            <a:schemeClr val="accent1"/>
+          </a:lnRef>
+          <a:fillRef idx="3">
+            <a:schemeClr val="accent1"/>
+          </a:fillRef>
+          <a:effectRef idx="2">
+            <a:schemeClr val="accent1"/>
+          </a:effectRef>
+          <a:fontRef idx="minor">
+            <a:schemeClr val="lt1"/>
+          </a:fontRef>
+        </p:style>
+        <p:txBody>
+          <a:bodyPr rtlCol="0" anchor="ctr" wrap="square"/>
+          <a:lstStyle/>
+          <a:p>
+            <a:pPr algn="ctr">
+              <a:lnSpc>
+                <a:spcPct val="122000"/>
+              </a:lnSpc>
+            </a:pPr>
+            <a:r>
+              <a:rPr sz="1200" b="1">
+                <a:solidFill>
+                  <a:srgbClr val="000000"/>
+                </a:solidFill>
+                <a:latin typeface="Amazon Ember"/>
+                <a:ea typeface="メイリオ"/>
+                <a:cs typeface="メイリオ"/>
+              </a:rPr>
+              <a:t>6</a:t>
+            </a:r>
+          </a:p>
+        </p:txBody>
+      </p:sp>
+      <p:sp>
+        <p:nvSpPr>
+          <p:cNvPr id="22" name="Rounded Rectangle 21"/>
+          <p:cNvSpPr/>
+          <p:nvPr/>
+        </p:nvSpPr>
+        <p:spPr>
+          <a:xfrm>
+            <a:off x="9334500" y="4114800"/>
+            <a:ext cx="1333500" cy="914400"/>
+          </a:xfrm>
+          <a:prstGeom prst="roundRect">
+            <a:avLst>
+              <a:gd name="adj" fmla="val 10000"/>
+            </a:avLst>
+          </a:prstGeom>
+          <a:solidFill>
+            <a:srgbClr val="124022"/>
+          </a:solidFill>
+          <a:ln w="15875">
+            <a:solidFill>
+              <a:srgbClr val="24A046"/>
+            </a:solidFill>
+          </a:ln>
+          <a:effectLst/>
+        </p:spPr>
+        <p:style>
+          <a:lnRef idx="1">
+            <a:schemeClr val="accent1"/>
+          </a:lnRef>
+          <a:fillRef idx="3">
+            <a:schemeClr val="accent1"/>
+          </a:fillRef>
+          <a:effectRef idx="2">
+            <a:schemeClr val="accent1"/>
+          </a:effectRef>
+          <a:fontRef idx="minor">
+            <a:schemeClr val="lt1"/>
+          </a:fontRef>
+        </p:style>
+        <p:txBody>
+          <a:bodyPr rtlCol="0" anchor="ctr" wrap="square" lIns="19050" rIns="19050" tIns="19050" bIns="19050"/>
+          <a:lstStyle/>
+          <a:p>
+            <a:pPr algn="ctr">
+              <a:lnSpc>
+                <a:spcPct val="122000"/>
+              </a:lnSpc>
+            </a:pPr>
+            <a:r>
+              <a:rPr sz="1400" b="1">
+                <a:solidFill>
+                  <a:srgbClr val="F5F5F8"/>
+                </a:solidFill>
+                <a:latin typeface="Amazon Ember"/>
+                <a:ea typeface="メイリオ"/>
+                <a:cs typeface="メイリオ"/>
+              </a:rPr>
+              <a:t>bind_kv_cache</a:t>
+            </a:r>
+          </a:p>
+          <a:p>
+            <a:pPr algn="ctr">
+              <a:lnSpc>
+                <a:spcPct val="122000"/>
+              </a:lnSpc>
+            </a:pPr>
+            <a:r>
+              <a:rPr sz="1400" b="1">
+                <a:solidFill>
+                  <a:srgbClr val="F5F5F8"/>
+                </a:solidFill>
+                <a:latin typeface="Amazon Ember"/>
+                <a:ea typeface="メイリオ"/>
+                <a:cs typeface="メイリオ"/>
+              </a:rPr>
+              <a:t>attach KV</a:t>
+            </a:r>
+          </a:p>
+        </p:txBody>
+      </p:sp>
+      <p:sp>
+        <p:nvSpPr>
+          <p:cNvPr id="23" name="Oval 22"/>
+          <p:cNvSpPr/>
+          <p:nvPr/>
+        </p:nvSpPr>
+        <p:spPr>
+          <a:xfrm>
+            <a:off x="9220200" y="4000500"/>
+            <a:ext cx="247650" cy="247650"/>
+          </a:xfrm>
+          <a:prstGeom prst="ellipse">
+            <a:avLst/>
+          </a:prstGeom>
+          <a:solidFill>
+            <a:srgbClr val="FBD332"/>
+          </a:solidFill>
+          <a:ln>
+            <a:noFill/>
+          </a:ln>
+          <a:effectLst/>
+        </p:spPr>
+        <p:style>
+          <a:lnRef idx="1">
+            <a:schemeClr val="accent1"/>
+          </a:lnRef>
+          <a:fillRef idx="3">
+            <a:schemeClr val="accent1"/>
+          </a:fillRef>
+          <a:effectRef idx="2">
+            <a:schemeClr val="accent1"/>
+          </a:effectRef>
+          <a:fontRef idx="minor">
+            <a:schemeClr val="lt1"/>
+          </a:fontRef>
+        </p:style>
+        <p:txBody>
+          <a:bodyPr rtlCol="0" anchor="ctr" wrap="square"/>
+          <a:lstStyle/>
+          <a:p>
+            <a:pPr algn="ctr">
+              <a:lnSpc>
+                <a:spcPct val="122000"/>
+              </a:lnSpc>
+            </a:pPr>
+            <a:r>
+              <a:rPr sz="1200" b="1">
+                <a:solidFill>
+                  <a:srgbClr val="000000"/>
+                </a:solidFill>
+                <a:latin typeface="Amazon Ember"/>
+                <a:ea typeface="メイリオ"/>
+                <a:cs typeface="メイリオ"/>
+              </a:rPr>
+              <a:t>7</a:t>
+            </a:r>
+          </a:p>
+        </p:txBody>
+      </p:sp>
+      <p:sp>
+        <p:nvSpPr>
+          <p:cNvPr id="24" name="Rounded Rectangle 23"/>
+          <p:cNvSpPr/>
+          <p:nvPr/>
+        </p:nvSpPr>
+        <p:spPr>
+          <a:xfrm>
+            <a:off x="9334500" y="2686050"/>
+            <a:ext cx="2286000" cy="914400"/>
+          </a:xfrm>
+          <a:prstGeom prst="roundRect">
+            <a:avLst>
+              <a:gd name="adj" fmla="val 10000"/>
+            </a:avLst>
+          </a:prstGeom>
+          <a:solidFill>
+            <a:srgbClr val="102C48"/>
+          </a:solidFill>
+          <a:ln w="15875">
+            <a:solidFill>
+              <a:srgbClr val="2896F0"/>
+            </a:solidFill>
+          </a:ln>
+          <a:effectLst/>
+        </p:spPr>
+        <p:style>
+          <a:lnRef idx="1">
+            <a:schemeClr val="accent1"/>
+          </a:lnRef>
+          <a:fillRef idx="3">
+            <a:schemeClr val="accent1"/>
+          </a:fillRef>
+          <a:effectRef idx="2">
+            <a:schemeClr val="accent1"/>
+          </a:effectRef>
+          <a:fontRef idx="minor">
+            <a:schemeClr val="lt1"/>
+          </a:fontRef>
+        </p:style>
+        <p:txBody>
+          <a:bodyPr rtlCol="0" anchor="ctr" wrap="square" lIns="19050" rIns="19050" tIns="19050" bIns="19050"/>
+          <a:lstStyle/>
+          <a:p>
+            <a:pPr algn="ctr">
+              <a:lnSpc>
+                <a:spcPct val="122000"/>
+              </a:lnSpc>
+            </a:pPr>
+            <a:r>
+              <a:rPr sz="1400" b="1">
+                <a:solidFill>
+                  <a:srgbClr val="F5F5F8"/>
+                </a:solidFill>
+                <a:latin typeface="Amazon Ember"/>
+                <a:ea typeface="メイリオ"/>
+                <a:cs typeface="メイリオ"/>
+              </a:rPr>
+              <a:t>compile forward</a:t>
+            </a:r>
+          </a:p>
+          <a:p>
+            <a:pPr algn="ctr">
+              <a:lnSpc>
+                <a:spcPct val="122000"/>
+              </a:lnSpc>
+            </a:pPr>
+            <a:r>
+              <a:rPr sz="1400" b="1">
+                <a:solidFill>
+                  <a:srgbClr val="F5F5F8"/>
+                </a:solidFill>
+                <a:latin typeface="Amazon Ember"/>
+                <a:ea typeface="メイリオ"/>
+                <a:cs typeface="メイリオ"/>
+              </a:rPr>
+              <a:t>per bucket to NEFF</a:t>
+            </a:r>
+          </a:p>
+        </p:txBody>
+      </p:sp>
+      <p:sp>
+        <p:nvSpPr>
+          <p:cNvPr id="25" name="Oval 24"/>
+          <p:cNvSpPr/>
+          <p:nvPr/>
+        </p:nvSpPr>
+        <p:spPr>
+          <a:xfrm>
+            <a:off x="9220200" y="2571750"/>
+            <a:ext cx="247650" cy="247650"/>
+          </a:xfrm>
+          <a:prstGeom prst="ellipse">
+            <a:avLst/>
+          </a:prstGeom>
+          <a:solidFill>
+            <a:srgbClr val="FBD332"/>
+          </a:solidFill>
+          <a:ln>
+            <a:noFill/>
+          </a:ln>
+          <a:effectLst/>
+        </p:spPr>
+        <p:style>
+          <a:lnRef idx="1">
+            <a:schemeClr val="accent1"/>
+          </a:lnRef>
+          <a:fillRef idx="3">
+            <a:schemeClr val="accent1"/>
+          </a:fillRef>
+          <a:effectRef idx="2">
+            <a:schemeClr val="accent1"/>
+          </a:effectRef>
+          <a:fontRef idx="minor">
+            <a:schemeClr val="lt1"/>
+          </a:fontRef>
+        </p:style>
+        <p:txBody>
+          <a:bodyPr rtlCol="0" anchor="ctr" wrap="square"/>
+          <a:lstStyle/>
+          <a:p>
+            <a:pPr algn="ctr">
+              <a:lnSpc>
+                <a:spcPct val="122000"/>
+              </a:lnSpc>
+            </a:pPr>
+            <a:r>
+              <a:rPr sz="1200" b="1">
+                <a:solidFill>
+                  <a:srgbClr val="000000"/>
+                </a:solidFill>
+                <a:latin typeface="Amazon Ember"/>
+                <a:ea typeface="メイリオ"/>
+                <a:cs typeface="メイリオ"/>
+              </a:rPr>
+              <a:t>8</a:t>
+            </a:r>
+          </a:p>
+        </p:txBody>
+      </p:sp>
+      <p:cxnSp>
+        <p:nvCxnSpPr>
+          <p:cNvPr id="26" name="Connector 25"/>
+          <p:cNvCxnSpPr/>
+          <p:nvPr/>
+        </p:nvCxnSpPr>
+        <p:spPr>
+          <a:xfrm>
+            <a:off x="2714625" y="2171700"/>
+            <a:ext cx="0" cy="514350"/>
+          </a:xfrm>
+          <a:prstGeom prst="line">
+            <a:avLst/>
+          </a:prstGeom>
+          <a:ln w="25400">
+            <a:solidFill>
+              <a:srgbClr val="F5F5F8"/>
+            </a:solidFill>
+            <a:tailEnd type="triangle" w="med" len="med"/>
+          </a:ln>
+          <a:effectLst/>
+        </p:spPr>
+        <p:style>
+          <a:lnRef idx="2">
+            <a:schemeClr val="accent1"/>
+          </a:lnRef>
+          <a:fillRef idx="0">
+            <a:schemeClr val="accent1"/>
+          </a:fillRef>
+          <a:effectRef idx="1">
+            <a:schemeClr val="accent1"/>
+          </a:effectRef>
+          <a:fontRef idx="minor">
+            <a:schemeClr val="tx1"/>
+          </a:fontRef>
+        </p:style>
+      </p:cxnSp>
+      <p:cxnSp>
+        <p:nvCxnSpPr>
+          <p:cNvPr id="27" name="Connector 26"/>
+          <p:cNvCxnSpPr/>
+          <p:nvPr/>
+        </p:nvCxnSpPr>
+        <p:spPr>
+          <a:xfrm>
+            <a:off x="3524250" y="3143250"/>
+            <a:ext cx="1047750" cy="971550"/>
+          </a:xfrm>
+          <a:prstGeom prst="line">
+            <a:avLst/>
+          </a:prstGeom>
+          <a:ln w="25400">
+            <a:solidFill>
+              <a:srgbClr val="F5F5F8"/>
+            </a:solidFill>
+            <a:tailEnd type="triangle" w="med" len="med"/>
+          </a:ln>
+          <a:effectLst/>
+        </p:spPr>
+        <p:style>
+          <a:lnRef idx="2">
+            <a:schemeClr val="accent1"/>
+          </a:lnRef>
+          <a:fillRef idx="0">
+            <a:schemeClr val="accent1"/>
+          </a:fillRef>
+          <a:effectRef idx="1">
+            <a:schemeClr val="accent1"/>
+          </a:effectRef>
+          <a:fontRef idx="minor">
+            <a:schemeClr val="tx1"/>
+          </a:fontRef>
+        </p:style>
+      </p:cxnSp>
+      <p:cxnSp>
+        <p:nvCxnSpPr>
+          <p:cNvPr id="28" name="Connector 27"/>
+          <p:cNvCxnSpPr/>
+          <p:nvPr/>
+        </p:nvCxnSpPr>
+        <p:spPr>
+          <a:xfrm>
+            <a:off x="5381625" y="4572000"/>
+            <a:ext cx="238125" cy="0"/>
+          </a:xfrm>
+          <a:prstGeom prst="line">
+            <a:avLst/>
+          </a:prstGeom>
+          <a:ln w="25400">
+            <a:solidFill>
+              <a:srgbClr val="F5F5F8"/>
+            </a:solidFill>
+            <a:tailEnd type="triangle" w="med" len="med"/>
+          </a:ln>
+          <a:effectLst/>
+        </p:spPr>
+        <p:style>
+          <a:lnRef idx="2">
+            <a:schemeClr val="accent1"/>
+          </a:lnRef>
+          <a:fillRef idx="0">
+            <a:schemeClr val="accent1"/>
+          </a:fillRef>
+          <a:effectRef idx="1">
+            <a:schemeClr val="accent1"/>
+          </a:effectRef>
+          <a:fontRef idx="minor">
+            <a:schemeClr val="tx1"/>
+          </a:fontRef>
+        </p:style>
+      </p:cxnSp>
+      <p:cxnSp>
+        <p:nvCxnSpPr>
+          <p:cNvPr id="29" name="Connector 28"/>
+          <p:cNvCxnSpPr/>
+          <p:nvPr/>
+        </p:nvCxnSpPr>
+        <p:spPr>
+          <a:xfrm>
+            <a:off x="7239000" y="4572000"/>
+            <a:ext cx="238125" cy="0"/>
+          </a:xfrm>
+          <a:prstGeom prst="line">
+            <a:avLst/>
+          </a:prstGeom>
+          <a:ln w="25400">
+            <a:solidFill>
+              <a:srgbClr val="F5F5F8"/>
+            </a:solidFill>
+            <a:tailEnd type="triangle" w="med" len="med"/>
+          </a:ln>
+          <a:effectLst/>
+        </p:spPr>
+        <p:style>
+          <a:lnRef idx="2">
+            <a:schemeClr val="accent1"/>
+          </a:lnRef>
+          <a:fillRef idx="0">
+            <a:schemeClr val="accent1"/>
+          </a:fillRef>
+          <a:effectRef idx="1">
+            <a:schemeClr val="accent1"/>
+          </a:effectRef>
+          <a:fontRef idx="minor">
+            <a:schemeClr val="tx1"/>
+          </a:fontRef>
+        </p:style>
+      </p:cxnSp>
+      <p:cxnSp>
+        <p:nvCxnSpPr>
+          <p:cNvPr id="30" name="Connector 29"/>
+          <p:cNvCxnSpPr/>
+          <p:nvPr/>
+        </p:nvCxnSpPr>
+        <p:spPr>
+          <a:xfrm flipV="1">
+            <a:off x="8286750" y="3600450"/>
+            <a:ext cx="0" cy="514350"/>
+          </a:xfrm>
+          <a:prstGeom prst="line">
+            <a:avLst/>
+          </a:prstGeom>
+          <a:ln w="25400">
+            <a:solidFill>
+              <a:srgbClr val="F5F5F8"/>
+            </a:solidFill>
+            <a:tailEnd type="triangle" w="med" len="med"/>
+          </a:ln>
+          <a:effectLst/>
+        </p:spPr>
+        <p:style>
+          <a:lnRef idx="2">
+            <a:schemeClr val="accent1"/>
+          </a:lnRef>
+          <a:fillRef idx="0">
+            <a:schemeClr val="accent1"/>
+          </a:fillRef>
+          <a:effectRef idx="1">
+            <a:schemeClr val="accent1"/>
+          </a:effectRef>
+          <a:fontRef idx="minor">
+            <a:schemeClr val="tx1"/>
+          </a:fontRef>
+        </p:style>
+      </p:cxnSp>
+      <p:cxnSp>
+        <p:nvCxnSpPr>
+          <p:cNvPr id="31" name="Connector 30"/>
+          <p:cNvCxnSpPr/>
+          <p:nvPr/>
+        </p:nvCxnSpPr>
+        <p:spPr>
+          <a:xfrm>
+            <a:off x="8763000" y="3600450"/>
+            <a:ext cx="857250" cy="514350"/>
+          </a:xfrm>
+          <a:prstGeom prst="line">
+            <a:avLst/>
+          </a:prstGeom>
+          <a:ln w="25400">
+            <a:solidFill>
+              <a:srgbClr val="F5F5F8"/>
+            </a:solidFill>
+            <a:tailEnd type="triangle" w="med" len="med"/>
+          </a:ln>
+          <a:effectLst/>
+        </p:spPr>
+        <p:style>
+          <a:lnRef idx="2">
+            <a:schemeClr val="accent1"/>
+          </a:lnRef>
+          <a:fillRef idx="0">
+            <a:schemeClr val="accent1"/>
+          </a:fillRef>
+          <a:effectRef idx="1">
+            <a:schemeClr val="accent1"/>
+          </a:effectRef>
+          <a:fontRef idx="minor">
+            <a:schemeClr val="tx1"/>
+          </a:fontRef>
+        </p:style>
+      </p:cxnSp>
+      <p:cxnSp>
+        <p:nvCxnSpPr>
+          <p:cNvPr id="32" name="Connector 31"/>
+          <p:cNvCxnSpPr/>
+          <p:nvPr/>
+        </p:nvCxnSpPr>
+        <p:spPr>
+          <a:xfrm flipV="1">
+            <a:off x="10477500" y="3600450"/>
+            <a:ext cx="0" cy="514350"/>
+          </a:xfrm>
+          <a:prstGeom prst="line">
+            <a:avLst/>
+          </a:prstGeom>
+          <a:ln w="25400">
+            <a:solidFill>
+              <a:srgbClr val="F5F5F8"/>
+            </a:solidFill>
+            <a:tailEnd type="triangle" w="med" len="med"/>
+          </a:ln>
+          <a:effectLst/>
+        </p:spPr>
+        <p:style>
+          <a:lnRef idx="2">
+            <a:schemeClr val="accent1"/>
+          </a:lnRef>
+          <a:fillRef idx="0">
+            <a:schemeClr val="accent1"/>
+          </a:fillRef>
+          <a:effectRef idx="1">
+            <a:schemeClr val="accent1"/>
+          </a:effectRef>
+          <a:fontRef idx="minor">
+            <a:schemeClr val="tx1"/>
+          </a:fontRef>
+        </p:style>
+      </p:cxnSp>
+      <p:sp>
+        <p:nvSpPr>
+          <p:cNvPr id="33" name="Rounded Rectangle 32"/>
+          <p:cNvSpPr/>
+          <p:nvPr/>
+        </p:nvSpPr>
+        <p:spPr>
+          <a:xfrm>
+            <a:off x="409575" y="5391150"/>
+            <a:ext cx="11372850" cy="438150"/>
+          </a:xfrm>
+          <a:prstGeom prst="roundRect">
+            <a:avLst>
+              <a:gd name="adj" fmla="val 30000"/>
+            </a:avLst>
+          </a:prstGeom>
+          <a:solidFill>
+            <a:srgbClr val="50420E"/>
+          </a:solidFill>
+          <a:ln w="15875">
+            <a:solidFill>
+              <a:srgbClr val="FBD332"/>
+            </a:solidFill>
+          </a:ln>
+          <a:effectLst/>
+        </p:spPr>
+        <p:style>
+          <a:lnRef idx="1">
+            <a:schemeClr val="accent1"/>
+          </a:lnRef>
+          <a:fillRef idx="3">
+            <a:schemeClr val="accent1"/>
+          </a:fillRef>
+          <a:effectRef idx="2">
+            <a:schemeClr val="accent1"/>
+          </a:effectRef>
+          <a:fontRef idx="minor">
+            <a:schemeClr val="lt1"/>
+          </a:fontRef>
+        </p:style>
+        <p:txBody>
+          <a:bodyPr rtlCol="0" anchor="ctr" wrap="square" lIns="19050" rIns="19050" tIns="19050" bIns="19050"/>
+          <a:lstStyle/>
+          <a:p>
+            <a:pPr algn="ctr">
+              <a:lnSpc>
+                <a:spcPct val="122000"/>
+              </a:lnSpc>
+            </a:pPr>
+            <a:r>
+              <a:rPr sz="1400" b="1">
+                <a:solidFill>
+                  <a:srgbClr val="F5F5F8"/>
+                </a:solidFill>
+                <a:latin typeface="Amazon Ember"/>
+                <a:ea typeface="メイリオ"/>
+                <a:cs typeface="メイリオ"/>
+              </a:rPr>
+              <a:t>KV cache: vLLM decides how many blocks each request gets; the plugin owns the memory; your model only reads and writes it</a:t>
+            </a:r>
+          </a:p>
+        </p:txBody>
+      </p:sp>
+    </p:spTree>
+  </p:cSld>
+  <p:clrMapOvr>
+    <a:masterClrMapping/>
+  </p:clrMapOvr>
+</p:sld>
+</file>
+
+<file path=ppt/slides/slide12.xml><?xml version="1.0" encoding="utf-8"?>
+<p:sld xmlns:a="http://schemas.openxmlformats.org/drawingml/2006/main" xmlns:p="http://schemas.openxmlformats.org/presentationml/2006/main" xmlns:r="http://schemas.openxmlformats.org/officeDocument/2006/relationships" showMasterSp="0">
+  <p:cSld>
+    <p:spTree>
+      <p:nvGrpSpPr>
+        <p:cNvPr id="1" name=""/>
+        <p:cNvGrpSpPr/>
+        <p:nvPr/>
+      </p:nvGrpSpPr>
+      <p:grpSpPr/>
+      <p:sp>
+        <p:nvSpPr>
+          <p:cNvPr id="2" name="TextBox 1"/>
+          <p:cNvSpPr txBox="1"/>
+          <p:nvPr/>
+        </p:nvSpPr>
+        <p:spPr>
+          <a:xfrm>
+            <a:off x="409575" y="247650"/>
+            <a:ext cx="11334750" cy="438150"/>
+          </a:xfrm>
+          <a:prstGeom prst="rect">
+            <a:avLst/>
+          </a:prstGeom>
+          <a:noFill/>
+        </p:spPr>
+        <p:txBody>
+          <a:bodyPr wrap="square" lIns="0" rIns="0" tIns="0" bIns="0" anchor="ctr">
+            <a:spAutoFit/>
+          </a:bodyPr>
+          <a:lstStyle/>
+          <a:p>
+            <a:pPr algn="l">
+              <a:lnSpc>
+                <a:spcPct val="122000"/>
+              </a:lnSpc>
+            </a:pPr>
+            <a:r>
+              <a:rPr sz="3000" b="1">
+                <a:solidFill>
+                  <a:srgbClr val="F5F5F8"/>
+                </a:solidFill>
+                <a:latin typeface="Amazon Ember"/>
+                <a:ea typeface="メイリオ"/>
+                <a:cs typeface="メイリオ"/>
+              </a:rPr>
+              <a:t>Every step: vLLM decides what to run, your model computes it</a:t>
+            </a:r>
+          </a:p>
+        </p:txBody>
+      </p:sp>
+      <p:sp>
+        <p:nvSpPr>
+          <p:cNvPr id="3" name="TextBox 2"/>
+          <p:cNvSpPr txBox="1"/>
+          <p:nvPr/>
+        </p:nvSpPr>
+        <p:spPr>
+          <a:xfrm>
+            <a:off x="409575" y="685800"/>
+            <a:ext cx="11334750" cy="247650"/>
+          </a:xfrm>
+          <a:prstGeom prst="rect">
+            <a:avLst/>
+          </a:prstGeom>
+          <a:noFill/>
+        </p:spPr>
+        <p:txBody>
+          <a:bodyPr wrap="square" lIns="0" rIns="0" tIns="0" bIns="0" anchor="ctr">
+            <a:spAutoFit/>
+          </a:bodyPr>
+          <a:lstStyle/>
+          <a:p>
+            <a:pPr algn="l">
+              <a:lnSpc>
+                <a:spcPct val="122000"/>
+              </a:lnSpc>
+            </a:pPr>
+            <a:r>
+              <a:rPr sz="1600" b="0">
+                <a:solidFill>
+                  <a:srgbClr val="96969E"/>
+                </a:solidFill>
+                <a:latin typeface="Amazon Ember"/>
+                <a:ea typeface="メイリオ"/>
+                <a:cs typeface="メイリオ"/>
+              </a:rPr>
+              <a:t>Numbers: order within one step.  Prefill and decode never share a step</a:t>
+            </a:r>
+          </a:p>
+        </p:txBody>
+      </p:sp>
+      <p:sp>
+        <p:nvSpPr>
+          <p:cNvPr id="4" name="Rectangle 3"/>
+          <p:cNvSpPr/>
+          <p:nvPr/>
+        </p:nvSpPr>
+        <p:spPr>
+          <a:xfrm>
+            <a:off x="409575" y="1066800"/>
+            <a:ext cx="11372850" cy="1295400"/>
+          </a:xfrm>
+          <a:prstGeom prst="rect">
+            <a:avLst/>
+          </a:prstGeom>
+          <a:solidFill>
+            <a:srgbClr val="161A1E"/>
+          </a:solidFill>
+          <a:ln w="9525">
+            <a:solidFill>
+              <a:srgbClr val="464A50"/>
+            </a:solidFill>
+          </a:ln>
+          <a:effectLst/>
+        </p:spPr>
+        <p:style>
+          <a:lnRef idx="1">
+            <a:schemeClr val="accent1"/>
+          </a:lnRef>
+          <a:fillRef idx="3">
+            <a:schemeClr val="accent1"/>
+          </a:fillRef>
+          <a:effectRef idx="2">
+            <a:schemeClr val="accent1"/>
+          </a:effectRef>
+          <a:fontRef idx="minor">
+            <a:schemeClr val="lt1"/>
+          </a:fontRef>
+        </p:style>
+        <p:txBody>
+          <a:bodyPr rtlCol="0" anchor="ctr"/>
+          <a:lstStyle/>
+          <a:p>
+            <a:pPr algn="ctr"/>
+          </a:p>
+        </p:txBody>
+      </p:sp>
+      <p:sp>
+        <p:nvSpPr>
+          <p:cNvPr id="5" name="TextBox 4"/>
+          <p:cNvSpPr txBox="1"/>
+          <p:nvPr/>
+        </p:nvSpPr>
+        <p:spPr>
+          <a:xfrm>
+            <a:off x="485775" y="1066800"/>
+            <a:ext cx="1238250" cy="1295400"/>
+          </a:xfrm>
+          <a:prstGeom prst="rect">
+            <a:avLst/>
+          </a:prstGeom>
+          <a:noFill/>
+        </p:spPr>
+        <p:txBody>
+          <a:bodyPr wrap="square" lIns="0" rIns="0" tIns="0" bIns="0" anchor="ctr">
+            <a:spAutoFit/>
+          </a:bodyPr>
+          <a:lstStyle/>
+          <a:p>
+            <a:pPr algn="l">
+              <a:lnSpc>
+                <a:spcPct val="122000"/>
+              </a:lnSpc>
+            </a:pPr>
+            <a:r>
+              <a:rPr sz="1600" b="1">
+                <a:solidFill>
+                  <a:srgbClr val="96969E"/>
+                </a:solidFill>
+                <a:latin typeface="Amazon Ember"/>
+                <a:ea typeface="メイリオ"/>
+                <a:cs typeface="メイリオ"/>
+              </a:rPr>
+              <a:t>vLLM</a:t>
+            </a:r>
+          </a:p>
+        </p:txBody>
+      </p:sp>
+      <p:sp>
+        <p:nvSpPr>
+          <p:cNvPr id="6" name="Rectangle 5"/>
+          <p:cNvSpPr/>
+          <p:nvPr/>
+        </p:nvSpPr>
+        <p:spPr>
+          <a:xfrm>
+            <a:off x="409575" y="2495550"/>
+            <a:ext cx="11372850" cy="1295400"/>
+          </a:xfrm>
+          <a:prstGeom prst="rect">
+            <a:avLst/>
+          </a:prstGeom>
+          <a:solidFill>
+            <a:srgbClr val="161A1E"/>
+          </a:solidFill>
+          <a:ln w="9525">
+            <a:solidFill>
+              <a:srgbClr val="464A50"/>
+            </a:solidFill>
+          </a:ln>
+          <a:effectLst/>
+        </p:spPr>
+        <p:style>
+          <a:lnRef idx="1">
+            <a:schemeClr val="accent1"/>
+          </a:lnRef>
+          <a:fillRef idx="3">
+            <a:schemeClr val="accent1"/>
+          </a:fillRef>
+          <a:effectRef idx="2">
+            <a:schemeClr val="accent1"/>
+          </a:effectRef>
+          <a:fontRef idx="minor">
+            <a:schemeClr val="lt1"/>
+          </a:fontRef>
+        </p:style>
+        <p:txBody>
+          <a:bodyPr rtlCol="0" anchor="ctr"/>
+          <a:lstStyle/>
+          <a:p>
+            <a:pPr algn="ctr"/>
+          </a:p>
+        </p:txBody>
+      </p:sp>
+      <p:sp>
+        <p:nvSpPr>
+          <p:cNvPr id="7" name="TextBox 6"/>
+          <p:cNvSpPr txBox="1"/>
+          <p:nvPr/>
+        </p:nvSpPr>
+        <p:spPr>
+          <a:xfrm>
+            <a:off x="485775" y="2495550"/>
+            <a:ext cx="1238250" cy="1295400"/>
+          </a:xfrm>
+          <a:prstGeom prst="rect">
+            <a:avLst/>
+          </a:prstGeom>
+          <a:noFill/>
+        </p:spPr>
+        <p:txBody>
+          <a:bodyPr wrap="square" lIns="0" rIns="0" tIns="0" bIns="0" anchor="ctr">
+            <a:spAutoFit/>
+          </a:bodyPr>
+          <a:lstStyle/>
+          <a:p>
+            <a:pPr algn="l">
+              <a:lnSpc>
+                <a:spcPct val="122000"/>
+              </a:lnSpc>
+            </a:pPr>
+            <a:r>
+              <a:rPr sz="1600" b="1">
+                <a:solidFill>
+                  <a:srgbClr val="2896F0"/>
+                </a:solidFill>
+                <a:latin typeface="Amazon Ember"/>
+                <a:ea typeface="メイリオ"/>
+                <a:cs typeface="メイリオ"/>
+              </a:rPr>
+              <a:t>Neuron plugin</a:t>
+            </a:r>
+          </a:p>
+        </p:txBody>
+      </p:sp>
+      <p:sp>
+        <p:nvSpPr>
+          <p:cNvPr id="8" name="Rectangle 7"/>
+          <p:cNvSpPr/>
+          <p:nvPr/>
+        </p:nvSpPr>
+        <p:spPr>
+          <a:xfrm>
+            <a:off x="409575" y="3924300"/>
+            <a:ext cx="11372850" cy="1295400"/>
+          </a:xfrm>
+          <a:prstGeom prst="rect">
+            <a:avLst/>
+          </a:prstGeom>
+          <a:solidFill>
+            <a:srgbClr val="161A1E"/>
+          </a:solidFill>
+          <a:ln w="9525">
+            <a:solidFill>
+              <a:srgbClr val="464A50"/>
+            </a:solidFill>
+          </a:ln>
+          <a:effectLst/>
+        </p:spPr>
+        <p:style>
+          <a:lnRef idx="1">
+            <a:schemeClr val="accent1"/>
+          </a:lnRef>
+          <a:fillRef idx="3">
+            <a:schemeClr val="accent1"/>
+          </a:fillRef>
+          <a:effectRef idx="2">
+            <a:schemeClr val="accent1"/>
+          </a:effectRef>
+          <a:fontRef idx="minor">
+            <a:schemeClr val="lt1"/>
+          </a:fontRef>
+        </p:style>
+        <p:txBody>
+          <a:bodyPr rtlCol="0" anchor="ctr"/>
+          <a:lstStyle/>
+          <a:p>
+            <a:pPr algn="ctr"/>
+          </a:p>
+        </p:txBody>
+      </p:sp>
+      <p:sp>
+        <p:nvSpPr>
+          <p:cNvPr id="9" name="TextBox 8"/>
+          <p:cNvSpPr txBox="1"/>
+          <p:nvPr/>
+        </p:nvSpPr>
+        <p:spPr>
+          <a:xfrm>
+            <a:off x="485775" y="3924300"/>
+            <a:ext cx="1238250" cy="1295400"/>
+          </a:xfrm>
+          <a:prstGeom prst="rect">
+            <a:avLst/>
+          </a:prstGeom>
+          <a:noFill/>
+        </p:spPr>
+        <p:txBody>
+          <a:bodyPr wrap="square" lIns="0" rIns="0" tIns="0" bIns="0" anchor="ctr">
+            <a:spAutoFit/>
+          </a:bodyPr>
+          <a:lstStyle/>
+          <a:p>
+            <a:pPr algn="l">
+              <a:lnSpc>
+                <a:spcPct val="122000"/>
+              </a:lnSpc>
+            </a:pPr>
+            <a:r>
+              <a:rPr sz="1600" b="1">
+                <a:solidFill>
+                  <a:srgbClr val="3BD16F"/>
+                </a:solidFill>
+                <a:latin typeface="Amazon Ember"/>
+                <a:ea typeface="メイリオ"/>
+                <a:cs typeface="メイリオ"/>
+              </a:rPr>
+              <a:t>your model</a:t>
+            </a:r>
+          </a:p>
+          <a:p>
+            <a:pPr algn="l">
+              <a:lnSpc>
+                <a:spcPct val="122000"/>
+              </a:lnSpc>
+            </a:pPr>
+            <a:r>
+              <a:rPr sz="1600" b="1">
+                <a:solidFill>
+                  <a:srgbClr val="3BD16F"/>
+                </a:solidFill>
+                <a:latin typeface="Amazon Ember"/>
+                <a:ea typeface="メイリオ"/>
+                <a:cs typeface="メイリオ"/>
+              </a:rPr>
+              <a:t>(BYOM)</a:t>
+            </a:r>
+          </a:p>
+        </p:txBody>
+      </p:sp>
+      <p:sp>
+        <p:nvSpPr>
+          <p:cNvPr id="10" name="Rounded Rectangle 9"/>
+          <p:cNvSpPr/>
+          <p:nvPr/>
+        </p:nvSpPr>
+        <p:spPr>
+          <a:xfrm>
+            <a:off x="1905000" y="1257300"/>
+            <a:ext cx="1809750" cy="914400"/>
+          </a:xfrm>
+          <a:prstGeom prst="roundRect">
+            <a:avLst>
+              <a:gd name="adj" fmla="val 10000"/>
+            </a:avLst>
+          </a:prstGeom>
+          <a:solidFill>
+            <a:srgbClr val="343840"/>
+          </a:solidFill>
+          <a:ln w="15875">
+            <a:solidFill>
+              <a:srgbClr val="464A50"/>
+            </a:solidFill>
+          </a:ln>
+          <a:effectLst/>
+        </p:spPr>
+        <p:style>
+          <a:lnRef idx="1">
+            <a:schemeClr val="accent1"/>
+          </a:lnRef>
+          <a:fillRef idx="3">
+            <a:schemeClr val="accent1"/>
+          </a:fillRef>
+          <a:effectRef idx="2">
+            <a:schemeClr val="accent1"/>
+          </a:effectRef>
+          <a:fontRef idx="minor">
+            <a:schemeClr val="lt1"/>
+          </a:fontRef>
+        </p:style>
+        <p:txBody>
+          <a:bodyPr rtlCol="0" anchor="ctr" wrap="square" lIns="19050" rIns="19050" tIns="19050" bIns="19050"/>
+          <a:lstStyle/>
+          <a:p>
+            <a:pPr algn="ctr">
+              <a:lnSpc>
+                <a:spcPct val="122000"/>
+              </a:lnSpc>
+            </a:pPr>
+            <a:r>
+              <a:rPr sz="1400" b="1">
+                <a:solidFill>
+                  <a:srgbClr val="F5F5F8"/>
+                </a:solidFill>
+                <a:latin typeface="Amazon Ember"/>
+                <a:ea typeface="メイリオ"/>
+                <a:cs typeface="メイリオ"/>
+              </a:rPr>
+              <a:t>request in,</a:t>
+            </a:r>
+          </a:p>
+          <a:p>
+            <a:pPr algn="ctr">
+              <a:lnSpc>
+                <a:spcPct val="122000"/>
+              </a:lnSpc>
+            </a:pPr>
+            <a:r>
+              <a:rPr sz="1400" b="1">
+                <a:solidFill>
+                  <a:srgbClr val="F5F5F8"/>
+                </a:solidFill>
+                <a:latin typeface="Amazon Ember"/>
+                <a:ea typeface="メイリオ"/>
+                <a:cs typeface="メイリオ"/>
+              </a:rPr>
+              <a:t>KV blocks assigned</a:t>
+            </a:r>
+          </a:p>
+        </p:txBody>
+      </p:sp>
+      <p:sp>
+        <p:nvSpPr>
+          <p:cNvPr id="11" name="Oval 10"/>
+          <p:cNvSpPr/>
+          <p:nvPr/>
+        </p:nvSpPr>
+        <p:spPr>
+          <a:xfrm>
+            <a:off x="1790700" y="1143000"/>
+            <a:ext cx="247650" cy="247650"/>
+          </a:xfrm>
+          <a:prstGeom prst="ellipse">
+            <a:avLst/>
+          </a:prstGeom>
+          <a:solidFill>
+            <a:srgbClr val="FBD332"/>
+          </a:solidFill>
+          <a:ln>
+            <a:noFill/>
+          </a:ln>
+          <a:effectLst/>
+        </p:spPr>
+        <p:style>
+          <a:lnRef idx="1">
+            <a:schemeClr val="accent1"/>
+          </a:lnRef>
+          <a:fillRef idx="3">
+            <a:schemeClr val="accent1"/>
+          </a:fillRef>
+          <a:effectRef idx="2">
+            <a:schemeClr val="accent1"/>
+          </a:effectRef>
+          <a:fontRef idx="minor">
+            <a:schemeClr val="lt1"/>
+          </a:fontRef>
+        </p:style>
+        <p:txBody>
+          <a:bodyPr rtlCol="0" anchor="ctr" wrap="square"/>
+          <a:lstStyle/>
+          <a:p>
+            <a:pPr algn="ctr">
+              <a:lnSpc>
+                <a:spcPct val="122000"/>
+              </a:lnSpc>
+            </a:pPr>
+            <a:r>
+              <a:rPr sz="1200" b="1">
+                <a:solidFill>
+                  <a:srgbClr val="000000"/>
+                </a:solidFill>
+                <a:latin typeface="Amazon Ember"/>
+                <a:ea typeface="メイリオ"/>
+                <a:cs typeface="メイリオ"/>
+              </a:rPr>
+              <a:t>1</a:t>
+            </a:r>
+          </a:p>
+        </p:txBody>
+      </p:sp>
+      <p:sp>
+        <p:nvSpPr>
+          <p:cNvPr id="12" name="Rounded Rectangle 11"/>
+          <p:cNvSpPr/>
+          <p:nvPr/>
+        </p:nvSpPr>
+        <p:spPr>
+          <a:xfrm>
+            <a:off x="1905000" y="2686050"/>
+            <a:ext cx="1809750" cy="914400"/>
+          </a:xfrm>
+          <a:prstGeom prst="roundRect">
+            <a:avLst>
+              <a:gd name="adj" fmla="val 10000"/>
+            </a:avLst>
+          </a:prstGeom>
+          <a:solidFill>
+            <a:srgbClr val="102C48"/>
+          </a:solidFill>
+          <a:ln w="15875">
+            <a:solidFill>
+              <a:srgbClr val="2896F0"/>
+            </a:solidFill>
+          </a:ln>
+          <a:effectLst/>
+        </p:spPr>
+        <p:style>
+          <a:lnRef idx="1">
+            <a:schemeClr val="accent1"/>
+          </a:lnRef>
+          <a:fillRef idx="3">
+            <a:schemeClr val="accent1"/>
+          </a:fillRef>
+          <a:effectRef idx="2">
+            <a:schemeClr val="accent1"/>
+          </a:effectRef>
+          <a:fontRef idx="minor">
+            <a:schemeClr val="lt1"/>
+          </a:fontRef>
+        </p:style>
+        <p:txBody>
+          <a:bodyPr rtlCol="0" anchor="ctr" wrap="square" lIns="19050" rIns="19050" tIns="19050" bIns="19050"/>
+          <a:lstStyle/>
+          <a:p>
+            <a:pPr algn="ctr">
+              <a:lnSpc>
+                <a:spcPct val="122000"/>
+              </a:lnSpc>
+            </a:pPr>
+            <a:r>
+              <a:rPr sz="1400" b="1">
+                <a:solidFill>
+                  <a:srgbClr val="F5F5F8"/>
+                </a:solidFill>
+                <a:latin typeface="Amazon Ember"/>
+                <a:ea typeface="メイリオ"/>
+                <a:cs typeface="メイリオ"/>
+              </a:rPr>
+              <a:t>scheduler: a prefill</a:t>
+            </a:r>
+          </a:p>
+          <a:p>
+            <a:pPr algn="ctr">
+              <a:lnSpc>
+                <a:spcPct val="122000"/>
+              </a:lnSpc>
+            </a:pPr>
+            <a:r>
+              <a:rPr sz="1400" b="1">
+                <a:solidFill>
+                  <a:srgbClr val="F5F5F8"/>
+                </a:solidFill>
+                <a:latin typeface="Amazon Ember"/>
+                <a:ea typeface="メイリオ"/>
+                <a:cs typeface="メイリオ"/>
+              </a:rPr>
+              <a:t>or a decode batch</a:t>
+            </a:r>
+          </a:p>
+        </p:txBody>
+      </p:sp>
+      <p:sp>
+        <p:nvSpPr>
+          <p:cNvPr id="13" name="Oval 12"/>
+          <p:cNvSpPr/>
+          <p:nvPr/>
+        </p:nvSpPr>
+        <p:spPr>
+          <a:xfrm>
+            <a:off x="1790700" y="2571750"/>
+            <a:ext cx="247650" cy="247650"/>
+          </a:xfrm>
+          <a:prstGeom prst="ellipse">
+            <a:avLst/>
+          </a:prstGeom>
+          <a:solidFill>
+            <a:srgbClr val="FBD332"/>
+          </a:solidFill>
+          <a:ln>
+            <a:noFill/>
+          </a:ln>
+          <a:effectLst/>
+        </p:spPr>
+        <p:style>
+          <a:lnRef idx="1">
+            <a:schemeClr val="accent1"/>
+          </a:lnRef>
+          <a:fillRef idx="3">
+            <a:schemeClr val="accent1"/>
+          </a:fillRef>
+          <a:effectRef idx="2">
+            <a:schemeClr val="accent1"/>
+          </a:effectRef>
+          <a:fontRef idx="minor">
+            <a:schemeClr val="lt1"/>
+          </a:fontRef>
+        </p:style>
+        <p:txBody>
+          <a:bodyPr rtlCol="0" anchor="ctr" wrap="square"/>
+          <a:lstStyle/>
+          <a:p>
+            <a:pPr algn="ctr">
+              <a:lnSpc>
+                <a:spcPct val="122000"/>
+              </a:lnSpc>
+            </a:pPr>
+            <a:r>
+              <a:rPr sz="1200" b="1">
+                <a:solidFill>
+                  <a:srgbClr val="000000"/>
+                </a:solidFill>
+                <a:latin typeface="Amazon Ember"/>
+                <a:ea typeface="メイリオ"/>
+                <a:cs typeface="メイリオ"/>
+              </a:rPr>
+              <a:t>2</a:t>
+            </a:r>
+          </a:p>
+        </p:txBody>
+      </p:sp>
+      <p:sp>
+        <p:nvSpPr>
+          <p:cNvPr id="14" name="Rounded Rectangle 13"/>
+          <p:cNvSpPr/>
+          <p:nvPr/>
+        </p:nvSpPr>
+        <p:spPr>
+          <a:xfrm>
+            <a:off x="4048125" y="2686050"/>
+            <a:ext cx="1905000" cy="914400"/>
+          </a:xfrm>
+          <a:prstGeom prst="roundRect">
+            <a:avLst>
+              <a:gd name="adj" fmla="val 10000"/>
+            </a:avLst>
+          </a:prstGeom>
+          <a:solidFill>
+            <a:srgbClr val="102C48"/>
+          </a:solidFill>
+          <a:ln w="15875">
+            <a:solidFill>
+              <a:srgbClr val="2896F0"/>
+            </a:solidFill>
+          </a:ln>
+          <a:effectLst/>
+        </p:spPr>
+        <p:style>
+          <a:lnRef idx="1">
+            <a:schemeClr val="accent1"/>
+          </a:lnRef>
+          <a:fillRef idx="3">
+            <a:schemeClr val="accent1"/>
+          </a:fillRef>
+          <a:effectRef idx="2">
+            <a:schemeClr val="accent1"/>
+          </a:effectRef>
+          <a:fontRef idx="minor">
+            <a:schemeClr val="lt1"/>
+          </a:fontRef>
+        </p:style>
+        <p:txBody>
+          <a:bodyPr rtlCol="0" anchor="ctr" wrap="square" lIns="19050" rIns="19050" tIns="19050" bIns="19050"/>
+          <a:lstStyle/>
+          <a:p>
+            <a:pPr algn="ctr">
+              <a:lnSpc>
+                <a:spcPct val="122000"/>
+              </a:lnSpc>
+            </a:pPr>
+            <a:r>
+              <a:rPr sz="1400" b="1">
+                <a:solidFill>
+                  <a:srgbClr val="F5F5F8"/>
+                </a:solidFill>
+                <a:latin typeface="Amazon Ember"/>
+                <a:ea typeface="メイリオ"/>
+                <a:cs typeface="メイリオ"/>
+              </a:rPr>
+              <a:t>build inputs: tokens,</a:t>
+            </a:r>
+          </a:p>
+          <a:p>
+            <a:pPr algn="ctr">
+              <a:lnSpc>
+                <a:spcPct val="122000"/>
+              </a:lnSpc>
+            </a:pPr>
+            <a:r>
+              <a:rPr sz="1400" b="1">
+                <a:solidFill>
+                  <a:srgbClr val="F5F5F8"/>
+                </a:solidFill>
+                <a:latin typeface="Amazon Ember"/>
+                <a:ea typeface="メイリオ"/>
+                <a:cs typeface="メイリオ"/>
+              </a:rPr>
+              <a:t>positions, block table</a:t>
+            </a:r>
+          </a:p>
+        </p:txBody>
+      </p:sp>
+      <p:sp>
+        <p:nvSpPr>
+          <p:cNvPr id="15" name="Oval 14"/>
+          <p:cNvSpPr/>
+          <p:nvPr/>
+        </p:nvSpPr>
+        <p:spPr>
+          <a:xfrm>
+            <a:off x="3933825" y="2571750"/>
+            <a:ext cx="247650" cy="247650"/>
+          </a:xfrm>
+          <a:prstGeom prst="ellipse">
+            <a:avLst/>
+          </a:prstGeom>
+          <a:solidFill>
+            <a:srgbClr val="FBD332"/>
+          </a:solidFill>
+          <a:ln>
+            <a:noFill/>
+          </a:ln>
+          <a:effectLst/>
+        </p:spPr>
+        <p:style>
+          <a:lnRef idx="1">
+            <a:schemeClr val="accent1"/>
+          </a:lnRef>
+          <a:fillRef idx="3">
+            <a:schemeClr val="accent1"/>
+          </a:fillRef>
+          <a:effectRef idx="2">
+            <a:schemeClr val="accent1"/>
+          </a:effectRef>
+          <a:fontRef idx="minor">
+            <a:schemeClr val="lt1"/>
+          </a:fontRef>
+        </p:style>
+        <p:txBody>
+          <a:bodyPr rtlCol="0" anchor="ctr" wrap="square"/>
+          <a:lstStyle/>
+          <a:p>
+            <a:pPr algn="ctr">
+              <a:lnSpc>
+                <a:spcPct val="122000"/>
+              </a:lnSpc>
+            </a:pPr>
+            <a:r>
+              <a:rPr sz="1200" b="1">
+                <a:solidFill>
+                  <a:srgbClr val="000000"/>
+                </a:solidFill>
+                <a:latin typeface="Amazon Ember"/>
+                <a:ea typeface="メイリオ"/>
+                <a:cs typeface="メイリオ"/>
+              </a:rPr>
+              <a:t>3</a:t>
+            </a:r>
+          </a:p>
+        </p:txBody>
+      </p:sp>
+      <p:sp>
+        <p:nvSpPr>
+          <p:cNvPr id="16" name="Rounded Rectangle 15"/>
+          <p:cNvSpPr/>
+          <p:nvPr/>
+        </p:nvSpPr>
+        <p:spPr>
+          <a:xfrm>
+            <a:off x="6286500" y="4114800"/>
+            <a:ext cx="2857500" cy="914400"/>
+          </a:xfrm>
+          <a:prstGeom prst="roundRect">
+            <a:avLst>
+              <a:gd name="adj" fmla="val 10000"/>
+            </a:avLst>
+          </a:prstGeom>
+          <a:solidFill>
+            <a:srgbClr val="124022"/>
+          </a:solidFill>
+          <a:ln w="15875">
+            <a:solidFill>
+              <a:srgbClr val="24A046"/>
+            </a:solidFill>
+          </a:ln>
+          <a:effectLst/>
+        </p:spPr>
+        <p:style>
+          <a:lnRef idx="1">
+            <a:schemeClr val="accent1"/>
+          </a:lnRef>
+          <a:fillRef idx="3">
+            <a:schemeClr val="accent1"/>
+          </a:fillRef>
+          <a:effectRef idx="2">
+            <a:schemeClr val="accent1"/>
+          </a:effectRef>
+          <a:fontRef idx="minor">
+            <a:schemeClr val="lt1"/>
+          </a:fontRef>
+        </p:style>
+        <p:txBody>
+          <a:bodyPr rtlCol="0" anchor="ctr" wrap="square" lIns="19050" rIns="19050" tIns="19050" bIns="19050"/>
+          <a:lstStyle/>
+          <a:p>
+            <a:pPr algn="ctr">
+              <a:lnSpc>
+                <a:spcPct val="122000"/>
+              </a:lnSpc>
+            </a:pPr>
+            <a:r>
+              <a:rPr sz="1400" b="1">
+                <a:solidFill>
+                  <a:srgbClr val="F5F5F8"/>
+                </a:solidFill>
+                <a:latin typeface="Amazon Ember"/>
+                <a:ea typeface="メイリオ"/>
+                <a:cs typeface="メイリオ"/>
+              </a:rPr>
+              <a:t>forward: find each request's</a:t>
+            </a:r>
+          </a:p>
+          <a:p>
+            <a:pPr algn="ctr">
+              <a:lnSpc>
+                <a:spcPct val="122000"/>
+              </a:lnSpc>
+            </a:pPr>
+            <a:r>
+              <a:rPr sz="1400" b="1">
+                <a:solidFill>
+                  <a:srgbClr val="F5F5F8"/>
+                </a:solidFill>
+                <a:latin typeface="Amazon Ember"/>
+                <a:ea typeface="メイリオ"/>
+                <a:cs typeface="メイリオ"/>
+              </a:rPr>
+              <a:t>state row, run 52 layers</a:t>
+            </a:r>
+          </a:p>
+          <a:p>
+            <a:pPr algn="ctr">
+              <a:lnSpc>
+                <a:spcPct val="122000"/>
+              </a:lnSpc>
+            </a:pPr>
+            <a:r>
+              <a:rPr sz="1400" b="1">
+                <a:solidFill>
+                  <a:srgbClr val="F5F5F8"/>
+                </a:solidFill>
+                <a:latin typeface="Amazon Ember"/>
+                <a:ea typeface="メイリオ"/>
+                <a:cs typeface="メイリオ"/>
+              </a:rPr>
+              <a:t>(NKI kernels), write KV</a:t>
+            </a:r>
+          </a:p>
+        </p:txBody>
+      </p:sp>
+      <p:sp>
+        <p:nvSpPr>
+          <p:cNvPr id="17" name="Oval 16"/>
+          <p:cNvSpPr/>
+          <p:nvPr/>
+        </p:nvSpPr>
+        <p:spPr>
+          <a:xfrm>
+            <a:off x="6172200" y="4000500"/>
+            <a:ext cx="247650" cy="247650"/>
+          </a:xfrm>
+          <a:prstGeom prst="ellipse">
+            <a:avLst/>
+          </a:prstGeom>
+          <a:solidFill>
+            <a:srgbClr val="FBD332"/>
+          </a:solidFill>
+          <a:ln>
+            <a:noFill/>
+          </a:ln>
+          <a:effectLst/>
+        </p:spPr>
+        <p:style>
+          <a:lnRef idx="1">
+            <a:schemeClr val="accent1"/>
+          </a:lnRef>
+          <a:fillRef idx="3">
+            <a:schemeClr val="accent1"/>
+          </a:fillRef>
+          <a:effectRef idx="2">
+            <a:schemeClr val="accent1"/>
+          </a:effectRef>
+          <a:fontRef idx="minor">
+            <a:schemeClr val="lt1"/>
+          </a:fontRef>
+        </p:style>
+        <p:txBody>
+          <a:bodyPr rtlCol="0" anchor="ctr" wrap="square"/>
+          <a:lstStyle/>
+          <a:p>
+            <a:pPr algn="ctr">
+              <a:lnSpc>
+                <a:spcPct val="122000"/>
+              </a:lnSpc>
+            </a:pPr>
+            <a:r>
+              <a:rPr sz="1200" b="1">
+                <a:solidFill>
+                  <a:srgbClr val="000000"/>
+                </a:solidFill>
+                <a:latin typeface="Amazon Ember"/>
+                <a:ea typeface="メイリオ"/>
+                <a:cs typeface="メイリオ"/>
+              </a:rPr>
+              <a:t>4</a:t>
+            </a:r>
+          </a:p>
+        </p:txBody>
+      </p:sp>
+      <p:sp>
+        <p:nvSpPr>
+          <p:cNvPr id="18" name="Rounded Rectangle 17"/>
+          <p:cNvSpPr/>
+          <p:nvPr/>
+        </p:nvSpPr>
+        <p:spPr>
+          <a:xfrm>
+            <a:off x="9477375" y="2686050"/>
+            <a:ext cx="1333500" cy="914400"/>
+          </a:xfrm>
+          <a:prstGeom prst="roundRect">
+            <a:avLst>
+              <a:gd name="adj" fmla="val 10000"/>
+            </a:avLst>
+          </a:prstGeom>
+          <a:solidFill>
+            <a:srgbClr val="102C48"/>
+          </a:solidFill>
+          <a:ln w="15875">
+            <a:solidFill>
+              <a:srgbClr val="2896F0"/>
+            </a:solidFill>
+          </a:ln>
+          <a:effectLst/>
+        </p:spPr>
+        <p:style>
+          <a:lnRef idx="1">
+            <a:schemeClr val="accent1"/>
+          </a:lnRef>
+          <a:fillRef idx="3">
+            <a:schemeClr val="accent1"/>
+          </a:fillRef>
+          <a:effectRef idx="2">
+            <a:schemeClr val="accent1"/>
+          </a:effectRef>
+          <a:fontRef idx="minor">
+            <a:schemeClr val="lt1"/>
+          </a:fontRef>
+        </p:style>
+        <p:txBody>
+          <a:bodyPr rtlCol="0" anchor="ctr" wrap="square" lIns="19050" rIns="19050" tIns="19050" bIns="19050"/>
+          <a:lstStyle/>
+          <a:p>
+            <a:pPr algn="ctr">
+              <a:lnSpc>
+                <a:spcPct val="122000"/>
+              </a:lnSpc>
+            </a:pPr>
+            <a:r>
+              <a:rPr sz="1400" b="1">
+                <a:solidFill>
+                  <a:srgbClr val="F5F5F8"/>
+                </a:solidFill>
+                <a:latin typeface="Amazon Ember"/>
+                <a:ea typeface="メイリオ"/>
+                <a:cs typeface="メイリオ"/>
+              </a:rPr>
+              <a:t>sample</a:t>
+            </a:r>
+          </a:p>
+          <a:p>
+            <a:pPr algn="ctr">
+              <a:lnSpc>
+                <a:spcPct val="122000"/>
+              </a:lnSpc>
+            </a:pPr>
+            <a:r>
+              <a:rPr sz="1400" b="1">
+                <a:solidFill>
+                  <a:srgbClr val="F5F5F8"/>
+                </a:solidFill>
+                <a:latin typeface="Amazon Ember"/>
+                <a:ea typeface="メイリオ"/>
+                <a:cs typeface="メイリオ"/>
+              </a:rPr>
+              <a:t>on device</a:t>
+            </a:r>
+          </a:p>
+        </p:txBody>
+      </p:sp>
+      <p:sp>
+        <p:nvSpPr>
+          <p:cNvPr id="19" name="Oval 18"/>
+          <p:cNvSpPr/>
+          <p:nvPr/>
+        </p:nvSpPr>
+        <p:spPr>
+          <a:xfrm>
+            <a:off x="9363075" y="2571750"/>
+            <a:ext cx="247650" cy="247650"/>
+          </a:xfrm>
+          <a:prstGeom prst="ellipse">
+            <a:avLst/>
+          </a:prstGeom>
+          <a:solidFill>
+            <a:srgbClr val="FBD332"/>
+          </a:solidFill>
+          <a:ln>
+            <a:noFill/>
+          </a:ln>
+          <a:effectLst/>
+        </p:spPr>
+        <p:style>
+          <a:lnRef idx="1">
+            <a:schemeClr val="accent1"/>
+          </a:lnRef>
+          <a:fillRef idx="3">
+            <a:schemeClr val="accent1"/>
+          </a:fillRef>
+          <a:effectRef idx="2">
+            <a:schemeClr val="accent1"/>
+          </a:effectRef>
+          <a:fontRef idx="minor">
+            <a:schemeClr val="lt1"/>
+          </a:fontRef>
+        </p:style>
+        <p:txBody>
+          <a:bodyPr rtlCol="0" anchor="ctr" wrap="square"/>
+          <a:lstStyle/>
+          <a:p>
+            <a:pPr algn="ctr">
+              <a:lnSpc>
+                <a:spcPct val="122000"/>
+              </a:lnSpc>
+            </a:pPr>
+            <a:r>
+              <a:rPr sz="1200" b="1">
+                <a:solidFill>
+                  <a:srgbClr val="000000"/>
+                </a:solidFill>
+                <a:latin typeface="Amazon Ember"/>
+                <a:ea typeface="メイリオ"/>
+                <a:cs typeface="メイリオ"/>
+              </a:rPr>
+              <a:t>5</a:t>
+            </a:r>
+          </a:p>
+        </p:txBody>
+      </p:sp>
+      <p:sp>
+        <p:nvSpPr>
+          <p:cNvPr id="20" name="Rounded Rectangle 19"/>
+          <p:cNvSpPr/>
+          <p:nvPr/>
+        </p:nvSpPr>
+        <p:spPr>
+          <a:xfrm>
+            <a:off x="9477375" y="1257300"/>
+            <a:ext cx="1333500" cy="914400"/>
+          </a:xfrm>
+          <a:prstGeom prst="roundRect">
+            <a:avLst>
+              <a:gd name="adj" fmla="val 10000"/>
+            </a:avLst>
+          </a:prstGeom>
+          <a:solidFill>
+            <a:srgbClr val="343840"/>
+          </a:solidFill>
+          <a:ln w="15875">
+            <a:solidFill>
+              <a:srgbClr val="464A50"/>
+            </a:solidFill>
+          </a:ln>
+          <a:effectLst/>
+        </p:spPr>
+        <p:style>
+          <a:lnRef idx="1">
+            <a:schemeClr val="accent1"/>
+          </a:lnRef>
+          <a:fillRef idx="3">
+            <a:schemeClr val="accent1"/>
+          </a:fillRef>
+          <a:effectRef idx="2">
+            <a:schemeClr val="accent1"/>
+          </a:effectRef>
+          <a:fontRef idx="minor">
+            <a:schemeClr val="lt1"/>
+          </a:fontRef>
+        </p:style>
+        <p:txBody>
+          <a:bodyPr rtlCol="0" anchor="ctr" wrap="square" lIns="19050" rIns="19050" tIns="19050" bIns="19050"/>
+          <a:lstStyle/>
+          <a:p>
+            <a:pPr algn="ctr">
+              <a:lnSpc>
+                <a:spcPct val="122000"/>
+              </a:lnSpc>
+            </a:pPr>
+            <a:r>
+              <a:rPr sz="1400" b="1">
+                <a:solidFill>
+                  <a:srgbClr val="F5F5F8"/>
+                </a:solidFill>
+                <a:latin typeface="Amazon Ember"/>
+                <a:ea typeface="メイリオ"/>
+                <a:cs typeface="メイリオ"/>
+              </a:rPr>
+              <a:t>stream</a:t>
+            </a:r>
+          </a:p>
+          <a:p>
+            <a:pPr algn="ctr">
+              <a:lnSpc>
+                <a:spcPct val="122000"/>
+              </a:lnSpc>
+            </a:pPr>
+            <a:r>
+              <a:rPr sz="1400" b="1">
+                <a:solidFill>
+                  <a:srgbClr val="F5F5F8"/>
+                </a:solidFill>
+                <a:latin typeface="Amazon Ember"/>
+                <a:ea typeface="メイリオ"/>
+                <a:cs typeface="メイリオ"/>
+              </a:rPr>
+              <a:t>tokens out</a:t>
+            </a:r>
+          </a:p>
+        </p:txBody>
+      </p:sp>
+      <p:sp>
+        <p:nvSpPr>
+          <p:cNvPr id="21" name="Oval 20"/>
+          <p:cNvSpPr/>
+          <p:nvPr/>
+        </p:nvSpPr>
+        <p:spPr>
+          <a:xfrm>
+            <a:off x="9363075" y="1143000"/>
+            <a:ext cx="247650" cy="247650"/>
+          </a:xfrm>
+          <a:prstGeom prst="ellipse">
+            <a:avLst/>
+          </a:prstGeom>
+          <a:solidFill>
+            <a:srgbClr val="FBD332"/>
+          </a:solidFill>
+          <a:ln>
+            <a:noFill/>
+          </a:ln>
+          <a:effectLst/>
+        </p:spPr>
+        <p:style>
+          <a:lnRef idx="1">
+            <a:schemeClr val="accent1"/>
+          </a:lnRef>
+          <a:fillRef idx="3">
+            <a:schemeClr val="accent1"/>
+          </a:fillRef>
+          <a:effectRef idx="2">
+            <a:schemeClr val="accent1"/>
+          </a:effectRef>
+          <a:fontRef idx="minor">
+            <a:schemeClr val="lt1"/>
+          </a:fontRef>
+        </p:style>
+        <p:txBody>
+          <a:bodyPr rtlCol="0" anchor="ctr" wrap="square"/>
+          <a:lstStyle/>
+          <a:p>
+            <a:pPr algn="ctr">
+              <a:lnSpc>
+                <a:spcPct val="122000"/>
+              </a:lnSpc>
+            </a:pPr>
+            <a:r>
+              <a:rPr sz="1200" b="1">
+                <a:solidFill>
+                  <a:srgbClr val="000000"/>
+                </a:solidFill>
+                <a:latin typeface="Amazon Ember"/>
+                <a:ea typeface="メイリオ"/>
+                <a:cs typeface="メイリオ"/>
+              </a:rPr>
+              <a:t>6</a:t>
+            </a:r>
+          </a:p>
+        </p:txBody>
+      </p:sp>
+      <p:cxnSp>
+        <p:nvCxnSpPr>
+          <p:cNvPr id="22" name="Connector 21"/>
+          <p:cNvCxnSpPr/>
+          <p:nvPr/>
+        </p:nvCxnSpPr>
+        <p:spPr>
+          <a:xfrm>
+            <a:off x="2809875" y="2171700"/>
+            <a:ext cx="0" cy="514350"/>
+          </a:xfrm>
+          <a:prstGeom prst="line">
+            <a:avLst/>
+          </a:prstGeom>
+          <a:ln w="25400">
+            <a:solidFill>
+              <a:srgbClr val="F5F5F8"/>
+            </a:solidFill>
+            <a:tailEnd type="triangle" w="med" len="med"/>
+          </a:ln>
+          <a:effectLst/>
+        </p:spPr>
+        <p:style>
+          <a:lnRef idx="2">
+            <a:schemeClr val="accent1"/>
+          </a:lnRef>
+          <a:fillRef idx="0">
+            <a:schemeClr val="accent1"/>
+          </a:fillRef>
+          <a:effectRef idx="1">
+            <a:schemeClr val="accent1"/>
+          </a:effectRef>
+          <a:fontRef idx="minor">
+            <a:schemeClr val="tx1"/>
+          </a:fontRef>
+        </p:style>
+      </p:cxnSp>
+      <p:cxnSp>
+        <p:nvCxnSpPr>
+          <p:cNvPr id="23" name="Connector 22"/>
+          <p:cNvCxnSpPr/>
+          <p:nvPr/>
+        </p:nvCxnSpPr>
+        <p:spPr>
+          <a:xfrm>
+            <a:off x="3714750" y="3143250"/>
+            <a:ext cx="333375" cy="0"/>
+          </a:xfrm>
+          <a:prstGeom prst="line">
+            <a:avLst/>
+          </a:prstGeom>
+          <a:ln w="25400">
+            <a:solidFill>
+              <a:srgbClr val="F5F5F8"/>
+            </a:solidFill>
+            <a:tailEnd type="triangle" w="med" len="med"/>
+          </a:ln>
+          <a:effectLst/>
+        </p:spPr>
+        <p:style>
+          <a:lnRef idx="2">
+            <a:schemeClr val="accent1"/>
+          </a:lnRef>
+          <a:fillRef idx="0">
+            <a:schemeClr val="accent1"/>
+          </a:fillRef>
+          <a:effectRef idx="1">
+            <a:schemeClr val="accent1"/>
+          </a:effectRef>
+          <a:fontRef idx="minor">
+            <a:schemeClr val="tx1"/>
+          </a:fontRef>
+        </p:style>
+      </p:cxnSp>
+      <p:cxnSp>
+        <p:nvCxnSpPr>
+          <p:cNvPr id="24" name="Connector 23"/>
+          <p:cNvCxnSpPr/>
+          <p:nvPr/>
+        </p:nvCxnSpPr>
+        <p:spPr>
+          <a:xfrm>
+            <a:off x="5953125" y="3143250"/>
+            <a:ext cx="714375" cy="971550"/>
+          </a:xfrm>
+          <a:prstGeom prst="line">
+            <a:avLst/>
+          </a:prstGeom>
+          <a:ln w="25400">
+            <a:solidFill>
+              <a:srgbClr val="F5F5F8"/>
+            </a:solidFill>
+            <a:tailEnd type="triangle" w="med" len="med"/>
+          </a:ln>
+          <a:effectLst/>
+        </p:spPr>
+        <p:style>
+          <a:lnRef idx="2">
+            <a:schemeClr val="accent1"/>
+          </a:lnRef>
+          <a:fillRef idx="0">
+            <a:schemeClr val="accent1"/>
+          </a:fillRef>
+          <a:effectRef idx="1">
+            <a:schemeClr val="accent1"/>
+          </a:effectRef>
+          <a:fontRef idx="minor">
+            <a:schemeClr val="tx1"/>
+          </a:fontRef>
+        </p:style>
+      </p:cxnSp>
+      <p:cxnSp>
+        <p:nvCxnSpPr>
+          <p:cNvPr id="25" name="Connector 24"/>
+          <p:cNvCxnSpPr/>
+          <p:nvPr/>
+        </p:nvCxnSpPr>
+        <p:spPr>
+          <a:xfrm flipV="1">
+            <a:off x="9144000" y="3600450"/>
+            <a:ext cx="762000" cy="514350"/>
+          </a:xfrm>
+          <a:prstGeom prst="line">
+            <a:avLst/>
+          </a:prstGeom>
+          <a:ln w="25400">
+            <a:solidFill>
+              <a:srgbClr val="F5F5F8"/>
+            </a:solidFill>
+            <a:tailEnd type="triangle" w="med" len="med"/>
+          </a:ln>
+          <a:effectLst/>
+        </p:spPr>
+        <p:style>
+          <a:lnRef idx="2">
+            <a:schemeClr val="accent1"/>
+          </a:lnRef>
+          <a:fillRef idx="0">
+            <a:schemeClr val="accent1"/>
+          </a:fillRef>
+          <a:effectRef idx="1">
+            <a:schemeClr val="accent1"/>
+          </a:effectRef>
+          <a:fontRef idx="minor">
+            <a:schemeClr val="tx1"/>
+          </a:fontRef>
+        </p:style>
+      </p:cxnSp>
+      <p:cxnSp>
+        <p:nvCxnSpPr>
+          <p:cNvPr id="26" name="Connector 25"/>
+          <p:cNvCxnSpPr/>
+          <p:nvPr/>
+        </p:nvCxnSpPr>
+        <p:spPr>
+          <a:xfrm flipV="1">
+            <a:off x="10144125" y="2171700"/>
+            <a:ext cx="0" cy="514350"/>
+          </a:xfrm>
+          <a:prstGeom prst="line">
+            <a:avLst/>
+          </a:prstGeom>
+          <a:ln w="25400">
+            <a:solidFill>
+              <a:srgbClr val="F5F5F8"/>
+            </a:solidFill>
+            <a:tailEnd type="triangle" w="med" len="med"/>
+          </a:ln>
+          <a:effectLst/>
+        </p:spPr>
+        <p:style>
+          <a:lnRef idx="2">
+            <a:schemeClr val="accent1"/>
+          </a:lnRef>
+          <a:fillRef idx="0">
+            <a:schemeClr val="accent1"/>
+          </a:fillRef>
+          <a:effectRef idx="1">
+            <a:schemeClr val="accent1"/>
+          </a:effectRef>
+          <a:fontRef idx="minor">
+            <a:schemeClr val="tx1"/>
+          </a:fontRef>
+        </p:style>
+      </p:cxnSp>
+      <p:sp>
+        <p:nvSpPr>
+          <p:cNvPr id="27" name="Rounded Rectangle 26"/>
+          <p:cNvSpPr/>
+          <p:nvPr/>
+        </p:nvSpPr>
+        <p:spPr>
+          <a:xfrm>
+            <a:off x="409575" y="5391150"/>
+            <a:ext cx="11372850" cy="438150"/>
+          </a:xfrm>
+          <a:prstGeom prst="roundRect">
+            <a:avLst>
+              <a:gd name="adj" fmla="val 30000"/>
+            </a:avLst>
+          </a:prstGeom>
+          <a:solidFill>
+            <a:srgbClr val="50420E"/>
+          </a:solidFill>
+          <a:ln w="15875">
+            <a:solidFill>
+              <a:srgbClr val="FBD332"/>
+            </a:solidFill>
+          </a:ln>
+          <a:effectLst/>
+        </p:spPr>
+        <p:style>
+          <a:lnRef idx="1">
+            <a:schemeClr val="accent1"/>
+          </a:lnRef>
+          <a:fillRef idx="3">
+            <a:schemeClr val="accent1"/>
+          </a:fillRef>
+          <a:effectRef idx="2">
+            <a:schemeClr val="accent1"/>
+          </a:effectRef>
+          <a:fontRef idx="minor">
+            <a:schemeClr val="lt1"/>
+          </a:fontRef>
+        </p:style>
+        <p:txBody>
+          <a:bodyPr rtlCol="0" anchor="ctr" wrap="square" lIns="19050" rIns="19050" tIns="19050" bIns="19050"/>
+          <a:lstStyle/>
+          <a:p>
+            <a:pPr algn="ctr">
+              <a:lnSpc>
+                <a:spcPct val="122000"/>
+              </a:lnSpc>
+            </a:pPr>
+            <a:r>
+              <a:rPr sz="1400" b="1">
+                <a:solidFill>
+                  <a:srgbClr val="F5F5F8"/>
+                </a:solidFill>
+                <a:latin typeface="Amazon Ember"/>
+                <a:ea typeface="メイリオ"/>
+                <a:cs typeface="メイリオ"/>
+              </a:rPr>
+              <a:t>What crosses into your model each step: token ids, positions, and per-layer metadata (block table, slot mapping)</a:t>
             </a:r>
           </a:p>
         </p:txBody>

</xml_diff>

<commit_message>
articles: NemotronH on vLLM Neuron plugin: where weights, KV and Mamba state live
</commit_message>
<xml_diff>
--- a/diagrams/articles/162e5225ba1c9b-figures.pptx
+++ b/diagrams/articles/162e5225ba1c9b-figures.pptx
@@ -23,6 +23,7 @@
     <p:sldId id="265" r:id="rId3"/>
     <p:sldId id="266" r:id="rId2"/>
     <p:sldId id="267" r:id="rId20"/>
+    <p:sldId id="268" r:id="rId21"/>
   </p:sldIdLst>
   <p:sldSz cx="12192000" cy="6858000"/>
   <p:notesSz cx="6858000" cy="9144000"/>
@@ -8029,6 +8030,3659 @@
                 <a:cs typeface="メイリオ"/>
               </a:rPr>
               <a:t>What crosses into your model each step: token ids, positions, and per-layer metadata (block table, slot mapping)</a:t>
+            </a:r>
+          </a:p>
+        </p:txBody>
+      </p:sp>
+    </p:spTree>
+  </p:cSld>
+  <p:clrMapOvr>
+    <a:masterClrMapping/>
+  </p:clrMapOvr>
+</p:sld>
+</file>
+
+<file path=ppt/slides/slide13.xml><?xml version="1.0" encoding="utf-8"?>
+<p:sld xmlns:a="http://schemas.openxmlformats.org/drawingml/2006/main" xmlns:p="http://schemas.openxmlformats.org/presentationml/2006/main" xmlns:r="http://schemas.openxmlformats.org/officeDocument/2006/relationships" showMasterSp="0">
+  <p:cSld>
+    <p:spTree>
+      <p:nvGrpSpPr>
+        <p:cNvPr id="1" name=""/>
+        <p:cNvGrpSpPr/>
+        <p:nvPr/>
+      </p:nvGrpSpPr>
+      <p:grpSpPr/>
+      <p:sp>
+        <p:nvSpPr>
+          <p:cNvPr id="2" name="TextBox 1"/>
+          <p:cNvSpPr txBox="1"/>
+          <p:nvPr/>
+        </p:nvSpPr>
+        <p:spPr>
+          <a:xfrm>
+            <a:off x="409575" y="247650"/>
+            <a:ext cx="11334750" cy="438150"/>
+          </a:xfrm>
+          <a:prstGeom prst="rect">
+            <a:avLst/>
+          </a:prstGeom>
+          <a:noFill/>
+        </p:spPr>
+        <p:txBody>
+          <a:bodyPr wrap="square" lIns="0" rIns="0" tIns="0" bIns="0" anchor="ctr">
+            <a:spAutoFit/>
+          </a:bodyPr>
+          <a:lstStyle/>
+          <a:p>
+            <a:pPr algn="l">
+              <a:lnSpc>
+                <a:spcPct val="122000"/>
+              </a:lnSpc>
+            </a:pPr>
+            <a:r>
+              <a:rPr sz="3000" b="1">
+                <a:solidFill>
+                  <a:srgbClr val="F5F5F8"/>
+                </a:solidFill>
+                <a:latin typeface="Amazon Ember"/>
+                <a:ea typeface="メイリオ"/>
+                <a:cs typeface="メイリオ"/>
+              </a:rPr>
+              <a:t>Where each kind of data lives on one TP rank</a:t>
+            </a:r>
+          </a:p>
+        </p:txBody>
+      </p:sp>
+      <p:sp>
+        <p:nvSpPr>
+          <p:cNvPr id="3" name="TextBox 2"/>
+          <p:cNvSpPr txBox="1"/>
+          <p:nvPr/>
+        </p:nvSpPr>
+        <p:spPr>
+          <a:xfrm>
+            <a:off x="409575" y="685800"/>
+            <a:ext cx="11334750" cy="247650"/>
+          </a:xfrm>
+          <a:prstGeom prst="rect">
+            <a:avLst/>
+          </a:prstGeom>
+          <a:noFill/>
+        </p:spPr>
+        <p:txBody>
+          <a:bodyPr wrap="square" lIns="0" rIns="0" tIns="0" bIns="0" anchor="ctr">
+            <a:spAutoFit/>
+          </a:bodyPr>
+          <a:lstStyle/>
+          <a:p>
+            <a:pPr algn="l">
+              <a:lnSpc>
+                <a:spcPct val="122000"/>
+              </a:lnSpc>
+            </a:pPr>
+            <a:r>
+              <a:rPr sz="1600" b="0">
+                <a:solidFill>
+                  <a:srgbClr val="96969E"/>
+                </a:solidFill>
+                <a:latin typeface="Amazon Ember"/>
+                <a:ea typeface="メイリオ"/>
+                <a:cs typeface="メイリオ"/>
+              </a:rPr>
+              <a:t>Grey: weights.  Blue: KV cache, owned by the plugin.  Green: Mamba state, owned by your model</a:t>
+            </a:r>
+          </a:p>
+        </p:txBody>
+      </p:sp>
+      <p:sp>
+        <p:nvSpPr>
+          <p:cNvPr id="4" name="Rectangle 3"/>
+          <p:cNvSpPr/>
+          <p:nvPr/>
+        </p:nvSpPr>
+        <p:spPr>
+          <a:xfrm>
+            <a:off x="409575" y="1028700"/>
+            <a:ext cx="11372850" cy="3143250"/>
+          </a:xfrm>
+          <a:prstGeom prst="rect">
+            <a:avLst/>
+          </a:prstGeom>
+          <a:solidFill>
+            <a:srgbClr val="161A1E"/>
+          </a:solidFill>
+          <a:ln w="9525">
+            <a:solidFill>
+              <a:srgbClr val="464A50"/>
+            </a:solidFill>
+          </a:ln>
+          <a:effectLst/>
+        </p:spPr>
+        <p:style>
+          <a:lnRef idx="1">
+            <a:schemeClr val="accent1"/>
+          </a:lnRef>
+          <a:fillRef idx="3">
+            <a:schemeClr val="accent1"/>
+          </a:fillRef>
+          <a:effectRef idx="2">
+            <a:schemeClr val="accent1"/>
+          </a:effectRef>
+          <a:fontRef idx="minor">
+            <a:schemeClr val="lt1"/>
+          </a:fontRef>
+        </p:style>
+        <p:txBody>
+          <a:bodyPr rtlCol="0" anchor="ctr"/>
+          <a:lstStyle/>
+          <a:p>
+            <a:pPr algn="ctr"/>
+          </a:p>
+        </p:txBody>
+      </p:sp>
+      <p:sp>
+        <p:nvSpPr>
+          <p:cNvPr id="5" name="TextBox 4"/>
+          <p:cNvSpPr txBox="1"/>
+          <p:nvPr/>
+        </p:nvSpPr>
+        <p:spPr>
+          <a:xfrm>
+            <a:off x="523875" y="1047750"/>
+            <a:ext cx="5715000" cy="247650"/>
+          </a:xfrm>
+          <a:prstGeom prst="rect">
+            <a:avLst/>
+          </a:prstGeom>
+          <a:noFill/>
+        </p:spPr>
+        <p:txBody>
+          <a:bodyPr wrap="square" lIns="0" rIns="0" tIns="0" bIns="0" anchor="ctr">
+            <a:spAutoFit/>
+          </a:bodyPr>
+          <a:lstStyle/>
+          <a:p>
+            <a:pPr algn="l">
+              <a:lnSpc>
+                <a:spcPct val="122000"/>
+              </a:lnSpc>
+            </a:pPr>
+            <a:r>
+              <a:rPr sz="1400" b="0">
+                <a:solidFill>
+                  <a:srgbClr val="96969E"/>
+                </a:solidFill>
+                <a:latin typeface="Amazon Ember"/>
+                <a:ea typeface="メイリオ"/>
+                <a:cs typeface="メイリオ"/>
+              </a:rPr>
+              <a:t>device memory (HBM) of one TP rank</a:t>
+            </a:r>
+          </a:p>
+        </p:txBody>
+      </p:sp>
+      <p:sp>
+        <p:nvSpPr>
+          <p:cNvPr id="6" name="Rounded Rectangle 5"/>
+          <p:cNvSpPr/>
+          <p:nvPr/>
+        </p:nvSpPr>
+        <p:spPr>
+          <a:xfrm>
+            <a:off x="600075" y="1390650"/>
+            <a:ext cx="2571750" cy="2571750"/>
+          </a:xfrm>
+          <a:prstGeom prst="roundRect">
+            <a:avLst>
+              <a:gd name="adj" fmla="val 10000"/>
+            </a:avLst>
+          </a:prstGeom>
+          <a:solidFill>
+            <a:srgbClr val="343840"/>
+          </a:solidFill>
+          <a:ln w="15875">
+            <a:solidFill>
+              <a:srgbClr val="464A50"/>
+            </a:solidFill>
+          </a:ln>
+          <a:effectLst/>
+        </p:spPr>
+        <p:style>
+          <a:lnRef idx="1">
+            <a:schemeClr val="accent1"/>
+          </a:lnRef>
+          <a:fillRef idx="3">
+            <a:schemeClr val="accent1"/>
+          </a:fillRef>
+          <a:effectRef idx="2">
+            <a:schemeClr val="accent1"/>
+          </a:effectRef>
+          <a:fontRef idx="minor">
+            <a:schemeClr val="lt1"/>
+          </a:fontRef>
+        </p:style>
+        <p:txBody>
+          <a:bodyPr rtlCol="0" anchor="ctr" wrap="square" lIns="19050" rIns="19050" tIns="19050" bIns="19050"/>
+          <a:lstStyle/>
+          <a:p>
+            <a:pPr algn="ctr">
+              <a:lnSpc>
+                <a:spcPct val="122000"/>
+              </a:lnSpc>
+            </a:pPr>
+            <a:r>
+              <a:rPr sz="1600" b="1">
+                <a:solidFill>
+                  <a:srgbClr val="F5F5F8"/>
+                </a:solidFill>
+                <a:latin typeface="Amazon Ember"/>
+                <a:ea typeface="メイリオ"/>
+                <a:cs typeface="メイリオ"/>
+              </a:rPr>
+              <a:t>weights</a:t>
+            </a:r>
+          </a:p>
+          <a:p>
+            <a:pPr algn="ctr">
+              <a:lnSpc>
+                <a:spcPct val="122000"/>
+              </a:lnSpc>
+            </a:pPr>
+            <a:r>
+              <a:rPr sz="1600" b="1">
+                <a:solidFill>
+                  <a:srgbClr val="F5F5F8"/>
+                </a:solidFill>
+                <a:latin typeface="Amazon Ember"/>
+                <a:ea typeface="メイリオ"/>
+                <a:cs typeface="メイリオ"/>
+              </a:rPr>
+              <a:t>about 15 GB</a:t>
+            </a:r>
+          </a:p>
+          <a:p>
+            <a:pPr algn="ctr">
+              <a:lnSpc>
+                <a:spcPct val="122000"/>
+              </a:lnSpc>
+            </a:pPr>
+            <a:r>
+              <a:rPr sz="1600" b="1">
+                <a:solidFill>
+                  <a:srgbClr val="F5F5F8"/>
+                </a:solidFill>
+                <a:latin typeface="Amazon Ember"/>
+                <a:ea typeface="メイリオ"/>
+                <a:cs typeface="メイリオ"/>
+              </a:rPr>
+              <a:t/>
+            </a:r>
+          </a:p>
+          <a:p>
+            <a:pPr algn="ctr">
+              <a:lnSpc>
+                <a:spcPct val="122000"/>
+              </a:lnSpc>
+            </a:pPr>
+            <a:r>
+              <a:rPr sz="1600" b="1">
+                <a:solidFill>
+                  <a:srgbClr val="F5F5F8"/>
+                </a:solidFill>
+                <a:latin typeface="Amazon Ember"/>
+                <a:ea typeface="メイリオ"/>
+                <a:cs typeface="メイリオ"/>
+              </a:rPr>
+              <a:t>loaded once</a:t>
+            </a:r>
+          </a:p>
+          <a:p>
+            <a:pPr algn="ctr">
+              <a:lnSpc>
+                <a:spcPct val="122000"/>
+              </a:lnSpc>
+            </a:pPr>
+            <a:r>
+              <a:rPr sz="1600" b="1">
+                <a:solidFill>
+                  <a:srgbClr val="F5F5F8"/>
+                </a:solidFill>
+                <a:latin typeface="Amazon Ember"/>
+                <a:ea typeface="メイリオ"/>
+                <a:cs typeface="メイリオ"/>
+              </a:rPr>
+              <a:t>by load_weights</a:t>
+            </a:r>
+          </a:p>
+        </p:txBody>
+      </p:sp>
+      <p:sp>
+        <p:nvSpPr>
+          <p:cNvPr id="7" name="TextBox 6"/>
+          <p:cNvSpPr txBox="1"/>
+          <p:nvPr/>
+        </p:nvSpPr>
+        <p:spPr>
+          <a:xfrm>
+            <a:off x="3362325" y="1333500"/>
+            <a:ext cx="4000500" cy="247650"/>
+          </a:xfrm>
+          <a:prstGeom prst="rect">
+            <a:avLst/>
+          </a:prstGeom>
+          <a:noFill/>
+        </p:spPr>
+        <p:txBody>
+          <a:bodyPr wrap="square" lIns="0" rIns="0" tIns="0" bIns="0" anchor="ctr">
+            <a:spAutoFit/>
+          </a:bodyPr>
+          <a:lstStyle/>
+          <a:p>
+            <a:pPr algn="l">
+              <a:lnSpc>
+                <a:spcPct val="122000"/>
+              </a:lnSpc>
+            </a:pPr>
+            <a:r>
+              <a:rPr sz="1500" b="0">
+                <a:solidFill>
+                  <a:srgbClr val="2896F0"/>
+                </a:solidFill>
+                <a:latin typeface="Amazon Ember"/>
+                <a:ea typeface="メイリオ"/>
+                <a:cs typeface="メイリオ"/>
+              </a:rPr>
+              <a:t>KV cache: 2,400 blocks x 32 tokens</a:t>
+            </a:r>
+          </a:p>
+        </p:txBody>
+      </p:sp>
+      <p:sp>
+        <p:nvSpPr>
+          <p:cNvPr id="8" name="Rectangle 7"/>
+          <p:cNvSpPr/>
+          <p:nvPr/>
+        </p:nvSpPr>
+        <p:spPr>
+          <a:xfrm>
+            <a:off x="3362325" y="1638300"/>
+            <a:ext cx="285750" cy="285750"/>
+          </a:xfrm>
+          <a:prstGeom prst="rect">
+            <a:avLst/>
+          </a:prstGeom>
+          <a:solidFill>
+            <a:srgbClr val="102C48"/>
+          </a:solidFill>
+          <a:ln>
+            <a:noFill/>
+          </a:ln>
+          <a:effectLst/>
+        </p:spPr>
+        <p:style>
+          <a:lnRef idx="1">
+            <a:schemeClr val="accent1"/>
+          </a:lnRef>
+          <a:fillRef idx="3">
+            <a:schemeClr val="accent1"/>
+          </a:fillRef>
+          <a:effectRef idx="2">
+            <a:schemeClr val="accent1"/>
+          </a:effectRef>
+          <a:fontRef idx="minor">
+            <a:schemeClr val="lt1"/>
+          </a:fontRef>
+        </p:style>
+        <p:txBody>
+          <a:bodyPr rtlCol="0" anchor="ctr"/>
+          <a:lstStyle/>
+          <a:p>
+            <a:pPr algn="ctr"/>
+          </a:p>
+        </p:txBody>
+      </p:sp>
+      <p:sp>
+        <p:nvSpPr>
+          <p:cNvPr id="9" name="Rectangle 8"/>
+          <p:cNvSpPr/>
+          <p:nvPr/>
+        </p:nvSpPr>
+        <p:spPr>
+          <a:xfrm>
+            <a:off x="3686175" y="1638300"/>
+            <a:ext cx="285750" cy="285750"/>
+          </a:xfrm>
+          <a:prstGeom prst="rect">
+            <a:avLst/>
+          </a:prstGeom>
+          <a:solidFill>
+            <a:srgbClr val="102C48"/>
+          </a:solidFill>
+          <a:ln>
+            <a:noFill/>
+          </a:ln>
+          <a:effectLst/>
+        </p:spPr>
+        <p:style>
+          <a:lnRef idx="1">
+            <a:schemeClr val="accent1"/>
+          </a:lnRef>
+          <a:fillRef idx="3">
+            <a:schemeClr val="accent1"/>
+          </a:fillRef>
+          <a:effectRef idx="2">
+            <a:schemeClr val="accent1"/>
+          </a:effectRef>
+          <a:fontRef idx="minor">
+            <a:schemeClr val="lt1"/>
+          </a:fontRef>
+        </p:style>
+        <p:txBody>
+          <a:bodyPr rtlCol="0" anchor="ctr"/>
+          <a:lstStyle/>
+          <a:p>
+            <a:pPr algn="ctr"/>
+          </a:p>
+        </p:txBody>
+      </p:sp>
+      <p:sp>
+        <p:nvSpPr>
+          <p:cNvPr id="10" name="Rectangle 9"/>
+          <p:cNvSpPr/>
+          <p:nvPr/>
+        </p:nvSpPr>
+        <p:spPr>
+          <a:xfrm>
+            <a:off x="4010025" y="1638300"/>
+            <a:ext cx="285750" cy="285750"/>
+          </a:xfrm>
+          <a:prstGeom prst="rect">
+            <a:avLst/>
+          </a:prstGeom>
+          <a:solidFill>
+            <a:srgbClr val="102C48"/>
+          </a:solidFill>
+          <a:ln>
+            <a:noFill/>
+          </a:ln>
+          <a:effectLst/>
+        </p:spPr>
+        <p:style>
+          <a:lnRef idx="1">
+            <a:schemeClr val="accent1"/>
+          </a:lnRef>
+          <a:fillRef idx="3">
+            <a:schemeClr val="accent1"/>
+          </a:fillRef>
+          <a:effectRef idx="2">
+            <a:schemeClr val="accent1"/>
+          </a:effectRef>
+          <a:fontRef idx="minor">
+            <a:schemeClr val="lt1"/>
+          </a:fontRef>
+        </p:style>
+        <p:txBody>
+          <a:bodyPr rtlCol="0" anchor="ctr"/>
+          <a:lstStyle/>
+          <a:p>
+            <a:pPr algn="ctr"/>
+          </a:p>
+        </p:txBody>
+      </p:sp>
+      <p:sp>
+        <p:nvSpPr>
+          <p:cNvPr id="11" name="Rectangle 10"/>
+          <p:cNvSpPr/>
+          <p:nvPr/>
+        </p:nvSpPr>
+        <p:spPr>
+          <a:xfrm>
+            <a:off x="4333875" y="1638300"/>
+            <a:ext cx="285750" cy="285750"/>
+          </a:xfrm>
+          <a:prstGeom prst="rect">
+            <a:avLst/>
+          </a:prstGeom>
+          <a:solidFill>
+            <a:srgbClr val="102C48"/>
+          </a:solidFill>
+          <a:ln>
+            <a:noFill/>
+          </a:ln>
+          <a:effectLst/>
+        </p:spPr>
+        <p:style>
+          <a:lnRef idx="1">
+            <a:schemeClr val="accent1"/>
+          </a:lnRef>
+          <a:fillRef idx="3">
+            <a:schemeClr val="accent1"/>
+          </a:fillRef>
+          <a:effectRef idx="2">
+            <a:schemeClr val="accent1"/>
+          </a:effectRef>
+          <a:fontRef idx="minor">
+            <a:schemeClr val="lt1"/>
+          </a:fontRef>
+        </p:style>
+        <p:txBody>
+          <a:bodyPr rtlCol="0" anchor="ctr"/>
+          <a:lstStyle/>
+          <a:p>
+            <a:pPr algn="ctr"/>
+          </a:p>
+        </p:txBody>
+      </p:sp>
+      <p:sp>
+        <p:nvSpPr>
+          <p:cNvPr id="12" name="Rectangle 11"/>
+          <p:cNvSpPr/>
+          <p:nvPr/>
+        </p:nvSpPr>
+        <p:spPr>
+          <a:xfrm>
+            <a:off x="4657725" y="1638300"/>
+            <a:ext cx="285750" cy="285750"/>
+          </a:xfrm>
+          <a:prstGeom prst="rect">
+            <a:avLst/>
+          </a:prstGeom>
+          <a:solidFill>
+            <a:srgbClr val="2896F0"/>
+          </a:solidFill>
+          <a:ln>
+            <a:noFill/>
+          </a:ln>
+          <a:effectLst/>
+        </p:spPr>
+        <p:style>
+          <a:lnRef idx="1">
+            <a:schemeClr val="accent1"/>
+          </a:lnRef>
+          <a:fillRef idx="3">
+            <a:schemeClr val="accent1"/>
+          </a:fillRef>
+          <a:effectRef idx="2">
+            <a:schemeClr val="accent1"/>
+          </a:effectRef>
+          <a:fontRef idx="minor">
+            <a:schemeClr val="lt1"/>
+          </a:fontRef>
+        </p:style>
+        <p:txBody>
+          <a:bodyPr rtlCol="0" anchor="ctr"/>
+          <a:lstStyle/>
+          <a:p>
+            <a:pPr algn="ctr"/>
+          </a:p>
+        </p:txBody>
+      </p:sp>
+      <p:sp>
+        <p:nvSpPr>
+          <p:cNvPr id="13" name="Rectangle 12"/>
+          <p:cNvSpPr/>
+          <p:nvPr/>
+        </p:nvSpPr>
+        <p:spPr>
+          <a:xfrm>
+            <a:off x="4981575" y="1638300"/>
+            <a:ext cx="285750" cy="285750"/>
+          </a:xfrm>
+          <a:prstGeom prst="rect">
+            <a:avLst/>
+          </a:prstGeom>
+          <a:solidFill>
+            <a:srgbClr val="2896F0"/>
+          </a:solidFill>
+          <a:ln>
+            <a:noFill/>
+          </a:ln>
+          <a:effectLst/>
+        </p:spPr>
+        <p:style>
+          <a:lnRef idx="1">
+            <a:schemeClr val="accent1"/>
+          </a:lnRef>
+          <a:fillRef idx="3">
+            <a:schemeClr val="accent1"/>
+          </a:fillRef>
+          <a:effectRef idx="2">
+            <a:schemeClr val="accent1"/>
+          </a:effectRef>
+          <a:fontRef idx="minor">
+            <a:schemeClr val="lt1"/>
+          </a:fontRef>
+        </p:style>
+        <p:txBody>
+          <a:bodyPr rtlCol="0" anchor="ctr"/>
+          <a:lstStyle/>
+          <a:p>
+            <a:pPr algn="ctr"/>
+          </a:p>
+        </p:txBody>
+      </p:sp>
+      <p:sp>
+        <p:nvSpPr>
+          <p:cNvPr id="14" name="Rectangle 13"/>
+          <p:cNvSpPr/>
+          <p:nvPr/>
+        </p:nvSpPr>
+        <p:spPr>
+          <a:xfrm>
+            <a:off x="5305425" y="1638300"/>
+            <a:ext cx="285750" cy="285750"/>
+          </a:xfrm>
+          <a:prstGeom prst="rect">
+            <a:avLst/>
+          </a:prstGeom>
+          <a:solidFill>
+            <a:srgbClr val="2896F0"/>
+          </a:solidFill>
+          <a:ln>
+            <a:noFill/>
+          </a:ln>
+          <a:effectLst/>
+        </p:spPr>
+        <p:style>
+          <a:lnRef idx="1">
+            <a:schemeClr val="accent1"/>
+          </a:lnRef>
+          <a:fillRef idx="3">
+            <a:schemeClr val="accent1"/>
+          </a:fillRef>
+          <a:effectRef idx="2">
+            <a:schemeClr val="accent1"/>
+          </a:effectRef>
+          <a:fontRef idx="minor">
+            <a:schemeClr val="lt1"/>
+          </a:fontRef>
+        </p:style>
+        <p:txBody>
+          <a:bodyPr rtlCol="0" anchor="ctr"/>
+          <a:lstStyle/>
+          <a:p>
+            <a:pPr algn="ctr"/>
+          </a:p>
+        </p:txBody>
+      </p:sp>
+      <p:sp>
+        <p:nvSpPr>
+          <p:cNvPr id="15" name="Rectangle 14"/>
+          <p:cNvSpPr/>
+          <p:nvPr/>
+        </p:nvSpPr>
+        <p:spPr>
+          <a:xfrm>
+            <a:off x="5629275" y="1638300"/>
+            <a:ext cx="285750" cy="285750"/>
+          </a:xfrm>
+          <a:prstGeom prst="rect">
+            <a:avLst/>
+          </a:prstGeom>
+          <a:solidFill>
+            <a:srgbClr val="102C48"/>
+          </a:solidFill>
+          <a:ln>
+            <a:noFill/>
+          </a:ln>
+          <a:effectLst/>
+        </p:spPr>
+        <p:style>
+          <a:lnRef idx="1">
+            <a:schemeClr val="accent1"/>
+          </a:lnRef>
+          <a:fillRef idx="3">
+            <a:schemeClr val="accent1"/>
+          </a:fillRef>
+          <a:effectRef idx="2">
+            <a:schemeClr val="accent1"/>
+          </a:effectRef>
+          <a:fontRef idx="minor">
+            <a:schemeClr val="lt1"/>
+          </a:fontRef>
+        </p:style>
+        <p:txBody>
+          <a:bodyPr rtlCol="0" anchor="ctr"/>
+          <a:lstStyle/>
+          <a:p>
+            <a:pPr algn="ctr"/>
+          </a:p>
+        </p:txBody>
+      </p:sp>
+      <p:sp>
+        <p:nvSpPr>
+          <p:cNvPr id="16" name="Rectangle 15"/>
+          <p:cNvSpPr/>
+          <p:nvPr/>
+        </p:nvSpPr>
+        <p:spPr>
+          <a:xfrm>
+            <a:off x="5953125" y="1638300"/>
+            <a:ext cx="285750" cy="285750"/>
+          </a:xfrm>
+          <a:prstGeom prst="rect">
+            <a:avLst/>
+          </a:prstGeom>
+          <a:solidFill>
+            <a:srgbClr val="102C48"/>
+          </a:solidFill>
+          <a:ln>
+            <a:noFill/>
+          </a:ln>
+          <a:effectLst/>
+        </p:spPr>
+        <p:style>
+          <a:lnRef idx="1">
+            <a:schemeClr val="accent1"/>
+          </a:lnRef>
+          <a:fillRef idx="3">
+            <a:schemeClr val="accent1"/>
+          </a:fillRef>
+          <a:effectRef idx="2">
+            <a:schemeClr val="accent1"/>
+          </a:effectRef>
+          <a:fontRef idx="minor">
+            <a:schemeClr val="lt1"/>
+          </a:fontRef>
+        </p:style>
+        <p:txBody>
+          <a:bodyPr rtlCol="0" anchor="ctr"/>
+          <a:lstStyle/>
+          <a:p>
+            <a:pPr algn="ctr"/>
+          </a:p>
+        </p:txBody>
+      </p:sp>
+      <p:sp>
+        <p:nvSpPr>
+          <p:cNvPr id="17" name="Rectangle 16"/>
+          <p:cNvSpPr/>
+          <p:nvPr/>
+        </p:nvSpPr>
+        <p:spPr>
+          <a:xfrm>
+            <a:off x="6276975" y="1638300"/>
+            <a:ext cx="285750" cy="285750"/>
+          </a:xfrm>
+          <a:prstGeom prst="rect">
+            <a:avLst/>
+          </a:prstGeom>
+          <a:solidFill>
+            <a:srgbClr val="102C48"/>
+          </a:solidFill>
+          <a:ln>
+            <a:noFill/>
+          </a:ln>
+          <a:effectLst/>
+        </p:spPr>
+        <p:style>
+          <a:lnRef idx="1">
+            <a:schemeClr val="accent1"/>
+          </a:lnRef>
+          <a:fillRef idx="3">
+            <a:schemeClr val="accent1"/>
+          </a:fillRef>
+          <a:effectRef idx="2">
+            <a:schemeClr val="accent1"/>
+          </a:effectRef>
+          <a:fontRef idx="minor">
+            <a:schemeClr val="lt1"/>
+          </a:fontRef>
+        </p:style>
+        <p:txBody>
+          <a:bodyPr rtlCol="0" anchor="ctr"/>
+          <a:lstStyle/>
+          <a:p>
+            <a:pPr algn="ctr"/>
+          </a:p>
+        </p:txBody>
+      </p:sp>
+      <p:sp>
+        <p:nvSpPr>
+          <p:cNvPr id="18" name="Rectangle 17"/>
+          <p:cNvSpPr/>
+          <p:nvPr/>
+        </p:nvSpPr>
+        <p:spPr>
+          <a:xfrm>
+            <a:off x="6600825" y="1638300"/>
+            <a:ext cx="285750" cy="285750"/>
+          </a:xfrm>
+          <a:prstGeom prst="rect">
+            <a:avLst/>
+          </a:prstGeom>
+          <a:solidFill>
+            <a:srgbClr val="102C48"/>
+          </a:solidFill>
+          <a:ln>
+            <a:noFill/>
+          </a:ln>
+          <a:effectLst/>
+        </p:spPr>
+        <p:style>
+          <a:lnRef idx="1">
+            <a:schemeClr val="accent1"/>
+          </a:lnRef>
+          <a:fillRef idx="3">
+            <a:schemeClr val="accent1"/>
+          </a:fillRef>
+          <a:effectRef idx="2">
+            <a:schemeClr val="accent1"/>
+          </a:effectRef>
+          <a:fontRef idx="minor">
+            <a:schemeClr val="lt1"/>
+          </a:fontRef>
+        </p:style>
+        <p:txBody>
+          <a:bodyPr rtlCol="0" anchor="ctr"/>
+          <a:lstStyle/>
+          <a:p>
+            <a:pPr algn="ctr"/>
+          </a:p>
+        </p:txBody>
+      </p:sp>
+      <p:sp>
+        <p:nvSpPr>
+          <p:cNvPr id="19" name="Rectangle 18"/>
+          <p:cNvSpPr/>
+          <p:nvPr/>
+        </p:nvSpPr>
+        <p:spPr>
+          <a:xfrm>
+            <a:off x="6924675" y="1638300"/>
+            <a:ext cx="285750" cy="285750"/>
+          </a:xfrm>
+          <a:prstGeom prst="rect">
+            <a:avLst/>
+          </a:prstGeom>
+          <a:solidFill>
+            <a:srgbClr val="102C48"/>
+          </a:solidFill>
+          <a:ln>
+            <a:noFill/>
+          </a:ln>
+          <a:effectLst/>
+        </p:spPr>
+        <p:style>
+          <a:lnRef idx="1">
+            <a:schemeClr val="accent1"/>
+          </a:lnRef>
+          <a:fillRef idx="3">
+            <a:schemeClr val="accent1"/>
+          </a:fillRef>
+          <a:effectRef idx="2">
+            <a:schemeClr val="accent1"/>
+          </a:effectRef>
+          <a:fontRef idx="minor">
+            <a:schemeClr val="lt1"/>
+          </a:fontRef>
+        </p:style>
+        <p:txBody>
+          <a:bodyPr rtlCol="0" anchor="ctr"/>
+          <a:lstStyle/>
+          <a:p>
+            <a:pPr algn="ctr"/>
+          </a:p>
+        </p:txBody>
+      </p:sp>
+      <p:sp>
+        <p:nvSpPr>
+          <p:cNvPr id="20" name="Rectangle 19"/>
+          <p:cNvSpPr/>
+          <p:nvPr/>
+        </p:nvSpPr>
+        <p:spPr>
+          <a:xfrm>
+            <a:off x="3362325" y="1962150"/>
+            <a:ext cx="285750" cy="285750"/>
+          </a:xfrm>
+          <a:prstGeom prst="rect">
+            <a:avLst/>
+          </a:prstGeom>
+          <a:solidFill>
+            <a:srgbClr val="102C48"/>
+          </a:solidFill>
+          <a:ln>
+            <a:noFill/>
+          </a:ln>
+          <a:effectLst/>
+        </p:spPr>
+        <p:style>
+          <a:lnRef idx="1">
+            <a:schemeClr val="accent1"/>
+          </a:lnRef>
+          <a:fillRef idx="3">
+            <a:schemeClr val="accent1"/>
+          </a:fillRef>
+          <a:effectRef idx="2">
+            <a:schemeClr val="accent1"/>
+          </a:effectRef>
+          <a:fontRef idx="minor">
+            <a:schemeClr val="lt1"/>
+          </a:fontRef>
+        </p:style>
+        <p:txBody>
+          <a:bodyPr rtlCol="0" anchor="ctr"/>
+          <a:lstStyle/>
+          <a:p>
+            <a:pPr algn="ctr"/>
+          </a:p>
+        </p:txBody>
+      </p:sp>
+      <p:sp>
+        <p:nvSpPr>
+          <p:cNvPr id="21" name="Rectangle 20"/>
+          <p:cNvSpPr/>
+          <p:nvPr/>
+        </p:nvSpPr>
+        <p:spPr>
+          <a:xfrm>
+            <a:off x="3686175" y="1962150"/>
+            <a:ext cx="285750" cy="285750"/>
+          </a:xfrm>
+          <a:prstGeom prst="rect">
+            <a:avLst/>
+          </a:prstGeom>
+          <a:solidFill>
+            <a:srgbClr val="102C48"/>
+          </a:solidFill>
+          <a:ln>
+            <a:noFill/>
+          </a:ln>
+          <a:effectLst/>
+        </p:spPr>
+        <p:style>
+          <a:lnRef idx="1">
+            <a:schemeClr val="accent1"/>
+          </a:lnRef>
+          <a:fillRef idx="3">
+            <a:schemeClr val="accent1"/>
+          </a:fillRef>
+          <a:effectRef idx="2">
+            <a:schemeClr val="accent1"/>
+          </a:effectRef>
+          <a:fontRef idx="minor">
+            <a:schemeClr val="lt1"/>
+          </a:fontRef>
+        </p:style>
+        <p:txBody>
+          <a:bodyPr rtlCol="0" anchor="ctr"/>
+          <a:lstStyle/>
+          <a:p>
+            <a:pPr algn="ctr"/>
+          </a:p>
+        </p:txBody>
+      </p:sp>
+      <p:sp>
+        <p:nvSpPr>
+          <p:cNvPr id="22" name="Rectangle 21"/>
+          <p:cNvSpPr/>
+          <p:nvPr/>
+        </p:nvSpPr>
+        <p:spPr>
+          <a:xfrm>
+            <a:off x="4010025" y="1962150"/>
+            <a:ext cx="285750" cy="285750"/>
+          </a:xfrm>
+          <a:prstGeom prst="rect">
+            <a:avLst/>
+          </a:prstGeom>
+          <a:solidFill>
+            <a:srgbClr val="102C48"/>
+          </a:solidFill>
+          <a:ln>
+            <a:noFill/>
+          </a:ln>
+          <a:effectLst/>
+        </p:spPr>
+        <p:style>
+          <a:lnRef idx="1">
+            <a:schemeClr val="accent1"/>
+          </a:lnRef>
+          <a:fillRef idx="3">
+            <a:schemeClr val="accent1"/>
+          </a:fillRef>
+          <a:effectRef idx="2">
+            <a:schemeClr val="accent1"/>
+          </a:effectRef>
+          <a:fontRef idx="minor">
+            <a:schemeClr val="lt1"/>
+          </a:fontRef>
+        </p:style>
+        <p:txBody>
+          <a:bodyPr rtlCol="0" anchor="ctr"/>
+          <a:lstStyle/>
+          <a:p>
+            <a:pPr algn="ctr"/>
+          </a:p>
+        </p:txBody>
+      </p:sp>
+      <p:sp>
+        <p:nvSpPr>
+          <p:cNvPr id="23" name="Rectangle 22"/>
+          <p:cNvSpPr/>
+          <p:nvPr/>
+        </p:nvSpPr>
+        <p:spPr>
+          <a:xfrm>
+            <a:off x="4333875" y="1962150"/>
+            <a:ext cx="285750" cy="285750"/>
+          </a:xfrm>
+          <a:prstGeom prst="rect">
+            <a:avLst/>
+          </a:prstGeom>
+          <a:solidFill>
+            <a:srgbClr val="102C48"/>
+          </a:solidFill>
+          <a:ln>
+            <a:noFill/>
+          </a:ln>
+          <a:effectLst/>
+        </p:spPr>
+        <p:style>
+          <a:lnRef idx="1">
+            <a:schemeClr val="accent1"/>
+          </a:lnRef>
+          <a:fillRef idx="3">
+            <a:schemeClr val="accent1"/>
+          </a:fillRef>
+          <a:effectRef idx="2">
+            <a:schemeClr val="accent1"/>
+          </a:effectRef>
+          <a:fontRef idx="minor">
+            <a:schemeClr val="lt1"/>
+          </a:fontRef>
+        </p:style>
+        <p:txBody>
+          <a:bodyPr rtlCol="0" anchor="ctr"/>
+          <a:lstStyle/>
+          <a:p>
+            <a:pPr algn="ctr"/>
+          </a:p>
+        </p:txBody>
+      </p:sp>
+      <p:sp>
+        <p:nvSpPr>
+          <p:cNvPr id="24" name="Rectangle 23"/>
+          <p:cNvSpPr/>
+          <p:nvPr/>
+        </p:nvSpPr>
+        <p:spPr>
+          <a:xfrm>
+            <a:off x="4657725" y="1962150"/>
+            <a:ext cx="285750" cy="285750"/>
+          </a:xfrm>
+          <a:prstGeom prst="rect">
+            <a:avLst/>
+          </a:prstGeom>
+          <a:solidFill>
+            <a:srgbClr val="102C48"/>
+          </a:solidFill>
+          <a:ln>
+            <a:noFill/>
+          </a:ln>
+          <a:effectLst/>
+        </p:spPr>
+        <p:style>
+          <a:lnRef idx="1">
+            <a:schemeClr val="accent1"/>
+          </a:lnRef>
+          <a:fillRef idx="3">
+            <a:schemeClr val="accent1"/>
+          </a:fillRef>
+          <a:effectRef idx="2">
+            <a:schemeClr val="accent1"/>
+          </a:effectRef>
+          <a:fontRef idx="minor">
+            <a:schemeClr val="lt1"/>
+          </a:fontRef>
+        </p:style>
+        <p:txBody>
+          <a:bodyPr rtlCol="0" anchor="ctr"/>
+          <a:lstStyle/>
+          <a:p>
+            <a:pPr algn="ctr"/>
+          </a:p>
+        </p:txBody>
+      </p:sp>
+      <p:sp>
+        <p:nvSpPr>
+          <p:cNvPr id="25" name="Rectangle 24"/>
+          <p:cNvSpPr/>
+          <p:nvPr/>
+        </p:nvSpPr>
+        <p:spPr>
+          <a:xfrm>
+            <a:off x="4981575" y="1962150"/>
+            <a:ext cx="285750" cy="285750"/>
+          </a:xfrm>
+          <a:prstGeom prst="rect">
+            <a:avLst/>
+          </a:prstGeom>
+          <a:solidFill>
+            <a:srgbClr val="102C48"/>
+          </a:solidFill>
+          <a:ln>
+            <a:noFill/>
+          </a:ln>
+          <a:effectLst/>
+        </p:spPr>
+        <p:style>
+          <a:lnRef idx="1">
+            <a:schemeClr val="accent1"/>
+          </a:lnRef>
+          <a:fillRef idx="3">
+            <a:schemeClr val="accent1"/>
+          </a:fillRef>
+          <a:effectRef idx="2">
+            <a:schemeClr val="accent1"/>
+          </a:effectRef>
+          <a:fontRef idx="minor">
+            <a:schemeClr val="lt1"/>
+          </a:fontRef>
+        </p:style>
+        <p:txBody>
+          <a:bodyPr rtlCol="0" anchor="ctr"/>
+          <a:lstStyle/>
+          <a:p>
+            <a:pPr algn="ctr"/>
+          </a:p>
+        </p:txBody>
+      </p:sp>
+      <p:sp>
+        <p:nvSpPr>
+          <p:cNvPr id="26" name="Rectangle 25"/>
+          <p:cNvSpPr/>
+          <p:nvPr/>
+        </p:nvSpPr>
+        <p:spPr>
+          <a:xfrm>
+            <a:off x="5305425" y="1962150"/>
+            <a:ext cx="285750" cy="285750"/>
+          </a:xfrm>
+          <a:prstGeom prst="rect">
+            <a:avLst/>
+          </a:prstGeom>
+          <a:solidFill>
+            <a:srgbClr val="102C48"/>
+          </a:solidFill>
+          <a:ln>
+            <a:noFill/>
+          </a:ln>
+          <a:effectLst/>
+        </p:spPr>
+        <p:style>
+          <a:lnRef idx="1">
+            <a:schemeClr val="accent1"/>
+          </a:lnRef>
+          <a:fillRef idx="3">
+            <a:schemeClr val="accent1"/>
+          </a:fillRef>
+          <a:effectRef idx="2">
+            <a:schemeClr val="accent1"/>
+          </a:effectRef>
+          <a:fontRef idx="minor">
+            <a:schemeClr val="lt1"/>
+          </a:fontRef>
+        </p:style>
+        <p:txBody>
+          <a:bodyPr rtlCol="0" anchor="ctr"/>
+          <a:lstStyle/>
+          <a:p>
+            <a:pPr algn="ctr"/>
+          </a:p>
+        </p:txBody>
+      </p:sp>
+      <p:sp>
+        <p:nvSpPr>
+          <p:cNvPr id="27" name="Rectangle 26"/>
+          <p:cNvSpPr/>
+          <p:nvPr/>
+        </p:nvSpPr>
+        <p:spPr>
+          <a:xfrm>
+            <a:off x="5629275" y="1962150"/>
+            <a:ext cx="285750" cy="285750"/>
+          </a:xfrm>
+          <a:prstGeom prst="rect">
+            <a:avLst/>
+          </a:prstGeom>
+          <a:solidFill>
+            <a:srgbClr val="102C48"/>
+          </a:solidFill>
+          <a:ln>
+            <a:noFill/>
+          </a:ln>
+          <a:effectLst/>
+        </p:spPr>
+        <p:style>
+          <a:lnRef idx="1">
+            <a:schemeClr val="accent1"/>
+          </a:lnRef>
+          <a:fillRef idx="3">
+            <a:schemeClr val="accent1"/>
+          </a:fillRef>
+          <a:effectRef idx="2">
+            <a:schemeClr val="accent1"/>
+          </a:effectRef>
+          <a:fontRef idx="minor">
+            <a:schemeClr val="lt1"/>
+          </a:fontRef>
+        </p:style>
+        <p:txBody>
+          <a:bodyPr rtlCol="0" anchor="ctr"/>
+          <a:lstStyle/>
+          <a:p>
+            <a:pPr algn="ctr"/>
+          </a:p>
+        </p:txBody>
+      </p:sp>
+      <p:sp>
+        <p:nvSpPr>
+          <p:cNvPr id="28" name="Rectangle 27"/>
+          <p:cNvSpPr/>
+          <p:nvPr/>
+        </p:nvSpPr>
+        <p:spPr>
+          <a:xfrm>
+            <a:off x="5953125" y="1962150"/>
+            <a:ext cx="285750" cy="285750"/>
+          </a:xfrm>
+          <a:prstGeom prst="rect">
+            <a:avLst/>
+          </a:prstGeom>
+          <a:solidFill>
+            <a:srgbClr val="102C48"/>
+          </a:solidFill>
+          <a:ln>
+            <a:noFill/>
+          </a:ln>
+          <a:effectLst/>
+        </p:spPr>
+        <p:style>
+          <a:lnRef idx="1">
+            <a:schemeClr val="accent1"/>
+          </a:lnRef>
+          <a:fillRef idx="3">
+            <a:schemeClr val="accent1"/>
+          </a:fillRef>
+          <a:effectRef idx="2">
+            <a:schemeClr val="accent1"/>
+          </a:effectRef>
+          <a:fontRef idx="minor">
+            <a:schemeClr val="lt1"/>
+          </a:fontRef>
+        </p:style>
+        <p:txBody>
+          <a:bodyPr rtlCol="0" anchor="ctr"/>
+          <a:lstStyle/>
+          <a:p>
+            <a:pPr algn="ctr"/>
+          </a:p>
+        </p:txBody>
+      </p:sp>
+      <p:sp>
+        <p:nvSpPr>
+          <p:cNvPr id="29" name="Rectangle 28"/>
+          <p:cNvSpPr/>
+          <p:nvPr/>
+        </p:nvSpPr>
+        <p:spPr>
+          <a:xfrm>
+            <a:off x="6276975" y="1962150"/>
+            <a:ext cx="285750" cy="285750"/>
+          </a:xfrm>
+          <a:prstGeom prst="rect">
+            <a:avLst/>
+          </a:prstGeom>
+          <a:solidFill>
+            <a:srgbClr val="102C48"/>
+          </a:solidFill>
+          <a:ln>
+            <a:noFill/>
+          </a:ln>
+          <a:effectLst/>
+        </p:spPr>
+        <p:style>
+          <a:lnRef idx="1">
+            <a:schemeClr val="accent1"/>
+          </a:lnRef>
+          <a:fillRef idx="3">
+            <a:schemeClr val="accent1"/>
+          </a:fillRef>
+          <a:effectRef idx="2">
+            <a:schemeClr val="accent1"/>
+          </a:effectRef>
+          <a:fontRef idx="minor">
+            <a:schemeClr val="lt1"/>
+          </a:fontRef>
+        </p:style>
+        <p:txBody>
+          <a:bodyPr rtlCol="0" anchor="ctr"/>
+          <a:lstStyle/>
+          <a:p>
+            <a:pPr algn="ctr"/>
+          </a:p>
+        </p:txBody>
+      </p:sp>
+      <p:sp>
+        <p:nvSpPr>
+          <p:cNvPr id="30" name="Rectangle 29"/>
+          <p:cNvSpPr/>
+          <p:nvPr/>
+        </p:nvSpPr>
+        <p:spPr>
+          <a:xfrm>
+            <a:off x="6600825" y="1962150"/>
+            <a:ext cx="285750" cy="285750"/>
+          </a:xfrm>
+          <a:prstGeom prst="rect">
+            <a:avLst/>
+          </a:prstGeom>
+          <a:solidFill>
+            <a:srgbClr val="102C48"/>
+          </a:solidFill>
+          <a:ln>
+            <a:noFill/>
+          </a:ln>
+          <a:effectLst/>
+        </p:spPr>
+        <p:style>
+          <a:lnRef idx="1">
+            <a:schemeClr val="accent1"/>
+          </a:lnRef>
+          <a:fillRef idx="3">
+            <a:schemeClr val="accent1"/>
+          </a:fillRef>
+          <a:effectRef idx="2">
+            <a:schemeClr val="accent1"/>
+          </a:effectRef>
+          <a:fontRef idx="minor">
+            <a:schemeClr val="lt1"/>
+          </a:fontRef>
+        </p:style>
+        <p:txBody>
+          <a:bodyPr rtlCol="0" anchor="ctr"/>
+          <a:lstStyle/>
+          <a:p>
+            <a:pPr algn="ctr"/>
+          </a:p>
+        </p:txBody>
+      </p:sp>
+      <p:sp>
+        <p:nvSpPr>
+          <p:cNvPr id="31" name="Rectangle 30"/>
+          <p:cNvSpPr/>
+          <p:nvPr/>
+        </p:nvSpPr>
+        <p:spPr>
+          <a:xfrm>
+            <a:off x="6924675" y="1962150"/>
+            <a:ext cx="285750" cy="285750"/>
+          </a:xfrm>
+          <a:prstGeom prst="rect">
+            <a:avLst/>
+          </a:prstGeom>
+          <a:solidFill>
+            <a:srgbClr val="102C48"/>
+          </a:solidFill>
+          <a:ln>
+            <a:noFill/>
+          </a:ln>
+          <a:effectLst/>
+        </p:spPr>
+        <p:style>
+          <a:lnRef idx="1">
+            <a:schemeClr val="accent1"/>
+          </a:lnRef>
+          <a:fillRef idx="3">
+            <a:schemeClr val="accent1"/>
+          </a:fillRef>
+          <a:effectRef idx="2">
+            <a:schemeClr val="accent1"/>
+          </a:effectRef>
+          <a:fontRef idx="minor">
+            <a:schemeClr val="lt1"/>
+          </a:fontRef>
+        </p:style>
+        <p:txBody>
+          <a:bodyPr rtlCol="0" anchor="ctr"/>
+          <a:lstStyle/>
+          <a:p>
+            <a:pPr algn="ctr"/>
+          </a:p>
+        </p:txBody>
+      </p:sp>
+      <p:sp>
+        <p:nvSpPr>
+          <p:cNvPr id="32" name="Rectangle 31"/>
+          <p:cNvSpPr/>
+          <p:nvPr/>
+        </p:nvSpPr>
+        <p:spPr>
+          <a:xfrm>
+            <a:off x="3362325" y="2286000"/>
+            <a:ext cx="285750" cy="285750"/>
+          </a:xfrm>
+          <a:prstGeom prst="rect">
+            <a:avLst/>
+          </a:prstGeom>
+          <a:solidFill>
+            <a:srgbClr val="102C48"/>
+          </a:solidFill>
+          <a:ln>
+            <a:noFill/>
+          </a:ln>
+          <a:effectLst/>
+        </p:spPr>
+        <p:style>
+          <a:lnRef idx="1">
+            <a:schemeClr val="accent1"/>
+          </a:lnRef>
+          <a:fillRef idx="3">
+            <a:schemeClr val="accent1"/>
+          </a:fillRef>
+          <a:effectRef idx="2">
+            <a:schemeClr val="accent1"/>
+          </a:effectRef>
+          <a:fontRef idx="minor">
+            <a:schemeClr val="lt1"/>
+          </a:fontRef>
+        </p:style>
+        <p:txBody>
+          <a:bodyPr rtlCol="0" anchor="ctr"/>
+          <a:lstStyle/>
+          <a:p>
+            <a:pPr algn="ctr"/>
+          </a:p>
+        </p:txBody>
+      </p:sp>
+      <p:sp>
+        <p:nvSpPr>
+          <p:cNvPr id="33" name="Rectangle 32"/>
+          <p:cNvSpPr/>
+          <p:nvPr/>
+        </p:nvSpPr>
+        <p:spPr>
+          <a:xfrm>
+            <a:off x="3686175" y="2286000"/>
+            <a:ext cx="285750" cy="285750"/>
+          </a:xfrm>
+          <a:prstGeom prst="rect">
+            <a:avLst/>
+          </a:prstGeom>
+          <a:solidFill>
+            <a:srgbClr val="102C48"/>
+          </a:solidFill>
+          <a:ln>
+            <a:noFill/>
+          </a:ln>
+          <a:effectLst/>
+        </p:spPr>
+        <p:style>
+          <a:lnRef idx="1">
+            <a:schemeClr val="accent1"/>
+          </a:lnRef>
+          <a:fillRef idx="3">
+            <a:schemeClr val="accent1"/>
+          </a:fillRef>
+          <a:effectRef idx="2">
+            <a:schemeClr val="accent1"/>
+          </a:effectRef>
+          <a:fontRef idx="minor">
+            <a:schemeClr val="lt1"/>
+          </a:fontRef>
+        </p:style>
+        <p:txBody>
+          <a:bodyPr rtlCol="0" anchor="ctr"/>
+          <a:lstStyle/>
+          <a:p>
+            <a:pPr algn="ctr"/>
+          </a:p>
+        </p:txBody>
+      </p:sp>
+      <p:sp>
+        <p:nvSpPr>
+          <p:cNvPr id="34" name="Rectangle 33"/>
+          <p:cNvSpPr/>
+          <p:nvPr/>
+        </p:nvSpPr>
+        <p:spPr>
+          <a:xfrm>
+            <a:off x="4010025" y="2286000"/>
+            <a:ext cx="285750" cy="285750"/>
+          </a:xfrm>
+          <a:prstGeom prst="rect">
+            <a:avLst/>
+          </a:prstGeom>
+          <a:solidFill>
+            <a:srgbClr val="102C48"/>
+          </a:solidFill>
+          <a:ln>
+            <a:noFill/>
+          </a:ln>
+          <a:effectLst/>
+        </p:spPr>
+        <p:style>
+          <a:lnRef idx="1">
+            <a:schemeClr val="accent1"/>
+          </a:lnRef>
+          <a:fillRef idx="3">
+            <a:schemeClr val="accent1"/>
+          </a:fillRef>
+          <a:effectRef idx="2">
+            <a:schemeClr val="accent1"/>
+          </a:effectRef>
+          <a:fontRef idx="minor">
+            <a:schemeClr val="lt1"/>
+          </a:fontRef>
+        </p:style>
+        <p:txBody>
+          <a:bodyPr rtlCol="0" anchor="ctr"/>
+          <a:lstStyle/>
+          <a:p>
+            <a:pPr algn="ctr"/>
+          </a:p>
+        </p:txBody>
+      </p:sp>
+      <p:sp>
+        <p:nvSpPr>
+          <p:cNvPr id="35" name="Rectangle 34"/>
+          <p:cNvSpPr/>
+          <p:nvPr/>
+        </p:nvSpPr>
+        <p:spPr>
+          <a:xfrm>
+            <a:off x="4333875" y="2286000"/>
+            <a:ext cx="285750" cy="285750"/>
+          </a:xfrm>
+          <a:prstGeom prst="rect">
+            <a:avLst/>
+          </a:prstGeom>
+          <a:solidFill>
+            <a:srgbClr val="102C48"/>
+          </a:solidFill>
+          <a:ln>
+            <a:noFill/>
+          </a:ln>
+          <a:effectLst/>
+        </p:spPr>
+        <p:style>
+          <a:lnRef idx="1">
+            <a:schemeClr val="accent1"/>
+          </a:lnRef>
+          <a:fillRef idx="3">
+            <a:schemeClr val="accent1"/>
+          </a:fillRef>
+          <a:effectRef idx="2">
+            <a:schemeClr val="accent1"/>
+          </a:effectRef>
+          <a:fontRef idx="minor">
+            <a:schemeClr val="lt1"/>
+          </a:fontRef>
+        </p:style>
+        <p:txBody>
+          <a:bodyPr rtlCol="0" anchor="ctr"/>
+          <a:lstStyle/>
+          <a:p>
+            <a:pPr algn="ctr"/>
+          </a:p>
+        </p:txBody>
+      </p:sp>
+      <p:sp>
+        <p:nvSpPr>
+          <p:cNvPr id="36" name="Rectangle 35"/>
+          <p:cNvSpPr/>
+          <p:nvPr/>
+        </p:nvSpPr>
+        <p:spPr>
+          <a:xfrm>
+            <a:off x="4657725" y="2286000"/>
+            <a:ext cx="285750" cy="285750"/>
+          </a:xfrm>
+          <a:prstGeom prst="rect">
+            <a:avLst/>
+          </a:prstGeom>
+          <a:solidFill>
+            <a:srgbClr val="102C48"/>
+          </a:solidFill>
+          <a:ln>
+            <a:noFill/>
+          </a:ln>
+          <a:effectLst/>
+        </p:spPr>
+        <p:style>
+          <a:lnRef idx="1">
+            <a:schemeClr val="accent1"/>
+          </a:lnRef>
+          <a:fillRef idx="3">
+            <a:schemeClr val="accent1"/>
+          </a:fillRef>
+          <a:effectRef idx="2">
+            <a:schemeClr val="accent1"/>
+          </a:effectRef>
+          <a:fontRef idx="minor">
+            <a:schemeClr val="lt1"/>
+          </a:fontRef>
+        </p:style>
+        <p:txBody>
+          <a:bodyPr rtlCol="0" anchor="ctr"/>
+          <a:lstStyle/>
+          <a:p>
+            <a:pPr algn="ctr"/>
+          </a:p>
+        </p:txBody>
+      </p:sp>
+      <p:sp>
+        <p:nvSpPr>
+          <p:cNvPr id="37" name="Rectangle 36"/>
+          <p:cNvSpPr/>
+          <p:nvPr/>
+        </p:nvSpPr>
+        <p:spPr>
+          <a:xfrm>
+            <a:off x="4981575" y="2286000"/>
+            <a:ext cx="285750" cy="285750"/>
+          </a:xfrm>
+          <a:prstGeom prst="rect">
+            <a:avLst/>
+          </a:prstGeom>
+          <a:solidFill>
+            <a:srgbClr val="102C48"/>
+          </a:solidFill>
+          <a:ln>
+            <a:noFill/>
+          </a:ln>
+          <a:effectLst/>
+        </p:spPr>
+        <p:style>
+          <a:lnRef idx="1">
+            <a:schemeClr val="accent1"/>
+          </a:lnRef>
+          <a:fillRef idx="3">
+            <a:schemeClr val="accent1"/>
+          </a:fillRef>
+          <a:effectRef idx="2">
+            <a:schemeClr val="accent1"/>
+          </a:effectRef>
+          <a:fontRef idx="minor">
+            <a:schemeClr val="lt1"/>
+          </a:fontRef>
+        </p:style>
+        <p:txBody>
+          <a:bodyPr rtlCol="0" anchor="ctr"/>
+          <a:lstStyle/>
+          <a:p>
+            <a:pPr algn="ctr"/>
+          </a:p>
+        </p:txBody>
+      </p:sp>
+      <p:sp>
+        <p:nvSpPr>
+          <p:cNvPr id="38" name="Rectangle 37"/>
+          <p:cNvSpPr/>
+          <p:nvPr/>
+        </p:nvSpPr>
+        <p:spPr>
+          <a:xfrm>
+            <a:off x="5305425" y="2286000"/>
+            <a:ext cx="285750" cy="285750"/>
+          </a:xfrm>
+          <a:prstGeom prst="rect">
+            <a:avLst/>
+          </a:prstGeom>
+          <a:solidFill>
+            <a:srgbClr val="102C48"/>
+          </a:solidFill>
+          <a:ln>
+            <a:noFill/>
+          </a:ln>
+          <a:effectLst/>
+        </p:spPr>
+        <p:style>
+          <a:lnRef idx="1">
+            <a:schemeClr val="accent1"/>
+          </a:lnRef>
+          <a:fillRef idx="3">
+            <a:schemeClr val="accent1"/>
+          </a:fillRef>
+          <a:effectRef idx="2">
+            <a:schemeClr val="accent1"/>
+          </a:effectRef>
+          <a:fontRef idx="minor">
+            <a:schemeClr val="lt1"/>
+          </a:fontRef>
+        </p:style>
+        <p:txBody>
+          <a:bodyPr rtlCol="0" anchor="ctr"/>
+          <a:lstStyle/>
+          <a:p>
+            <a:pPr algn="ctr"/>
+          </a:p>
+        </p:txBody>
+      </p:sp>
+      <p:sp>
+        <p:nvSpPr>
+          <p:cNvPr id="39" name="Rectangle 38"/>
+          <p:cNvSpPr/>
+          <p:nvPr/>
+        </p:nvSpPr>
+        <p:spPr>
+          <a:xfrm>
+            <a:off x="5629275" y="2286000"/>
+            <a:ext cx="285750" cy="285750"/>
+          </a:xfrm>
+          <a:prstGeom prst="rect">
+            <a:avLst/>
+          </a:prstGeom>
+          <a:solidFill>
+            <a:srgbClr val="102C48"/>
+          </a:solidFill>
+          <a:ln>
+            <a:noFill/>
+          </a:ln>
+          <a:effectLst/>
+        </p:spPr>
+        <p:style>
+          <a:lnRef idx="1">
+            <a:schemeClr val="accent1"/>
+          </a:lnRef>
+          <a:fillRef idx="3">
+            <a:schemeClr val="accent1"/>
+          </a:fillRef>
+          <a:effectRef idx="2">
+            <a:schemeClr val="accent1"/>
+          </a:effectRef>
+          <a:fontRef idx="minor">
+            <a:schemeClr val="lt1"/>
+          </a:fontRef>
+        </p:style>
+        <p:txBody>
+          <a:bodyPr rtlCol="0" anchor="ctr"/>
+          <a:lstStyle/>
+          <a:p>
+            <a:pPr algn="ctr"/>
+          </a:p>
+        </p:txBody>
+      </p:sp>
+      <p:sp>
+        <p:nvSpPr>
+          <p:cNvPr id="40" name="Rectangle 39"/>
+          <p:cNvSpPr/>
+          <p:nvPr/>
+        </p:nvSpPr>
+        <p:spPr>
+          <a:xfrm>
+            <a:off x="5953125" y="2286000"/>
+            <a:ext cx="285750" cy="285750"/>
+          </a:xfrm>
+          <a:prstGeom prst="rect">
+            <a:avLst/>
+          </a:prstGeom>
+          <a:solidFill>
+            <a:srgbClr val="102C48"/>
+          </a:solidFill>
+          <a:ln>
+            <a:noFill/>
+          </a:ln>
+          <a:effectLst/>
+        </p:spPr>
+        <p:style>
+          <a:lnRef idx="1">
+            <a:schemeClr val="accent1"/>
+          </a:lnRef>
+          <a:fillRef idx="3">
+            <a:schemeClr val="accent1"/>
+          </a:fillRef>
+          <a:effectRef idx="2">
+            <a:schemeClr val="accent1"/>
+          </a:effectRef>
+          <a:fontRef idx="minor">
+            <a:schemeClr val="lt1"/>
+          </a:fontRef>
+        </p:style>
+        <p:txBody>
+          <a:bodyPr rtlCol="0" anchor="ctr"/>
+          <a:lstStyle/>
+          <a:p>
+            <a:pPr algn="ctr"/>
+          </a:p>
+        </p:txBody>
+      </p:sp>
+      <p:sp>
+        <p:nvSpPr>
+          <p:cNvPr id="41" name="Rectangle 40"/>
+          <p:cNvSpPr/>
+          <p:nvPr/>
+        </p:nvSpPr>
+        <p:spPr>
+          <a:xfrm>
+            <a:off x="6276975" y="2286000"/>
+            <a:ext cx="285750" cy="285750"/>
+          </a:xfrm>
+          <a:prstGeom prst="rect">
+            <a:avLst/>
+          </a:prstGeom>
+          <a:solidFill>
+            <a:srgbClr val="102C48"/>
+          </a:solidFill>
+          <a:ln>
+            <a:noFill/>
+          </a:ln>
+          <a:effectLst/>
+        </p:spPr>
+        <p:style>
+          <a:lnRef idx="1">
+            <a:schemeClr val="accent1"/>
+          </a:lnRef>
+          <a:fillRef idx="3">
+            <a:schemeClr val="accent1"/>
+          </a:fillRef>
+          <a:effectRef idx="2">
+            <a:schemeClr val="accent1"/>
+          </a:effectRef>
+          <a:fontRef idx="minor">
+            <a:schemeClr val="lt1"/>
+          </a:fontRef>
+        </p:style>
+        <p:txBody>
+          <a:bodyPr rtlCol="0" anchor="ctr"/>
+          <a:lstStyle/>
+          <a:p>
+            <a:pPr algn="ctr"/>
+          </a:p>
+        </p:txBody>
+      </p:sp>
+      <p:sp>
+        <p:nvSpPr>
+          <p:cNvPr id="42" name="Rectangle 41"/>
+          <p:cNvSpPr/>
+          <p:nvPr/>
+        </p:nvSpPr>
+        <p:spPr>
+          <a:xfrm>
+            <a:off x="6600825" y="2286000"/>
+            <a:ext cx="285750" cy="285750"/>
+          </a:xfrm>
+          <a:prstGeom prst="rect">
+            <a:avLst/>
+          </a:prstGeom>
+          <a:solidFill>
+            <a:srgbClr val="102C48"/>
+          </a:solidFill>
+          <a:ln>
+            <a:noFill/>
+          </a:ln>
+          <a:effectLst/>
+        </p:spPr>
+        <p:style>
+          <a:lnRef idx="1">
+            <a:schemeClr val="accent1"/>
+          </a:lnRef>
+          <a:fillRef idx="3">
+            <a:schemeClr val="accent1"/>
+          </a:fillRef>
+          <a:effectRef idx="2">
+            <a:schemeClr val="accent1"/>
+          </a:effectRef>
+          <a:fontRef idx="minor">
+            <a:schemeClr val="lt1"/>
+          </a:fontRef>
+        </p:style>
+        <p:txBody>
+          <a:bodyPr rtlCol="0" anchor="ctr"/>
+          <a:lstStyle/>
+          <a:p>
+            <a:pPr algn="ctr"/>
+          </a:p>
+        </p:txBody>
+      </p:sp>
+      <p:sp>
+        <p:nvSpPr>
+          <p:cNvPr id="43" name="Rectangle 42"/>
+          <p:cNvSpPr/>
+          <p:nvPr/>
+        </p:nvSpPr>
+        <p:spPr>
+          <a:xfrm>
+            <a:off x="6924675" y="2286000"/>
+            <a:ext cx="285750" cy="285750"/>
+          </a:xfrm>
+          <a:prstGeom prst="rect">
+            <a:avLst/>
+          </a:prstGeom>
+          <a:solidFill>
+            <a:srgbClr val="102C48"/>
+          </a:solidFill>
+          <a:ln>
+            <a:noFill/>
+          </a:ln>
+          <a:effectLst/>
+        </p:spPr>
+        <p:style>
+          <a:lnRef idx="1">
+            <a:schemeClr val="accent1"/>
+          </a:lnRef>
+          <a:fillRef idx="3">
+            <a:schemeClr val="accent1"/>
+          </a:fillRef>
+          <a:effectRef idx="2">
+            <a:schemeClr val="accent1"/>
+          </a:effectRef>
+          <a:fontRef idx="minor">
+            <a:schemeClr val="lt1"/>
+          </a:fontRef>
+        </p:style>
+        <p:txBody>
+          <a:bodyPr rtlCol="0" anchor="ctr"/>
+          <a:lstStyle/>
+          <a:p>
+            <a:pPr algn="ctr"/>
+          </a:p>
+        </p:txBody>
+      </p:sp>
+      <p:sp>
+        <p:nvSpPr>
+          <p:cNvPr id="44" name="Rectangle 43"/>
+          <p:cNvSpPr/>
+          <p:nvPr/>
+        </p:nvSpPr>
+        <p:spPr>
+          <a:xfrm>
+            <a:off x="3362325" y="2609850"/>
+            <a:ext cx="285750" cy="285750"/>
+          </a:xfrm>
+          <a:prstGeom prst="rect">
+            <a:avLst/>
+          </a:prstGeom>
+          <a:solidFill>
+            <a:srgbClr val="102C48"/>
+          </a:solidFill>
+          <a:ln>
+            <a:noFill/>
+          </a:ln>
+          <a:effectLst/>
+        </p:spPr>
+        <p:style>
+          <a:lnRef idx="1">
+            <a:schemeClr val="accent1"/>
+          </a:lnRef>
+          <a:fillRef idx="3">
+            <a:schemeClr val="accent1"/>
+          </a:fillRef>
+          <a:effectRef idx="2">
+            <a:schemeClr val="accent1"/>
+          </a:effectRef>
+          <a:fontRef idx="minor">
+            <a:schemeClr val="lt1"/>
+          </a:fontRef>
+        </p:style>
+        <p:txBody>
+          <a:bodyPr rtlCol="0" anchor="ctr"/>
+          <a:lstStyle/>
+          <a:p>
+            <a:pPr algn="ctr"/>
+          </a:p>
+        </p:txBody>
+      </p:sp>
+      <p:sp>
+        <p:nvSpPr>
+          <p:cNvPr id="45" name="Rectangle 44"/>
+          <p:cNvSpPr/>
+          <p:nvPr/>
+        </p:nvSpPr>
+        <p:spPr>
+          <a:xfrm>
+            <a:off x="3686175" y="2609850"/>
+            <a:ext cx="285750" cy="285750"/>
+          </a:xfrm>
+          <a:prstGeom prst="rect">
+            <a:avLst/>
+          </a:prstGeom>
+          <a:solidFill>
+            <a:srgbClr val="102C48"/>
+          </a:solidFill>
+          <a:ln>
+            <a:noFill/>
+          </a:ln>
+          <a:effectLst/>
+        </p:spPr>
+        <p:style>
+          <a:lnRef idx="1">
+            <a:schemeClr val="accent1"/>
+          </a:lnRef>
+          <a:fillRef idx="3">
+            <a:schemeClr val="accent1"/>
+          </a:fillRef>
+          <a:effectRef idx="2">
+            <a:schemeClr val="accent1"/>
+          </a:effectRef>
+          <a:fontRef idx="minor">
+            <a:schemeClr val="lt1"/>
+          </a:fontRef>
+        </p:style>
+        <p:txBody>
+          <a:bodyPr rtlCol="0" anchor="ctr"/>
+          <a:lstStyle/>
+          <a:p>
+            <a:pPr algn="ctr"/>
+          </a:p>
+        </p:txBody>
+      </p:sp>
+      <p:sp>
+        <p:nvSpPr>
+          <p:cNvPr id="46" name="Rectangle 45"/>
+          <p:cNvSpPr/>
+          <p:nvPr/>
+        </p:nvSpPr>
+        <p:spPr>
+          <a:xfrm>
+            <a:off x="4010025" y="2609850"/>
+            <a:ext cx="285750" cy="285750"/>
+          </a:xfrm>
+          <a:prstGeom prst="rect">
+            <a:avLst/>
+          </a:prstGeom>
+          <a:solidFill>
+            <a:srgbClr val="FBD332"/>
+          </a:solidFill>
+          <a:ln>
+            <a:noFill/>
+          </a:ln>
+          <a:effectLst/>
+        </p:spPr>
+        <p:style>
+          <a:lnRef idx="1">
+            <a:schemeClr val="accent1"/>
+          </a:lnRef>
+          <a:fillRef idx="3">
+            <a:schemeClr val="accent1"/>
+          </a:fillRef>
+          <a:effectRef idx="2">
+            <a:schemeClr val="accent1"/>
+          </a:effectRef>
+          <a:fontRef idx="minor">
+            <a:schemeClr val="lt1"/>
+          </a:fontRef>
+        </p:style>
+        <p:txBody>
+          <a:bodyPr rtlCol="0" anchor="ctr"/>
+          <a:lstStyle/>
+          <a:p>
+            <a:pPr algn="ctr"/>
+          </a:p>
+        </p:txBody>
+      </p:sp>
+      <p:sp>
+        <p:nvSpPr>
+          <p:cNvPr id="47" name="Rectangle 46"/>
+          <p:cNvSpPr/>
+          <p:nvPr/>
+        </p:nvSpPr>
+        <p:spPr>
+          <a:xfrm>
+            <a:off x="4333875" y="2609850"/>
+            <a:ext cx="285750" cy="285750"/>
+          </a:xfrm>
+          <a:prstGeom prst="rect">
+            <a:avLst/>
+          </a:prstGeom>
+          <a:solidFill>
+            <a:srgbClr val="FBD332"/>
+          </a:solidFill>
+          <a:ln>
+            <a:noFill/>
+          </a:ln>
+          <a:effectLst/>
+        </p:spPr>
+        <p:style>
+          <a:lnRef idx="1">
+            <a:schemeClr val="accent1"/>
+          </a:lnRef>
+          <a:fillRef idx="3">
+            <a:schemeClr val="accent1"/>
+          </a:fillRef>
+          <a:effectRef idx="2">
+            <a:schemeClr val="accent1"/>
+          </a:effectRef>
+          <a:fontRef idx="minor">
+            <a:schemeClr val="lt1"/>
+          </a:fontRef>
+        </p:style>
+        <p:txBody>
+          <a:bodyPr rtlCol="0" anchor="ctr"/>
+          <a:lstStyle/>
+          <a:p>
+            <a:pPr algn="ctr"/>
+          </a:p>
+        </p:txBody>
+      </p:sp>
+      <p:sp>
+        <p:nvSpPr>
+          <p:cNvPr id="48" name="Rectangle 47"/>
+          <p:cNvSpPr/>
+          <p:nvPr/>
+        </p:nvSpPr>
+        <p:spPr>
+          <a:xfrm>
+            <a:off x="4657725" y="2609850"/>
+            <a:ext cx="285750" cy="285750"/>
+          </a:xfrm>
+          <a:prstGeom prst="rect">
+            <a:avLst/>
+          </a:prstGeom>
+          <a:solidFill>
+            <a:srgbClr val="102C48"/>
+          </a:solidFill>
+          <a:ln>
+            <a:noFill/>
+          </a:ln>
+          <a:effectLst/>
+        </p:spPr>
+        <p:style>
+          <a:lnRef idx="1">
+            <a:schemeClr val="accent1"/>
+          </a:lnRef>
+          <a:fillRef idx="3">
+            <a:schemeClr val="accent1"/>
+          </a:fillRef>
+          <a:effectRef idx="2">
+            <a:schemeClr val="accent1"/>
+          </a:effectRef>
+          <a:fontRef idx="minor">
+            <a:schemeClr val="lt1"/>
+          </a:fontRef>
+        </p:style>
+        <p:txBody>
+          <a:bodyPr rtlCol="0" anchor="ctr"/>
+          <a:lstStyle/>
+          <a:p>
+            <a:pPr algn="ctr"/>
+          </a:p>
+        </p:txBody>
+      </p:sp>
+      <p:sp>
+        <p:nvSpPr>
+          <p:cNvPr id="49" name="Rectangle 48"/>
+          <p:cNvSpPr/>
+          <p:nvPr/>
+        </p:nvSpPr>
+        <p:spPr>
+          <a:xfrm>
+            <a:off x="4981575" y="2609850"/>
+            <a:ext cx="285750" cy="285750"/>
+          </a:xfrm>
+          <a:prstGeom prst="rect">
+            <a:avLst/>
+          </a:prstGeom>
+          <a:solidFill>
+            <a:srgbClr val="102C48"/>
+          </a:solidFill>
+          <a:ln>
+            <a:noFill/>
+          </a:ln>
+          <a:effectLst/>
+        </p:spPr>
+        <p:style>
+          <a:lnRef idx="1">
+            <a:schemeClr val="accent1"/>
+          </a:lnRef>
+          <a:fillRef idx="3">
+            <a:schemeClr val="accent1"/>
+          </a:fillRef>
+          <a:effectRef idx="2">
+            <a:schemeClr val="accent1"/>
+          </a:effectRef>
+          <a:fontRef idx="minor">
+            <a:schemeClr val="lt1"/>
+          </a:fontRef>
+        </p:style>
+        <p:txBody>
+          <a:bodyPr rtlCol="0" anchor="ctr"/>
+          <a:lstStyle/>
+          <a:p>
+            <a:pPr algn="ctr"/>
+          </a:p>
+        </p:txBody>
+      </p:sp>
+      <p:sp>
+        <p:nvSpPr>
+          <p:cNvPr id="50" name="Rectangle 49"/>
+          <p:cNvSpPr/>
+          <p:nvPr/>
+        </p:nvSpPr>
+        <p:spPr>
+          <a:xfrm>
+            <a:off x="5305425" y="2609850"/>
+            <a:ext cx="285750" cy="285750"/>
+          </a:xfrm>
+          <a:prstGeom prst="rect">
+            <a:avLst/>
+          </a:prstGeom>
+          <a:solidFill>
+            <a:srgbClr val="102C48"/>
+          </a:solidFill>
+          <a:ln>
+            <a:noFill/>
+          </a:ln>
+          <a:effectLst/>
+        </p:spPr>
+        <p:style>
+          <a:lnRef idx="1">
+            <a:schemeClr val="accent1"/>
+          </a:lnRef>
+          <a:fillRef idx="3">
+            <a:schemeClr val="accent1"/>
+          </a:fillRef>
+          <a:effectRef idx="2">
+            <a:schemeClr val="accent1"/>
+          </a:effectRef>
+          <a:fontRef idx="minor">
+            <a:schemeClr val="lt1"/>
+          </a:fontRef>
+        </p:style>
+        <p:txBody>
+          <a:bodyPr rtlCol="0" anchor="ctr"/>
+          <a:lstStyle/>
+          <a:p>
+            <a:pPr algn="ctr"/>
+          </a:p>
+        </p:txBody>
+      </p:sp>
+      <p:sp>
+        <p:nvSpPr>
+          <p:cNvPr id="51" name="Rectangle 50"/>
+          <p:cNvSpPr/>
+          <p:nvPr/>
+        </p:nvSpPr>
+        <p:spPr>
+          <a:xfrm>
+            <a:off x="5629275" y="2609850"/>
+            <a:ext cx="285750" cy="285750"/>
+          </a:xfrm>
+          <a:prstGeom prst="rect">
+            <a:avLst/>
+          </a:prstGeom>
+          <a:solidFill>
+            <a:srgbClr val="102C48"/>
+          </a:solidFill>
+          <a:ln>
+            <a:noFill/>
+          </a:ln>
+          <a:effectLst/>
+        </p:spPr>
+        <p:style>
+          <a:lnRef idx="1">
+            <a:schemeClr val="accent1"/>
+          </a:lnRef>
+          <a:fillRef idx="3">
+            <a:schemeClr val="accent1"/>
+          </a:fillRef>
+          <a:effectRef idx="2">
+            <a:schemeClr val="accent1"/>
+          </a:effectRef>
+          <a:fontRef idx="minor">
+            <a:schemeClr val="lt1"/>
+          </a:fontRef>
+        </p:style>
+        <p:txBody>
+          <a:bodyPr rtlCol="0" anchor="ctr"/>
+          <a:lstStyle/>
+          <a:p>
+            <a:pPr algn="ctr"/>
+          </a:p>
+        </p:txBody>
+      </p:sp>
+      <p:sp>
+        <p:nvSpPr>
+          <p:cNvPr id="52" name="Rectangle 51"/>
+          <p:cNvSpPr/>
+          <p:nvPr/>
+        </p:nvSpPr>
+        <p:spPr>
+          <a:xfrm>
+            <a:off x="5953125" y="2609850"/>
+            <a:ext cx="285750" cy="285750"/>
+          </a:xfrm>
+          <a:prstGeom prst="rect">
+            <a:avLst/>
+          </a:prstGeom>
+          <a:solidFill>
+            <a:srgbClr val="102C48"/>
+          </a:solidFill>
+          <a:ln>
+            <a:noFill/>
+          </a:ln>
+          <a:effectLst/>
+        </p:spPr>
+        <p:style>
+          <a:lnRef idx="1">
+            <a:schemeClr val="accent1"/>
+          </a:lnRef>
+          <a:fillRef idx="3">
+            <a:schemeClr val="accent1"/>
+          </a:fillRef>
+          <a:effectRef idx="2">
+            <a:schemeClr val="accent1"/>
+          </a:effectRef>
+          <a:fontRef idx="minor">
+            <a:schemeClr val="lt1"/>
+          </a:fontRef>
+        </p:style>
+        <p:txBody>
+          <a:bodyPr rtlCol="0" anchor="ctr"/>
+          <a:lstStyle/>
+          <a:p>
+            <a:pPr algn="ctr"/>
+          </a:p>
+        </p:txBody>
+      </p:sp>
+      <p:sp>
+        <p:nvSpPr>
+          <p:cNvPr id="53" name="Rectangle 52"/>
+          <p:cNvSpPr/>
+          <p:nvPr/>
+        </p:nvSpPr>
+        <p:spPr>
+          <a:xfrm>
+            <a:off x="6276975" y="2609850"/>
+            <a:ext cx="285750" cy="285750"/>
+          </a:xfrm>
+          <a:prstGeom prst="rect">
+            <a:avLst/>
+          </a:prstGeom>
+          <a:solidFill>
+            <a:srgbClr val="102C48"/>
+          </a:solidFill>
+          <a:ln>
+            <a:noFill/>
+          </a:ln>
+          <a:effectLst/>
+        </p:spPr>
+        <p:style>
+          <a:lnRef idx="1">
+            <a:schemeClr val="accent1"/>
+          </a:lnRef>
+          <a:fillRef idx="3">
+            <a:schemeClr val="accent1"/>
+          </a:fillRef>
+          <a:effectRef idx="2">
+            <a:schemeClr val="accent1"/>
+          </a:effectRef>
+          <a:fontRef idx="minor">
+            <a:schemeClr val="lt1"/>
+          </a:fontRef>
+        </p:style>
+        <p:txBody>
+          <a:bodyPr rtlCol="0" anchor="ctr"/>
+          <a:lstStyle/>
+          <a:p>
+            <a:pPr algn="ctr"/>
+          </a:p>
+        </p:txBody>
+      </p:sp>
+      <p:sp>
+        <p:nvSpPr>
+          <p:cNvPr id="54" name="Rectangle 53"/>
+          <p:cNvSpPr/>
+          <p:nvPr/>
+        </p:nvSpPr>
+        <p:spPr>
+          <a:xfrm>
+            <a:off x="6600825" y="2609850"/>
+            <a:ext cx="285750" cy="285750"/>
+          </a:xfrm>
+          <a:prstGeom prst="rect">
+            <a:avLst/>
+          </a:prstGeom>
+          <a:solidFill>
+            <a:srgbClr val="102C48"/>
+          </a:solidFill>
+          <a:ln>
+            <a:noFill/>
+          </a:ln>
+          <a:effectLst/>
+        </p:spPr>
+        <p:style>
+          <a:lnRef idx="1">
+            <a:schemeClr val="accent1"/>
+          </a:lnRef>
+          <a:fillRef idx="3">
+            <a:schemeClr val="accent1"/>
+          </a:fillRef>
+          <a:effectRef idx="2">
+            <a:schemeClr val="accent1"/>
+          </a:effectRef>
+          <a:fontRef idx="minor">
+            <a:schemeClr val="lt1"/>
+          </a:fontRef>
+        </p:style>
+        <p:txBody>
+          <a:bodyPr rtlCol="0" anchor="ctr"/>
+          <a:lstStyle/>
+          <a:p>
+            <a:pPr algn="ctr"/>
+          </a:p>
+        </p:txBody>
+      </p:sp>
+      <p:sp>
+        <p:nvSpPr>
+          <p:cNvPr id="55" name="Rectangle 54"/>
+          <p:cNvSpPr/>
+          <p:nvPr/>
+        </p:nvSpPr>
+        <p:spPr>
+          <a:xfrm>
+            <a:off x="6924675" y="2609850"/>
+            <a:ext cx="285750" cy="285750"/>
+          </a:xfrm>
+          <a:prstGeom prst="rect">
+            <a:avLst/>
+          </a:prstGeom>
+          <a:solidFill>
+            <a:srgbClr val="102C48"/>
+          </a:solidFill>
+          <a:ln>
+            <a:noFill/>
+          </a:ln>
+          <a:effectLst/>
+        </p:spPr>
+        <p:style>
+          <a:lnRef idx="1">
+            <a:schemeClr val="accent1"/>
+          </a:lnRef>
+          <a:fillRef idx="3">
+            <a:schemeClr val="accent1"/>
+          </a:fillRef>
+          <a:effectRef idx="2">
+            <a:schemeClr val="accent1"/>
+          </a:effectRef>
+          <a:fontRef idx="minor">
+            <a:schemeClr val="lt1"/>
+          </a:fontRef>
+        </p:style>
+        <p:txBody>
+          <a:bodyPr rtlCol="0" anchor="ctr"/>
+          <a:lstStyle/>
+          <a:p>
+            <a:pPr algn="ctr"/>
+          </a:p>
+        </p:txBody>
+      </p:sp>
+      <p:sp>
+        <p:nvSpPr>
+          <p:cNvPr id="56" name="TextBox 55"/>
+          <p:cNvSpPr txBox="1"/>
+          <p:nvPr/>
+        </p:nvSpPr>
+        <p:spPr>
+          <a:xfrm>
+            <a:off x="3362325" y="2971800"/>
+            <a:ext cx="4000500" cy="476250"/>
+          </a:xfrm>
+          <a:prstGeom prst="rect">
+            <a:avLst/>
+          </a:prstGeom>
+          <a:noFill/>
+        </p:spPr>
+        <p:txBody>
+          <a:bodyPr wrap="square" lIns="0" rIns="0" tIns="0" bIns="0" anchor="ctr">
+            <a:spAutoFit/>
+          </a:bodyPr>
+          <a:lstStyle/>
+          <a:p>
+            <a:pPr algn="l">
+              <a:lnSpc>
+                <a:spcPct val="122000"/>
+              </a:lnSpc>
+            </a:pPr>
+            <a:r>
+              <a:rPr sz="1300" b="0">
+                <a:solidFill>
+                  <a:srgbClr val="F5F5F8"/>
+                </a:solidFill>
+                <a:latin typeface="Amazon Ember"/>
+                <a:ea typeface="メイリオ"/>
+                <a:cs typeface="メイリオ"/>
+              </a:rPr>
+              <a:t>A holds blocks 7, 8, 9 (blue), B holds 41, 42 (yellow);</a:t>
+            </a:r>
+          </a:p>
+          <a:p>
+            <a:pPr algn="l">
+              <a:lnSpc>
+                <a:spcPct val="122000"/>
+              </a:lnSpc>
+            </a:pPr>
+            <a:r>
+              <a:rPr sz="1300" b="0">
+                <a:solidFill>
+                  <a:srgbClr val="F5F5F8"/>
+                </a:solidFill>
+                <a:latin typeface="Amazon Ember"/>
+                <a:ea typeface="メイリオ"/>
+                <a:cs typeface="メイリオ"/>
+              </a:rPr>
+              <a:t>a request gets more blocks as its text grows</a:t>
+            </a:r>
+          </a:p>
+        </p:txBody>
+      </p:sp>
+      <p:sp>
+        <p:nvSpPr>
+          <p:cNvPr id="57" name="TextBox 56"/>
+          <p:cNvSpPr txBox="1"/>
+          <p:nvPr/>
+        </p:nvSpPr>
+        <p:spPr>
+          <a:xfrm>
+            <a:off x="3362325" y="3486150"/>
+            <a:ext cx="4000500" cy="419100"/>
+          </a:xfrm>
+          <a:prstGeom prst="rect">
+            <a:avLst/>
+          </a:prstGeom>
+          <a:noFill/>
+        </p:spPr>
+        <p:txBody>
+          <a:bodyPr wrap="square" lIns="0" rIns="0" tIns="0" bIns="0" anchor="ctr">
+            <a:spAutoFit/>
+          </a:bodyPr>
+          <a:lstStyle/>
+          <a:p>
+            <a:pPr algn="l">
+              <a:lnSpc>
+                <a:spcPct val="122000"/>
+              </a:lnSpc>
+            </a:pPr>
+            <a:r>
+              <a:rPr sz="1300" b="0">
+                <a:solidFill>
+                  <a:srgbClr val="96969E"/>
+                </a:solidFill>
+                <a:latin typeface="Amazon Ember"/>
+                <a:ea typeface="メイリオ"/>
+                <a:cs typeface="メイリオ"/>
+              </a:rPr>
+              <a:t>attention layers only (6 of 52)</a:t>
+            </a:r>
+          </a:p>
+        </p:txBody>
+      </p:sp>
+      <p:sp>
+        <p:nvSpPr>
+          <p:cNvPr id="58" name="TextBox 57"/>
+          <p:cNvSpPr txBox="1"/>
+          <p:nvPr/>
+        </p:nvSpPr>
+        <p:spPr>
+          <a:xfrm>
+            <a:off x="7553325" y="1333500"/>
+            <a:ext cx="4229100" cy="247650"/>
+          </a:xfrm>
+          <a:prstGeom prst="rect">
+            <a:avLst/>
+          </a:prstGeom>
+          <a:noFill/>
+        </p:spPr>
+        <p:txBody>
+          <a:bodyPr wrap="square" lIns="0" rIns="0" tIns="0" bIns="0" anchor="ctr">
+            <a:spAutoFit/>
+          </a:bodyPr>
+          <a:lstStyle/>
+          <a:p>
+            <a:pPr algn="l">
+              <a:lnSpc>
+                <a:spcPct val="122000"/>
+              </a:lnSpc>
+            </a:pPr>
+            <a:r>
+              <a:rPr sz="1500" b="0">
+                <a:solidFill>
+                  <a:srgbClr val="3BD16F"/>
+                </a:solidFill>
+                <a:latin typeface="Amazon Ember"/>
+                <a:ea typeface="メイリオ"/>
+                <a:cs typeface="メイリオ"/>
+              </a:rPr>
+              <a:t>Mamba state pool: 2N + 1 rows</a:t>
+            </a:r>
+          </a:p>
+        </p:txBody>
+      </p:sp>
+      <p:sp>
+        <p:nvSpPr>
+          <p:cNvPr id="59" name="Rounded Rectangle 58"/>
+          <p:cNvSpPr/>
+          <p:nvPr/>
+        </p:nvSpPr>
+        <p:spPr>
+          <a:xfrm>
+            <a:off x="7553325" y="1638300"/>
+            <a:ext cx="952500" cy="342900"/>
+          </a:xfrm>
+          <a:prstGeom prst="roundRect">
+            <a:avLst>
+              <a:gd name="adj" fmla="val 10000"/>
+            </a:avLst>
+          </a:prstGeom>
+          <a:solidFill>
+            <a:srgbClr val="161A1E"/>
+          </a:solidFill>
+          <a:ln w="15875">
+            <a:solidFill>
+              <a:srgbClr val="464A50"/>
+            </a:solidFill>
+          </a:ln>
+          <a:effectLst/>
+        </p:spPr>
+        <p:style>
+          <a:lnRef idx="1">
+            <a:schemeClr val="accent1"/>
+          </a:lnRef>
+          <a:fillRef idx="3">
+            <a:schemeClr val="accent1"/>
+          </a:fillRef>
+          <a:effectRef idx="2">
+            <a:schemeClr val="accent1"/>
+          </a:effectRef>
+          <a:fontRef idx="minor">
+            <a:schemeClr val="lt1"/>
+          </a:fontRef>
+        </p:style>
+        <p:txBody>
+          <a:bodyPr rtlCol="0" anchor="ctr" wrap="square" lIns="19050" rIns="19050" tIns="19050" bIns="19050"/>
+          <a:lstStyle/>
+          <a:p>
+            <a:pPr algn="ctr">
+              <a:lnSpc>
+                <a:spcPct val="122000"/>
+              </a:lnSpc>
+            </a:pPr>
+            <a:r>
+              <a:rPr sz="1300" b="1">
+                <a:solidFill>
+                  <a:srgbClr val="F5F5F8"/>
+                </a:solidFill>
+                <a:latin typeface="Amazon Ember"/>
+                <a:ea typeface="メイリオ"/>
+                <a:cs typeface="メイリオ"/>
+              </a:rPr>
+              <a:t>row 0</a:t>
+            </a:r>
+          </a:p>
+        </p:txBody>
+      </p:sp>
+      <p:sp>
+        <p:nvSpPr>
+          <p:cNvPr id="60" name="Rounded Rectangle 59"/>
+          <p:cNvSpPr/>
+          <p:nvPr/>
+        </p:nvSpPr>
+        <p:spPr>
+          <a:xfrm>
+            <a:off x="8601075" y="1638300"/>
+            <a:ext cx="1524000" cy="342900"/>
+          </a:xfrm>
+          <a:prstGeom prst="roundRect">
+            <a:avLst>
+              <a:gd name="adj" fmla="val 10000"/>
+            </a:avLst>
+          </a:prstGeom>
+          <a:solidFill>
+            <a:srgbClr val="124022"/>
+          </a:solidFill>
+          <a:ln w="15875">
+            <a:solidFill>
+              <a:srgbClr val="24A046"/>
+            </a:solidFill>
+          </a:ln>
+          <a:effectLst/>
+        </p:spPr>
+        <p:style>
+          <a:lnRef idx="1">
+            <a:schemeClr val="accent1"/>
+          </a:lnRef>
+          <a:fillRef idx="3">
+            <a:schemeClr val="accent1"/>
+          </a:fillRef>
+          <a:effectRef idx="2">
+            <a:schemeClr val="accent1"/>
+          </a:effectRef>
+          <a:fontRef idx="minor">
+            <a:schemeClr val="lt1"/>
+          </a:fontRef>
+        </p:style>
+        <p:txBody>
+          <a:bodyPr rtlCol="0" anchor="ctr" wrap="square" lIns="19050" rIns="19050" tIns="19050" bIns="19050"/>
+          <a:lstStyle/>
+          <a:p>
+            <a:pPr algn="ctr">
+              <a:lnSpc>
+                <a:spcPct val="122000"/>
+              </a:lnSpc>
+            </a:pPr>
+            <a:r>
+              <a:rPr sz="1300" b="1">
+                <a:solidFill>
+                  <a:srgbClr val="F5F5F8"/>
+                </a:solidFill>
+                <a:latin typeface="Amazon Ember"/>
+                <a:ea typeface="メイリオ"/>
+                <a:cs typeface="メイリオ"/>
+              </a:rPr>
+              <a:t>request A</a:t>
+            </a:r>
+          </a:p>
+        </p:txBody>
+      </p:sp>
+      <p:sp>
+        <p:nvSpPr>
+          <p:cNvPr id="61" name="Rounded Rectangle 60"/>
+          <p:cNvSpPr/>
+          <p:nvPr/>
+        </p:nvSpPr>
+        <p:spPr>
+          <a:xfrm>
+            <a:off x="10220325" y="1638300"/>
+            <a:ext cx="1371600" cy="342900"/>
+          </a:xfrm>
+          <a:prstGeom prst="roundRect">
+            <a:avLst>
+              <a:gd name="adj" fmla="val 10000"/>
+            </a:avLst>
+          </a:prstGeom>
+          <a:solidFill>
+            <a:srgbClr val="161A1E"/>
+          </a:solidFill>
+          <a:ln w="15875">
+            <a:solidFill>
+              <a:srgbClr val="464A50"/>
+            </a:solidFill>
+          </a:ln>
+          <a:effectLst/>
+        </p:spPr>
+        <p:style>
+          <a:lnRef idx="1">
+            <a:schemeClr val="accent1"/>
+          </a:lnRef>
+          <a:fillRef idx="3">
+            <a:schemeClr val="accent1"/>
+          </a:fillRef>
+          <a:effectRef idx="2">
+            <a:schemeClr val="accent1"/>
+          </a:effectRef>
+          <a:fontRef idx="minor">
+            <a:schemeClr val="lt1"/>
+          </a:fontRef>
+        </p:style>
+        <p:txBody>
+          <a:bodyPr rtlCol="0" anchor="ctr" wrap="square" lIns="19050" rIns="19050" tIns="19050" bIns="19050"/>
+          <a:lstStyle/>
+          <a:p>
+            <a:pPr algn="ctr">
+              <a:lnSpc>
+                <a:spcPct val="122000"/>
+              </a:lnSpc>
+            </a:pPr>
+            <a:r>
+              <a:rPr sz="1200" b="1">
+                <a:solidFill>
+                  <a:srgbClr val="96969E"/>
+                </a:solidFill>
+                <a:latin typeface="Amazon Ember"/>
+                <a:ea typeface="メイリオ"/>
+                <a:cs typeface="メイリオ"/>
+              </a:rPr>
+              <a:t>owner: block 7</a:t>
+            </a:r>
+          </a:p>
+        </p:txBody>
+      </p:sp>
+      <p:sp>
+        <p:nvSpPr>
+          <p:cNvPr id="62" name="Rounded Rectangle 61"/>
+          <p:cNvSpPr/>
+          <p:nvPr/>
+        </p:nvSpPr>
+        <p:spPr>
+          <a:xfrm>
+            <a:off x="7553325" y="2038350"/>
+            <a:ext cx="952500" cy="342900"/>
+          </a:xfrm>
+          <a:prstGeom prst="roundRect">
+            <a:avLst>
+              <a:gd name="adj" fmla="val 10000"/>
+            </a:avLst>
+          </a:prstGeom>
+          <a:solidFill>
+            <a:srgbClr val="161A1E"/>
+          </a:solidFill>
+          <a:ln w="15875">
+            <a:solidFill>
+              <a:srgbClr val="464A50"/>
+            </a:solidFill>
+          </a:ln>
+          <a:effectLst/>
+        </p:spPr>
+        <p:style>
+          <a:lnRef idx="1">
+            <a:schemeClr val="accent1"/>
+          </a:lnRef>
+          <a:fillRef idx="3">
+            <a:schemeClr val="accent1"/>
+          </a:fillRef>
+          <a:effectRef idx="2">
+            <a:schemeClr val="accent1"/>
+          </a:effectRef>
+          <a:fontRef idx="minor">
+            <a:schemeClr val="lt1"/>
+          </a:fontRef>
+        </p:style>
+        <p:txBody>
+          <a:bodyPr rtlCol="0" anchor="ctr" wrap="square" lIns="19050" rIns="19050" tIns="19050" bIns="19050"/>
+          <a:lstStyle/>
+          <a:p>
+            <a:pPr algn="ctr">
+              <a:lnSpc>
+                <a:spcPct val="122000"/>
+              </a:lnSpc>
+            </a:pPr>
+            <a:r>
+              <a:rPr sz="1300" b="1">
+                <a:solidFill>
+                  <a:srgbClr val="F5F5F8"/>
+                </a:solidFill>
+                <a:latin typeface="Amazon Ember"/>
+                <a:ea typeface="メイリオ"/>
+                <a:cs typeface="メイリオ"/>
+              </a:rPr>
+              <a:t>row 1</a:t>
+            </a:r>
+          </a:p>
+        </p:txBody>
+      </p:sp>
+      <p:sp>
+        <p:nvSpPr>
+          <p:cNvPr id="63" name="Rounded Rectangle 62"/>
+          <p:cNvSpPr/>
+          <p:nvPr/>
+        </p:nvSpPr>
+        <p:spPr>
+          <a:xfrm>
+            <a:off x="8601075" y="2038350"/>
+            <a:ext cx="1524000" cy="342900"/>
+          </a:xfrm>
+          <a:prstGeom prst="roundRect">
+            <a:avLst>
+              <a:gd name="adj" fmla="val 10000"/>
+            </a:avLst>
+          </a:prstGeom>
+          <a:solidFill>
+            <a:srgbClr val="124022"/>
+          </a:solidFill>
+          <a:ln w="15875">
+            <a:solidFill>
+              <a:srgbClr val="24A046"/>
+            </a:solidFill>
+          </a:ln>
+          <a:effectLst/>
+        </p:spPr>
+        <p:style>
+          <a:lnRef idx="1">
+            <a:schemeClr val="accent1"/>
+          </a:lnRef>
+          <a:fillRef idx="3">
+            <a:schemeClr val="accent1"/>
+          </a:fillRef>
+          <a:effectRef idx="2">
+            <a:schemeClr val="accent1"/>
+          </a:effectRef>
+          <a:fontRef idx="minor">
+            <a:schemeClr val="lt1"/>
+          </a:fontRef>
+        </p:style>
+        <p:txBody>
+          <a:bodyPr rtlCol="0" anchor="ctr" wrap="square" lIns="19050" rIns="19050" tIns="19050" bIns="19050"/>
+          <a:lstStyle/>
+          <a:p>
+            <a:pPr algn="ctr">
+              <a:lnSpc>
+                <a:spcPct val="122000"/>
+              </a:lnSpc>
+            </a:pPr>
+            <a:r>
+              <a:rPr sz="1300" b="1">
+                <a:solidFill>
+                  <a:srgbClr val="F5F5F8"/>
+                </a:solidFill>
+                <a:latin typeface="Amazon Ember"/>
+                <a:ea typeface="メイリオ"/>
+                <a:cs typeface="メイリオ"/>
+              </a:rPr>
+              <a:t>request B</a:t>
+            </a:r>
+          </a:p>
+        </p:txBody>
+      </p:sp>
+      <p:sp>
+        <p:nvSpPr>
+          <p:cNvPr id="64" name="Rounded Rectangle 63"/>
+          <p:cNvSpPr/>
+          <p:nvPr/>
+        </p:nvSpPr>
+        <p:spPr>
+          <a:xfrm>
+            <a:off x="10220325" y="2038350"/>
+            <a:ext cx="1371600" cy="342900"/>
+          </a:xfrm>
+          <a:prstGeom prst="roundRect">
+            <a:avLst>
+              <a:gd name="adj" fmla="val 10000"/>
+            </a:avLst>
+          </a:prstGeom>
+          <a:solidFill>
+            <a:srgbClr val="161A1E"/>
+          </a:solidFill>
+          <a:ln w="15875">
+            <a:solidFill>
+              <a:srgbClr val="464A50"/>
+            </a:solidFill>
+          </a:ln>
+          <a:effectLst/>
+        </p:spPr>
+        <p:style>
+          <a:lnRef idx="1">
+            <a:schemeClr val="accent1"/>
+          </a:lnRef>
+          <a:fillRef idx="3">
+            <a:schemeClr val="accent1"/>
+          </a:fillRef>
+          <a:effectRef idx="2">
+            <a:schemeClr val="accent1"/>
+          </a:effectRef>
+          <a:fontRef idx="minor">
+            <a:schemeClr val="lt1"/>
+          </a:fontRef>
+        </p:style>
+        <p:txBody>
+          <a:bodyPr rtlCol="0" anchor="ctr" wrap="square" lIns="19050" rIns="19050" tIns="19050" bIns="19050"/>
+          <a:lstStyle/>
+          <a:p>
+            <a:pPr algn="ctr">
+              <a:lnSpc>
+                <a:spcPct val="122000"/>
+              </a:lnSpc>
+            </a:pPr>
+            <a:r>
+              <a:rPr sz="1200" b="1">
+                <a:solidFill>
+                  <a:srgbClr val="96969E"/>
+                </a:solidFill>
+                <a:latin typeface="Amazon Ember"/>
+                <a:ea typeface="メイリオ"/>
+                <a:cs typeface="メイリオ"/>
+              </a:rPr>
+              <a:t>owner: block 41</a:t>
+            </a:r>
+          </a:p>
+        </p:txBody>
+      </p:sp>
+      <p:sp>
+        <p:nvSpPr>
+          <p:cNvPr id="65" name="Rounded Rectangle 64"/>
+          <p:cNvSpPr/>
+          <p:nvPr/>
+        </p:nvSpPr>
+        <p:spPr>
+          <a:xfrm>
+            <a:off x="7553325" y="2438400"/>
+            <a:ext cx="952500" cy="342900"/>
+          </a:xfrm>
+          <a:prstGeom prst="roundRect">
+            <a:avLst>
+              <a:gd name="adj" fmla="val 10000"/>
+            </a:avLst>
+          </a:prstGeom>
+          <a:solidFill>
+            <a:srgbClr val="161A1E"/>
+          </a:solidFill>
+          <a:ln w="15875">
+            <a:solidFill>
+              <a:srgbClr val="464A50"/>
+            </a:solidFill>
+          </a:ln>
+          <a:effectLst/>
+        </p:spPr>
+        <p:style>
+          <a:lnRef idx="1">
+            <a:schemeClr val="accent1"/>
+          </a:lnRef>
+          <a:fillRef idx="3">
+            <a:schemeClr val="accent1"/>
+          </a:fillRef>
+          <a:effectRef idx="2">
+            <a:schemeClr val="accent1"/>
+          </a:effectRef>
+          <a:fontRef idx="minor">
+            <a:schemeClr val="lt1"/>
+          </a:fontRef>
+        </p:style>
+        <p:txBody>
+          <a:bodyPr rtlCol="0" anchor="ctr" wrap="square" lIns="19050" rIns="19050" tIns="19050" bIns="19050"/>
+          <a:lstStyle/>
+          <a:p>
+            <a:pPr algn="ctr">
+              <a:lnSpc>
+                <a:spcPct val="122000"/>
+              </a:lnSpc>
+            </a:pPr>
+            <a:r>
+              <a:rPr sz="1300" b="1">
+                <a:solidFill>
+                  <a:srgbClr val="F5F5F8"/>
+                </a:solidFill>
+                <a:latin typeface="Amazon Ember"/>
+                <a:ea typeface="メイリオ"/>
+                <a:cs typeface="メイリオ"/>
+              </a:rPr>
+              <a:t>...</a:t>
+            </a:r>
+          </a:p>
+        </p:txBody>
+      </p:sp>
+      <p:sp>
+        <p:nvSpPr>
+          <p:cNvPr id="66" name="Rounded Rectangle 65"/>
+          <p:cNvSpPr/>
+          <p:nvPr/>
+        </p:nvSpPr>
+        <p:spPr>
+          <a:xfrm>
+            <a:off x="8601075" y="2438400"/>
+            <a:ext cx="1524000" cy="342900"/>
+          </a:xfrm>
+          <a:prstGeom prst="roundRect">
+            <a:avLst>
+              <a:gd name="adj" fmla="val 10000"/>
+            </a:avLst>
+          </a:prstGeom>
+          <a:solidFill>
+            <a:srgbClr val="161A1E"/>
+          </a:solidFill>
+          <a:ln w="15875">
+            <a:solidFill>
+              <a:srgbClr val="464A50"/>
+            </a:solidFill>
+          </a:ln>
+          <a:effectLst/>
+        </p:spPr>
+        <p:style>
+          <a:lnRef idx="1">
+            <a:schemeClr val="accent1"/>
+          </a:lnRef>
+          <a:fillRef idx="3">
+            <a:schemeClr val="accent1"/>
+          </a:fillRef>
+          <a:effectRef idx="2">
+            <a:schemeClr val="accent1"/>
+          </a:effectRef>
+          <a:fontRef idx="minor">
+            <a:schemeClr val="lt1"/>
+          </a:fontRef>
+        </p:style>
+        <p:txBody>
+          <a:bodyPr rtlCol="0" anchor="ctr" wrap="square" lIns="19050" rIns="19050" tIns="19050" bIns="19050"/>
+          <a:lstStyle/>
+          <a:p>
+            <a:pPr algn="ctr">
+              <a:lnSpc>
+                <a:spcPct val="122000"/>
+              </a:lnSpc>
+            </a:pPr>
+            <a:r>
+              <a:rPr sz="1300" b="1">
+                <a:solidFill>
+                  <a:srgbClr val="F5F5F8"/>
+                </a:solidFill>
+                <a:latin typeface="Amazon Ember"/>
+                <a:ea typeface="メイリオ"/>
+                <a:cs typeface="メイリオ"/>
+              </a:rPr>
+              <a:t>free</a:t>
+            </a:r>
+          </a:p>
+        </p:txBody>
+      </p:sp>
+      <p:sp>
+        <p:nvSpPr>
+          <p:cNvPr id="67" name="Rounded Rectangle 66"/>
+          <p:cNvSpPr/>
+          <p:nvPr/>
+        </p:nvSpPr>
+        <p:spPr>
+          <a:xfrm>
+            <a:off x="10220325" y="2438400"/>
+            <a:ext cx="1371600" cy="342900"/>
+          </a:xfrm>
+          <a:prstGeom prst="roundRect">
+            <a:avLst>
+              <a:gd name="adj" fmla="val 10000"/>
+            </a:avLst>
+          </a:prstGeom>
+          <a:solidFill>
+            <a:srgbClr val="161A1E"/>
+          </a:solidFill>
+          <a:ln w="15875">
+            <a:solidFill>
+              <a:srgbClr val="464A50"/>
+            </a:solidFill>
+          </a:ln>
+          <a:effectLst/>
+        </p:spPr>
+        <p:style>
+          <a:lnRef idx="1">
+            <a:schemeClr val="accent1"/>
+          </a:lnRef>
+          <a:fillRef idx="3">
+            <a:schemeClr val="accent1"/>
+          </a:fillRef>
+          <a:effectRef idx="2">
+            <a:schemeClr val="accent1"/>
+          </a:effectRef>
+          <a:fontRef idx="minor">
+            <a:schemeClr val="lt1"/>
+          </a:fontRef>
+        </p:style>
+        <p:txBody>
+          <a:bodyPr rtlCol="0" anchor="ctr"/>
+          <a:lstStyle/>
+          <a:p>
+            <a:pPr algn="ctr"/>
+          </a:p>
+        </p:txBody>
+      </p:sp>
+      <p:sp>
+        <p:nvSpPr>
+          <p:cNvPr id="68" name="Rounded Rectangle 67"/>
+          <p:cNvSpPr/>
+          <p:nvPr/>
+        </p:nvSpPr>
+        <p:spPr>
+          <a:xfrm>
+            <a:off x="7553325" y="2838450"/>
+            <a:ext cx="952500" cy="342900"/>
+          </a:xfrm>
+          <a:prstGeom prst="roundRect">
+            <a:avLst>
+              <a:gd name="adj" fmla="val 10000"/>
+            </a:avLst>
+          </a:prstGeom>
+          <a:solidFill>
+            <a:srgbClr val="161A1E"/>
+          </a:solidFill>
+          <a:ln w="15875">
+            <a:solidFill>
+              <a:srgbClr val="464A50"/>
+            </a:solidFill>
+          </a:ln>
+          <a:effectLst/>
+        </p:spPr>
+        <p:style>
+          <a:lnRef idx="1">
+            <a:schemeClr val="accent1"/>
+          </a:lnRef>
+          <a:fillRef idx="3">
+            <a:schemeClr val="accent1"/>
+          </a:fillRef>
+          <a:effectRef idx="2">
+            <a:schemeClr val="accent1"/>
+          </a:effectRef>
+          <a:fontRef idx="minor">
+            <a:schemeClr val="lt1"/>
+          </a:fontRef>
+        </p:style>
+        <p:txBody>
+          <a:bodyPr rtlCol="0" anchor="ctr" wrap="square" lIns="19050" rIns="19050" tIns="19050" bIns="19050"/>
+          <a:lstStyle/>
+          <a:p>
+            <a:pPr algn="ctr">
+              <a:lnSpc>
+                <a:spcPct val="122000"/>
+              </a:lnSpc>
+            </a:pPr>
+            <a:r>
+              <a:rPr sz="1300" b="1">
+                <a:solidFill>
+                  <a:srgbClr val="F5F5F8"/>
+                </a:solidFill>
+                <a:latin typeface="Amazon Ember"/>
+                <a:ea typeface="メイリオ"/>
+                <a:cs typeface="メイリオ"/>
+              </a:rPr>
+              <a:t>last</a:t>
+            </a:r>
+          </a:p>
+        </p:txBody>
+      </p:sp>
+      <p:sp>
+        <p:nvSpPr>
+          <p:cNvPr id="69" name="Rounded Rectangle 68"/>
+          <p:cNvSpPr/>
+          <p:nvPr/>
+        </p:nvSpPr>
+        <p:spPr>
+          <a:xfrm>
+            <a:off x="8601075" y="2838450"/>
+            <a:ext cx="1524000" cy="342900"/>
+          </a:xfrm>
+          <a:prstGeom prst="roundRect">
+            <a:avLst>
+              <a:gd name="adj" fmla="val 10000"/>
+            </a:avLst>
+          </a:prstGeom>
+          <a:solidFill>
+            <a:srgbClr val="161A1E"/>
+          </a:solidFill>
+          <a:ln w="15875">
+            <a:solidFill>
+              <a:srgbClr val="464A50"/>
+            </a:solidFill>
+          </a:ln>
+          <a:effectLst/>
+        </p:spPr>
+        <p:style>
+          <a:lnRef idx="1">
+            <a:schemeClr val="accent1"/>
+          </a:lnRef>
+          <a:fillRef idx="3">
+            <a:schemeClr val="accent1"/>
+          </a:fillRef>
+          <a:effectRef idx="2">
+            <a:schemeClr val="accent1"/>
+          </a:effectRef>
+          <a:fontRef idx="minor">
+            <a:schemeClr val="lt1"/>
+          </a:fontRef>
+        </p:style>
+        <p:txBody>
+          <a:bodyPr rtlCol="0" anchor="ctr" wrap="square" lIns="19050" rIns="19050" tIns="19050" bIns="19050"/>
+          <a:lstStyle/>
+          <a:p>
+            <a:pPr algn="ctr">
+              <a:lnSpc>
+                <a:spcPct val="122000"/>
+              </a:lnSpc>
+            </a:pPr>
+            <a:r>
+              <a:rPr sz="1300" b="1">
+                <a:solidFill>
+                  <a:srgbClr val="F5F5F8"/>
+                </a:solidFill>
+                <a:latin typeface="Amazon Ember"/>
+                <a:ea typeface="メイリオ"/>
+                <a:cs typeface="メイリオ"/>
+              </a:rPr>
+              <a:t>scratch</a:t>
+            </a:r>
+          </a:p>
+        </p:txBody>
+      </p:sp>
+      <p:sp>
+        <p:nvSpPr>
+          <p:cNvPr id="70" name="Rounded Rectangle 69"/>
+          <p:cNvSpPr/>
+          <p:nvPr/>
+        </p:nvSpPr>
+        <p:spPr>
+          <a:xfrm>
+            <a:off x="10220325" y="2838450"/>
+            <a:ext cx="1371600" cy="342900"/>
+          </a:xfrm>
+          <a:prstGeom prst="roundRect">
+            <a:avLst>
+              <a:gd name="adj" fmla="val 10000"/>
+            </a:avLst>
+          </a:prstGeom>
+          <a:solidFill>
+            <a:srgbClr val="161A1E"/>
+          </a:solidFill>
+          <a:ln w="15875">
+            <a:solidFill>
+              <a:srgbClr val="464A50"/>
+            </a:solidFill>
+          </a:ln>
+          <a:effectLst/>
+        </p:spPr>
+        <p:style>
+          <a:lnRef idx="1">
+            <a:schemeClr val="accent1"/>
+          </a:lnRef>
+          <a:fillRef idx="3">
+            <a:schemeClr val="accent1"/>
+          </a:fillRef>
+          <a:effectRef idx="2">
+            <a:schemeClr val="accent1"/>
+          </a:effectRef>
+          <a:fontRef idx="minor">
+            <a:schemeClr val="lt1"/>
+          </a:fontRef>
+        </p:style>
+        <p:txBody>
+          <a:bodyPr rtlCol="0" anchor="ctr"/>
+          <a:lstStyle/>
+          <a:p>
+            <a:pPr algn="ctr"/>
+          </a:p>
+        </p:txBody>
+      </p:sp>
+      <p:sp>
+        <p:nvSpPr>
+          <p:cNvPr id="71" name="TextBox 70"/>
+          <p:cNvSpPr txBox="1"/>
+          <p:nvPr/>
+        </p:nvSpPr>
+        <p:spPr>
+          <a:xfrm>
+            <a:off x="7553325" y="3276600"/>
+            <a:ext cx="4229100" cy="628650"/>
+          </a:xfrm>
+          <a:prstGeom prst="rect">
+            <a:avLst/>
+          </a:prstGeom>
+          <a:noFill/>
+        </p:spPr>
+        <p:txBody>
+          <a:bodyPr wrap="square" lIns="0" rIns="0" tIns="0" bIns="0" anchor="ctr">
+            <a:spAutoFit/>
+          </a:bodyPr>
+          <a:lstStyle/>
+          <a:p>
+            <a:pPr algn="l">
+              <a:lnSpc>
+                <a:spcPct val="122000"/>
+              </a:lnSpc>
+            </a:pPr>
+            <a:r>
+              <a:rPr sz="1300" b="0">
+                <a:solidFill>
+                  <a:srgbClr val="F5F5F8"/>
+                </a:solidFill>
+                <a:latin typeface="Amazon Ember"/>
+                <a:ea typeface="メイリオ"/>
+                <a:cs typeface="メイリオ"/>
+              </a:rPr>
+              <a:t>one row per request in each of the 23 layers:</a:t>
+            </a:r>
+          </a:p>
+          <a:p>
+            <a:pPr algn="l">
+              <a:lnSpc>
+                <a:spcPct val="122000"/>
+              </a:lnSpc>
+            </a:pPr>
+            <a:r>
+              <a:rPr sz="1300" b="0">
+                <a:solidFill>
+                  <a:srgbClr val="F5F5F8"/>
+                </a:solidFill>
+                <a:latin typeface="Amazon Ember"/>
+                <a:ea typeface="メイリオ"/>
+                <a:cs typeface="メイリオ"/>
+              </a:rPr>
+              <a:t>SSM state 16 x 64 x 128 + last 3 conv inputs</a:t>
+            </a:r>
+          </a:p>
+          <a:p>
+            <a:pPr algn="l">
+              <a:lnSpc>
+                <a:spcPct val="122000"/>
+              </a:lnSpc>
+            </a:pPr>
+            <a:r>
+              <a:rPr sz="1300" b="0">
+                <a:solidFill>
+                  <a:srgbClr val="F5F5F8"/>
+                </a:solidFill>
+                <a:latin typeface="Amazon Ember"/>
+                <a:ea typeface="メイリオ"/>
+                <a:cs typeface="メイリオ"/>
+              </a:rPr>
+              <a:t>about 200 MB in all for N = 8</a:t>
+            </a:r>
+          </a:p>
+        </p:txBody>
+      </p:sp>
+      <p:sp>
+        <p:nvSpPr>
+          <p:cNvPr id="72" name="Rounded Rectangle 71"/>
+          <p:cNvSpPr/>
+          <p:nvPr/>
+        </p:nvSpPr>
+        <p:spPr>
+          <a:xfrm>
+            <a:off x="409575" y="4305300"/>
+            <a:ext cx="5572125" cy="1162050"/>
+          </a:xfrm>
+          <a:prstGeom prst="roundRect">
+            <a:avLst>
+              <a:gd name="adj" fmla="val 8000"/>
+            </a:avLst>
+          </a:prstGeom>
+          <a:solidFill>
+            <a:srgbClr val="102C48"/>
+          </a:solidFill>
+          <a:ln w="15875">
+            <a:solidFill>
+              <a:srgbClr val="2896F0"/>
+            </a:solidFill>
+          </a:ln>
+          <a:effectLst/>
+        </p:spPr>
+        <p:style>
+          <a:lnRef idx="1">
+            <a:schemeClr val="accent1"/>
+          </a:lnRef>
+          <a:fillRef idx="3">
+            <a:schemeClr val="accent1"/>
+          </a:fillRef>
+          <a:effectRef idx="2">
+            <a:schemeClr val="accent1"/>
+          </a:effectRef>
+          <a:fontRef idx="minor">
+            <a:schemeClr val="lt1"/>
+          </a:fontRef>
+        </p:style>
+        <p:txBody>
+          <a:bodyPr rtlCol="0" anchor="ctr" wrap="square" lIns="19050" rIns="19050" tIns="19050" bIns="19050"/>
+          <a:lstStyle/>
+          <a:p>
+            <a:pPr algn="ctr">
+              <a:lnSpc>
+                <a:spcPct val="122000"/>
+              </a:lnSpc>
+            </a:pPr>
+            <a:r>
+              <a:rPr sz="1400" b="1">
+                <a:solidFill>
+                  <a:srgbClr val="F5F5F8"/>
+                </a:solidFill>
+                <a:latin typeface="Amazon Ember"/>
+                <a:ea typeface="メイリオ"/>
+                <a:cs typeface="メイリオ"/>
+              </a:rPr>
+              <a:t>KV grows with every token, so it is paged in blocks.</a:t>
+            </a:r>
+          </a:p>
+          <a:p>
+            <a:pPr algn="ctr">
+              <a:lnSpc>
+                <a:spcPct val="122000"/>
+              </a:lnSpc>
+            </a:pPr>
+            <a:r>
+              <a:rPr sz="1400" b="1">
+                <a:solidFill>
+                  <a:srgbClr val="F5F5F8"/>
+                </a:solidFill>
+                <a:latin typeface="Amazon Ember"/>
+                <a:ea typeface="メイリオ"/>
+                <a:cs typeface="メイリオ"/>
+              </a:rPr>
+              <a:t>vLLM decides which blocks a request gets,</a:t>
+            </a:r>
+          </a:p>
+          <a:p>
+            <a:pPr algn="ctr">
+              <a:lnSpc>
+                <a:spcPct val="122000"/>
+              </a:lnSpc>
+            </a:pPr>
+            <a:r>
+              <a:rPr sz="1400" b="1">
+                <a:solidFill>
+                  <a:srgbClr val="F5F5F8"/>
+                </a:solidFill>
+                <a:latin typeface="Amazon Ember"/>
+                <a:ea typeface="メイリオ"/>
+                <a:cs typeface="メイリオ"/>
+              </a:rPr>
+              <a:t>the plugin allocates them, your model writes</a:t>
+            </a:r>
+          </a:p>
+          <a:p>
+            <a:pPr algn="ctr">
+              <a:lnSpc>
+                <a:spcPct val="122000"/>
+              </a:lnSpc>
+            </a:pPr>
+            <a:r>
+              <a:rPr sz="1400" b="1">
+                <a:solidFill>
+                  <a:srgbClr val="F5F5F8"/>
+                </a:solidFill>
+                <a:latin typeface="Amazon Ember"/>
+                <a:ea typeface="メイリオ"/>
+                <a:cs typeface="メイリオ"/>
+              </a:rPr>
+              <a:t>each token to its slot</a:t>
+            </a:r>
+          </a:p>
+        </p:txBody>
+      </p:sp>
+      <p:sp>
+        <p:nvSpPr>
+          <p:cNvPr id="73" name="Rounded Rectangle 72"/>
+          <p:cNvSpPr/>
+          <p:nvPr/>
+        </p:nvSpPr>
+        <p:spPr>
+          <a:xfrm>
+            <a:off x="6210300" y="4305300"/>
+            <a:ext cx="5572125" cy="1162050"/>
+          </a:xfrm>
+          <a:prstGeom prst="roundRect">
+            <a:avLst>
+              <a:gd name="adj" fmla="val 8000"/>
+            </a:avLst>
+          </a:prstGeom>
+          <a:solidFill>
+            <a:srgbClr val="124022"/>
+          </a:solidFill>
+          <a:ln w="15875">
+            <a:solidFill>
+              <a:srgbClr val="24A046"/>
+            </a:solidFill>
+          </a:ln>
+          <a:effectLst/>
+        </p:spPr>
+        <p:style>
+          <a:lnRef idx="1">
+            <a:schemeClr val="accent1"/>
+          </a:lnRef>
+          <a:fillRef idx="3">
+            <a:schemeClr val="accent1"/>
+          </a:fillRef>
+          <a:effectRef idx="2">
+            <a:schemeClr val="accent1"/>
+          </a:effectRef>
+          <a:fontRef idx="minor">
+            <a:schemeClr val="lt1"/>
+          </a:fontRef>
+        </p:style>
+        <p:txBody>
+          <a:bodyPr rtlCol="0" anchor="ctr" wrap="square" lIns="19050" rIns="19050" tIns="19050" bIns="19050"/>
+          <a:lstStyle/>
+          <a:p>
+            <a:pPr algn="ctr">
+              <a:lnSpc>
+                <a:spcPct val="122000"/>
+              </a:lnSpc>
+            </a:pPr>
+            <a:r>
+              <a:rPr sz="1400" b="1">
+                <a:solidFill>
+                  <a:srgbClr val="F5F5F8"/>
+                </a:solidFill>
+                <a:latin typeface="Amazon Ember"/>
+                <a:ea typeface="メイリオ"/>
+                <a:cs typeface="メイリオ"/>
+              </a:rPr>
+              <a:t>Mamba state has a fixed size per request, so it is not</a:t>
+            </a:r>
+          </a:p>
+          <a:p>
+            <a:pPr algn="ctr">
+              <a:lnSpc>
+                <a:spcPct val="122000"/>
+              </a:lnSpc>
+            </a:pPr>
+            <a:r>
+              <a:rPr sz="1400" b="1">
+                <a:solidFill>
+                  <a:srgbClr val="F5F5F8"/>
+                </a:solidFill>
+                <a:latin typeface="Amazon Ember"/>
+                <a:ea typeface="メイリオ"/>
+                <a:cs typeface="メイリオ"/>
+              </a:rPr>
+              <a:t>made of blocks and the plugin does not know about it.</a:t>
+            </a:r>
+          </a:p>
+          <a:p>
+            <a:pPr algn="ctr">
+              <a:lnSpc>
+                <a:spcPct val="122000"/>
+              </a:lnSpc>
+            </a:pPr>
+            <a:r>
+              <a:rPr sz="1400" b="1">
+                <a:solidFill>
+                  <a:srgbClr val="F5F5F8"/>
+                </a:solidFill>
+                <a:latin typeface="Amazon Ember"/>
+                <a:ea typeface="メイリオ"/>
+                <a:cs typeface="メイリオ"/>
+              </a:rPr>
+              <a:t>Your model keeps it in its own buffers, finds the row by</a:t>
+            </a:r>
+          </a:p>
+          <a:p>
+            <a:pPr algn="ctr">
+              <a:lnSpc>
+                <a:spcPct val="122000"/>
+              </a:lnSpc>
+            </a:pPr>
+            <a:r>
+              <a:rPr sz="1400" b="1">
+                <a:solidFill>
+                  <a:srgbClr val="F5F5F8"/>
+                </a:solidFill>
+                <a:latin typeface="Amazon Ember"/>
+                <a:ea typeface="メイリオ"/>
+                <a:cs typeface="メイリオ"/>
+              </a:rPr>
+              <a:t>the request's first block, and overwrites it every step</a:t>
             </a:r>
           </a:p>
         </p:txBody>

</xml_diff>

<commit_message>
articles: NemotronH on vLLM Neuron plugin: chunked SSD explained with the values in the matrix
</commit_message>
<xml_diff>
--- a/diagrams/articles/162e5225ba1c9b-figures.pptx
+++ b/diagrams/articles/162e5225ba1c9b-figures.pptx
@@ -26,6 +26,7 @@
     <p:sldId id="268" r:id="rId21"/>
     <p:sldId id="269" r:id="rId22"/>
     <p:sldId id="270" r:id="rId23"/>
+    <p:sldId id="271" r:id="rId24"/>
   </p:sldIdLst>
   <p:sldSz cx="12192000" cy="6858000"/>
   <p:notesSz cx="6858000" cy="9144000"/>
@@ -19313,6 +19314,3488 @@
                 <a:cs typeface="メイリオ"/>
               </a:rPr>
               <a:t>each round is a max, a compare and a subtract over all experts: the same work for every token, so it compiles</a:t>
+            </a:r>
+          </a:p>
+        </p:txBody>
+      </p:sp>
+    </p:spTree>
+  </p:cSld>
+  <p:clrMapOvr>
+    <a:masterClrMapping/>
+  </p:clrMapOvr>
+</p:sld>
+</file>
+
+<file path=ppt/slides/slide16.xml><?xml version="1.0" encoding="utf-8"?>
+<p:sld xmlns:a="http://schemas.openxmlformats.org/drawingml/2006/main" xmlns:p="http://schemas.openxmlformats.org/presentationml/2006/main" xmlns:r="http://schemas.openxmlformats.org/officeDocument/2006/relationships" showMasterSp="0">
+  <p:cSld>
+    <p:spTree>
+      <p:nvGrpSpPr>
+        <p:cNvPr id="1" name=""/>
+        <p:cNvGrpSpPr/>
+        <p:nvPr/>
+      </p:nvGrpSpPr>
+      <p:grpSpPr/>
+      <p:sp>
+        <p:nvSpPr>
+          <p:cNvPr id="2" name="TextBox 1"/>
+          <p:cNvSpPr txBox="1"/>
+          <p:nvPr/>
+        </p:nvSpPr>
+        <p:spPr>
+          <a:xfrm>
+            <a:off x="409575" y="247650"/>
+            <a:ext cx="11334750" cy="438150"/>
+          </a:xfrm>
+          <a:prstGeom prst="rect">
+            <a:avLst/>
+          </a:prstGeom>
+          <a:noFill/>
+        </p:spPr>
+        <p:txBody>
+          <a:bodyPr wrap="square" lIns="0" rIns="0" tIns="0" bIns="0" anchor="ctr">
+            <a:spAutoFit/>
+          </a:bodyPr>
+          <a:lstStyle/>
+          <a:p>
+            <a:pPr algn="l">
+              <a:lnSpc>
+                <a:spcPct val="122000"/>
+              </a:lnSpc>
+            </a:pPr>
+            <a:r>
+              <a:rPr sz="3000" b="1">
+                <a:solidFill>
+                  <a:srgbClr val="F5F5F8"/>
+                </a:solidFill>
+                <a:latin typeface="Amazon Ember"/>
+                <a:ea typeface="メイリオ"/>
+                <a:cs typeface="メイリオ"/>
+              </a:rPr>
+              <a:t>What the big matrix holds, and what chunks skip</a:t>
+            </a:r>
+          </a:p>
+        </p:txBody>
+      </p:sp>
+      <p:sp>
+        <p:nvSpPr>
+          <p:cNvPr id="3" name="TextBox 2"/>
+          <p:cNvSpPr txBox="1"/>
+          <p:nvPr/>
+        </p:nvSpPr>
+        <p:spPr>
+          <a:xfrm>
+            <a:off x="409575" y="685800"/>
+            <a:ext cx="11334750" cy="247650"/>
+          </a:xfrm>
+          <a:prstGeom prst="rect">
+            <a:avLst/>
+          </a:prstGeom>
+          <a:noFill/>
+        </p:spPr>
+        <p:txBody>
+          <a:bodyPr wrap="square" lIns="0" rIns="0" tIns="0" bIns="0" anchor="ctr">
+            <a:spAutoFit/>
+          </a:bodyPr>
+          <a:lstStyle/>
+          <a:p>
+            <a:pPr algn="l">
+              <a:lnSpc>
+                <a:spcPct val="122000"/>
+              </a:lnSpc>
+            </a:pPr>
+            <a:r>
+              <a:rPr sz="1600" b="0">
+                <a:solidFill>
+                  <a:srgbClr val="96969E"/>
+                </a:solidFill>
+                <a:latin typeface="Amazon Ember"/>
+                <a:ea typeface="メイリオ"/>
+                <a:cs typeface="メイリオ"/>
+              </a:rPr>
+              <a:t>Toy scan: h_t = a_t h_(t-1) + b_t x_t,  y_t = c_t h_t.  6 tokens, chunks of 3.  y = M . x</a:t>
+            </a:r>
+          </a:p>
+        </p:txBody>
+      </p:sp>
+      <p:sp>
+        <p:nvSpPr>
+          <p:cNvPr id="4" name="TextBox 3"/>
+          <p:cNvSpPr txBox="1"/>
+          <p:nvPr/>
+        </p:nvSpPr>
+        <p:spPr>
+          <a:xfrm>
+            <a:off x="981075" y="1314450"/>
+            <a:ext cx="895350" cy="266700"/>
+          </a:xfrm>
+          <a:prstGeom prst="rect">
+            <a:avLst/>
+          </a:prstGeom>
+          <a:noFill/>
+        </p:spPr>
+        <p:txBody>
+          <a:bodyPr wrap="square" lIns="0" rIns="0" tIns="0" bIns="0" anchor="ctr">
+            <a:spAutoFit/>
+          </a:bodyPr>
+          <a:lstStyle/>
+          <a:p>
+            <a:pPr algn="ctr">
+              <a:lnSpc>
+                <a:spcPct val="122000"/>
+              </a:lnSpc>
+            </a:pPr>
+            <a:r>
+              <a:rPr sz="1400" b="0">
+                <a:solidFill>
+                  <a:srgbClr val="96969E"/>
+                </a:solidFill>
+                <a:latin typeface="Amazon Ember"/>
+                <a:ea typeface="メイリオ"/>
+                <a:cs typeface="メイリオ"/>
+              </a:rPr>
+              <a:t>x1</a:t>
+            </a:r>
+          </a:p>
+        </p:txBody>
+      </p:sp>
+      <p:sp>
+        <p:nvSpPr>
+          <p:cNvPr id="5" name="TextBox 4"/>
+          <p:cNvSpPr txBox="1"/>
+          <p:nvPr/>
+        </p:nvSpPr>
+        <p:spPr>
+          <a:xfrm>
+            <a:off x="1876425" y="1314450"/>
+            <a:ext cx="895350" cy="266700"/>
+          </a:xfrm>
+          <a:prstGeom prst="rect">
+            <a:avLst/>
+          </a:prstGeom>
+          <a:noFill/>
+        </p:spPr>
+        <p:txBody>
+          <a:bodyPr wrap="square" lIns="0" rIns="0" tIns="0" bIns="0" anchor="ctr">
+            <a:spAutoFit/>
+          </a:bodyPr>
+          <a:lstStyle/>
+          <a:p>
+            <a:pPr algn="ctr">
+              <a:lnSpc>
+                <a:spcPct val="122000"/>
+              </a:lnSpc>
+            </a:pPr>
+            <a:r>
+              <a:rPr sz="1400" b="0">
+                <a:solidFill>
+                  <a:srgbClr val="96969E"/>
+                </a:solidFill>
+                <a:latin typeface="Amazon Ember"/>
+                <a:ea typeface="メイリオ"/>
+                <a:cs typeface="メイリオ"/>
+              </a:rPr>
+              <a:t>x2</a:t>
+            </a:r>
+          </a:p>
+        </p:txBody>
+      </p:sp>
+      <p:sp>
+        <p:nvSpPr>
+          <p:cNvPr id="6" name="TextBox 5"/>
+          <p:cNvSpPr txBox="1"/>
+          <p:nvPr/>
+        </p:nvSpPr>
+        <p:spPr>
+          <a:xfrm>
+            <a:off x="2771775" y="1314450"/>
+            <a:ext cx="895350" cy="266700"/>
+          </a:xfrm>
+          <a:prstGeom prst="rect">
+            <a:avLst/>
+          </a:prstGeom>
+          <a:noFill/>
+        </p:spPr>
+        <p:txBody>
+          <a:bodyPr wrap="square" lIns="0" rIns="0" tIns="0" bIns="0" anchor="ctr">
+            <a:spAutoFit/>
+          </a:bodyPr>
+          <a:lstStyle/>
+          <a:p>
+            <a:pPr algn="ctr">
+              <a:lnSpc>
+                <a:spcPct val="122000"/>
+              </a:lnSpc>
+            </a:pPr>
+            <a:r>
+              <a:rPr sz="1400" b="0">
+                <a:solidFill>
+                  <a:srgbClr val="96969E"/>
+                </a:solidFill>
+                <a:latin typeface="Amazon Ember"/>
+                <a:ea typeface="メイリオ"/>
+                <a:cs typeface="メイリオ"/>
+              </a:rPr>
+              <a:t>x3</a:t>
+            </a:r>
+          </a:p>
+        </p:txBody>
+      </p:sp>
+      <p:sp>
+        <p:nvSpPr>
+          <p:cNvPr id="7" name="TextBox 6"/>
+          <p:cNvSpPr txBox="1"/>
+          <p:nvPr/>
+        </p:nvSpPr>
+        <p:spPr>
+          <a:xfrm>
+            <a:off x="3667125" y="1314450"/>
+            <a:ext cx="895350" cy="266700"/>
+          </a:xfrm>
+          <a:prstGeom prst="rect">
+            <a:avLst/>
+          </a:prstGeom>
+          <a:noFill/>
+        </p:spPr>
+        <p:txBody>
+          <a:bodyPr wrap="square" lIns="0" rIns="0" tIns="0" bIns="0" anchor="ctr">
+            <a:spAutoFit/>
+          </a:bodyPr>
+          <a:lstStyle/>
+          <a:p>
+            <a:pPr algn="ctr">
+              <a:lnSpc>
+                <a:spcPct val="122000"/>
+              </a:lnSpc>
+            </a:pPr>
+            <a:r>
+              <a:rPr sz="1400" b="0">
+                <a:solidFill>
+                  <a:srgbClr val="96969E"/>
+                </a:solidFill>
+                <a:latin typeface="Amazon Ember"/>
+                <a:ea typeface="メイリオ"/>
+                <a:cs typeface="メイリオ"/>
+              </a:rPr>
+              <a:t>x4</a:t>
+            </a:r>
+          </a:p>
+        </p:txBody>
+      </p:sp>
+      <p:sp>
+        <p:nvSpPr>
+          <p:cNvPr id="8" name="TextBox 7"/>
+          <p:cNvSpPr txBox="1"/>
+          <p:nvPr/>
+        </p:nvSpPr>
+        <p:spPr>
+          <a:xfrm>
+            <a:off x="4562475" y="1314450"/>
+            <a:ext cx="895350" cy="266700"/>
+          </a:xfrm>
+          <a:prstGeom prst="rect">
+            <a:avLst/>
+          </a:prstGeom>
+          <a:noFill/>
+        </p:spPr>
+        <p:txBody>
+          <a:bodyPr wrap="square" lIns="0" rIns="0" tIns="0" bIns="0" anchor="ctr">
+            <a:spAutoFit/>
+          </a:bodyPr>
+          <a:lstStyle/>
+          <a:p>
+            <a:pPr algn="ctr">
+              <a:lnSpc>
+                <a:spcPct val="122000"/>
+              </a:lnSpc>
+            </a:pPr>
+            <a:r>
+              <a:rPr sz="1400" b="0">
+                <a:solidFill>
+                  <a:srgbClr val="96969E"/>
+                </a:solidFill>
+                <a:latin typeface="Amazon Ember"/>
+                <a:ea typeface="メイリオ"/>
+                <a:cs typeface="メイリオ"/>
+              </a:rPr>
+              <a:t>x5</a:t>
+            </a:r>
+          </a:p>
+        </p:txBody>
+      </p:sp>
+      <p:sp>
+        <p:nvSpPr>
+          <p:cNvPr id="9" name="TextBox 8"/>
+          <p:cNvSpPr txBox="1"/>
+          <p:nvPr/>
+        </p:nvSpPr>
+        <p:spPr>
+          <a:xfrm>
+            <a:off x="5457825" y="1314450"/>
+            <a:ext cx="895350" cy="266700"/>
+          </a:xfrm>
+          <a:prstGeom prst="rect">
+            <a:avLst/>
+          </a:prstGeom>
+          <a:noFill/>
+        </p:spPr>
+        <p:txBody>
+          <a:bodyPr wrap="square" lIns="0" rIns="0" tIns="0" bIns="0" anchor="ctr">
+            <a:spAutoFit/>
+          </a:bodyPr>
+          <a:lstStyle/>
+          <a:p>
+            <a:pPr algn="ctr">
+              <a:lnSpc>
+                <a:spcPct val="122000"/>
+              </a:lnSpc>
+            </a:pPr>
+            <a:r>
+              <a:rPr sz="1400" b="0">
+                <a:solidFill>
+                  <a:srgbClr val="96969E"/>
+                </a:solidFill>
+                <a:latin typeface="Amazon Ember"/>
+                <a:ea typeface="メイリオ"/>
+                <a:cs typeface="メイリオ"/>
+              </a:rPr>
+              <a:t>x6</a:t>
+            </a:r>
+          </a:p>
+        </p:txBody>
+      </p:sp>
+      <p:sp>
+        <p:nvSpPr>
+          <p:cNvPr id="10" name="TextBox 9"/>
+          <p:cNvSpPr txBox="1"/>
+          <p:nvPr/>
+        </p:nvSpPr>
+        <p:spPr>
+          <a:xfrm>
+            <a:off x="447675" y="1600200"/>
+            <a:ext cx="476250" cy="514350"/>
+          </a:xfrm>
+          <a:prstGeom prst="rect">
+            <a:avLst/>
+          </a:prstGeom>
+          <a:noFill/>
+        </p:spPr>
+        <p:txBody>
+          <a:bodyPr wrap="square" lIns="0" rIns="0" tIns="0" bIns="0" anchor="ctr">
+            <a:spAutoFit/>
+          </a:bodyPr>
+          <a:lstStyle/>
+          <a:p>
+            <a:pPr algn="r">
+              <a:lnSpc>
+                <a:spcPct val="122000"/>
+              </a:lnSpc>
+            </a:pPr>
+            <a:r>
+              <a:rPr sz="1400" b="0">
+                <a:solidFill>
+                  <a:srgbClr val="96969E"/>
+                </a:solidFill>
+                <a:latin typeface="Amazon Ember"/>
+                <a:ea typeface="メイリオ"/>
+                <a:cs typeface="メイリオ"/>
+              </a:rPr>
+              <a:t>y1</a:t>
+            </a:r>
+          </a:p>
+        </p:txBody>
+      </p:sp>
+      <p:sp>
+        <p:nvSpPr>
+          <p:cNvPr id="11" name="Rounded Rectangle 10"/>
+          <p:cNvSpPr/>
+          <p:nvPr/>
+        </p:nvSpPr>
+        <p:spPr>
+          <a:xfrm>
+            <a:off x="1000125" y="1619250"/>
+            <a:ext cx="857250" cy="476250"/>
+          </a:xfrm>
+          <a:prstGeom prst="roundRect">
+            <a:avLst>
+              <a:gd name="adj" fmla="val 8000"/>
+            </a:avLst>
+          </a:prstGeom>
+          <a:solidFill>
+            <a:srgbClr val="124022"/>
+          </a:solidFill>
+          <a:ln w="15875">
+            <a:solidFill>
+              <a:srgbClr val="24A046"/>
+            </a:solidFill>
+          </a:ln>
+          <a:effectLst/>
+        </p:spPr>
+        <p:style>
+          <a:lnRef idx="1">
+            <a:schemeClr val="accent1"/>
+          </a:lnRef>
+          <a:fillRef idx="3">
+            <a:schemeClr val="accent1"/>
+          </a:fillRef>
+          <a:effectRef idx="2">
+            <a:schemeClr val="accent1"/>
+          </a:effectRef>
+          <a:fontRef idx="minor">
+            <a:schemeClr val="lt1"/>
+          </a:fontRef>
+        </p:style>
+        <p:txBody>
+          <a:bodyPr rtlCol="0" anchor="ctr" wrap="square" lIns="19050" rIns="19050" tIns="19050" bIns="19050"/>
+          <a:lstStyle/>
+          <a:p>
+            <a:pPr algn="ctr">
+              <a:lnSpc>
+                <a:spcPct val="122000"/>
+              </a:lnSpc>
+            </a:pPr>
+            <a:r>
+              <a:rPr sz="1100" b="1">
+                <a:solidFill>
+                  <a:srgbClr val="F5F5F8"/>
+                </a:solidFill>
+                <a:latin typeface="Amazon Ember"/>
+                <a:ea typeface="メイリオ"/>
+                <a:cs typeface="メイリオ"/>
+              </a:rPr>
+              <a:t>c1b1</a:t>
+            </a:r>
+          </a:p>
+        </p:txBody>
+      </p:sp>
+      <p:sp>
+        <p:nvSpPr>
+          <p:cNvPr id="12" name="Rounded Rectangle 11"/>
+          <p:cNvSpPr/>
+          <p:nvPr/>
+        </p:nvSpPr>
+        <p:spPr>
+          <a:xfrm>
+            <a:off x="1895475" y="1619250"/>
+            <a:ext cx="857250" cy="476250"/>
+          </a:xfrm>
+          <a:prstGeom prst="roundRect">
+            <a:avLst>
+              <a:gd name="adj" fmla="val 8000"/>
+            </a:avLst>
+          </a:prstGeom>
+          <a:solidFill>
+            <a:srgbClr val="161A1E"/>
+          </a:solidFill>
+          <a:ln w="15875">
+            <a:solidFill>
+              <a:srgbClr val="464A50"/>
+            </a:solidFill>
+          </a:ln>
+          <a:effectLst/>
+        </p:spPr>
+        <p:style>
+          <a:lnRef idx="1">
+            <a:schemeClr val="accent1"/>
+          </a:lnRef>
+          <a:fillRef idx="3">
+            <a:schemeClr val="accent1"/>
+          </a:fillRef>
+          <a:effectRef idx="2">
+            <a:schemeClr val="accent1"/>
+          </a:effectRef>
+          <a:fontRef idx="minor">
+            <a:schemeClr val="lt1"/>
+          </a:fontRef>
+        </p:style>
+        <p:txBody>
+          <a:bodyPr rtlCol="0" anchor="ctr" wrap="square" lIns="19050" rIns="19050" tIns="19050" bIns="19050"/>
+          <a:lstStyle/>
+          <a:p>
+            <a:pPr algn="ctr">
+              <a:lnSpc>
+                <a:spcPct val="122000"/>
+              </a:lnSpc>
+            </a:pPr>
+            <a:r>
+              <a:rPr sz="1100" b="1">
+                <a:solidFill>
+                  <a:srgbClr val="96969E"/>
+                </a:solidFill>
+                <a:latin typeface="Amazon Ember"/>
+                <a:ea typeface="メイリオ"/>
+                <a:cs typeface="メイリオ"/>
+              </a:rPr>
+              <a:t>0</a:t>
+            </a:r>
+          </a:p>
+        </p:txBody>
+      </p:sp>
+      <p:sp>
+        <p:nvSpPr>
+          <p:cNvPr id="13" name="Rounded Rectangle 12"/>
+          <p:cNvSpPr/>
+          <p:nvPr/>
+        </p:nvSpPr>
+        <p:spPr>
+          <a:xfrm>
+            <a:off x="2790825" y="1619250"/>
+            <a:ext cx="857250" cy="476250"/>
+          </a:xfrm>
+          <a:prstGeom prst="roundRect">
+            <a:avLst>
+              <a:gd name="adj" fmla="val 8000"/>
+            </a:avLst>
+          </a:prstGeom>
+          <a:solidFill>
+            <a:srgbClr val="161A1E"/>
+          </a:solidFill>
+          <a:ln w="15875">
+            <a:solidFill>
+              <a:srgbClr val="464A50"/>
+            </a:solidFill>
+          </a:ln>
+          <a:effectLst/>
+        </p:spPr>
+        <p:style>
+          <a:lnRef idx="1">
+            <a:schemeClr val="accent1"/>
+          </a:lnRef>
+          <a:fillRef idx="3">
+            <a:schemeClr val="accent1"/>
+          </a:fillRef>
+          <a:effectRef idx="2">
+            <a:schemeClr val="accent1"/>
+          </a:effectRef>
+          <a:fontRef idx="minor">
+            <a:schemeClr val="lt1"/>
+          </a:fontRef>
+        </p:style>
+        <p:txBody>
+          <a:bodyPr rtlCol="0" anchor="ctr" wrap="square" lIns="19050" rIns="19050" tIns="19050" bIns="19050"/>
+          <a:lstStyle/>
+          <a:p>
+            <a:pPr algn="ctr">
+              <a:lnSpc>
+                <a:spcPct val="122000"/>
+              </a:lnSpc>
+            </a:pPr>
+            <a:r>
+              <a:rPr sz="1100" b="1">
+                <a:solidFill>
+                  <a:srgbClr val="96969E"/>
+                </a:solidFill>
+                <a:latin typeface="Amazon Ember"/>
+                <a:ea typeface="メイリオ"/>
+                <a:cs typeface="メイリオ"/>
+              </a:rPr>
+              <a:t>0</a:t>
+            </a:r>
+          </a:p>
+        </p:txBody>
+      </p:sp>
+      <p:sp>
+        <p:nvSpPr>
+          <p:cNvPr id="14" name="Rounded Rectangle 13"/>
+          <p:cNvSpPr/>
+          <p:nvPr/>
+        </p:nvSpPr>
+        <p:spPr>
+          <a:xfrm>
+            <a:off x="3686175" y="1619250"/>
+            <a:ext cx="857250" cy="476250"/>
+          </a:xfrm>
+          <a:prstGeom prst="roundRect">
+            <a:avLst>
+              <a:gd name="adj" fmla="val 8000"/>
+            </a:avLst>
+          </a:prstGeom>
+          <a:solidFill>
+            <a:srgbClr val="161A1E"/>
+          </a:solidFill>
+          <a:ln w="15875">
+            <a:solidFill>
+              <a:srgbClr val="464A50"/>
+            </a:solidFill>
+          </a:ln>
+          <a:effectLst/>
+        </p:spPr>
+        <p:style>
+          <a:lnRef idx="1">
+            <a:schemeClr val="accent1"/>
+          </a:lnRef>
+          <a:fillRef idx="3">
+            <a:schemeClr val="accent1"/>
+          </a:fillRef>
+          <a:effectRef idx="2">
+            <a:schemeClr val="accent1"/>
+          </a:effectRef>
+          <a:fontRef idx="minor">
+            <a:schemeClr val="lt1"/>
+          </a:fontRef>
+        </p:style>
+        <p:txBody>
+          <a:bodyPr rtlCol="0" anchor="ctr" wrap="square" lIns="19050" rIns="19050" tIns="19050" bIns="19050"/>
+          <a:lstStyle/>
+          <a:p>
+            <a:pPr algn="ctr">
+              <a:lnSpc>
+                <a:spcPct val="122000"/>
+              </a:lnSpc>
+            </a:pPr>
+            <a:r>
+              <a:rPr sz="1100" b="1">
+                <a:solidFill>
+                  <a:srgbClr val="96969E"/>
+                </a:solidFill>
+                <a:latin typeface="Amazon Ember"/>
+                <a:ea typeface="メイリオ"/>
+                <a:cs typeface="メイリオ"/>
+              </a:rPr>
+              <a:t>0</a:t>
+            </a:r>
+          </a:p>
+        </p:txBody>
+      </p:sp>
+      <p:sp>
+        <p:nvSpPr>
+          <p:cNvPr id="15" name="Rounded Rectangle 14"/>
+          <p:cNvSpPr/>
+          <p:nvPr/>
+        </p:nvSpPr>
+        <p:spPr>
+          <a:xfrm>
+            <a:off x="4581525" y="1619250"/>
+            <a:ext cx="857250" cy="476250"/>
+          </a:xfrm>
+          <a:prstGeom prst="roundRect">
+            <a:avLst>
+              <a:gd name="adj" fmla="val 8000"/>
+            </a:avLst>
+          </a:prstGeom>
+          <a:solidFill>
+            <a:srgbClr val="161A1E"/>
+          </a:solidFill>
+          <a:ln w="15875">
+            <a:solidFill>
+              <a:srgbClr val="464A50"/>
+            </a:solidFill>
+          </a:ln>
+          <a:effectLst/>
+        </p:spPr>
+        <p:style>
+          <a:lnRef idx="1">
+            <a:schemeClr val="accent1"/>
+          </a:lnRef>
+          <a:fillRef idx="3">
+            <a:schemeClr val="accent1"/>
+          </a:fillRef>
+          <a:effectRef idx="2">
+            <a:schemeClr val="accent1"/>
+          </a:effectRef>
+          <a:fontRef idx="minor">
+            <a:schemeClr val="lt1"/>
+          </a:fontRef>
+        </p:style>
+        <p:txBody>
+          <a:bodyPr rtlCol="0" anchor="ctr" wrap="square" lIns="19050" rIns="19050" tIns="19050" bIns="19050"/>
+          <a:lstStyle/>
+          <a:p>
+            <a:pPr algn="ctr">
+              <a:lnSpc>
+                <a:spcPct val="122000"/>
+              </a:lnSpc>
+            </a:pPr>
+            <a:r>
+              <a:rPr sz="1100" b="1">
+                <a:solidFill>
+                  <a:srgbClr val="96969E"/>
+                </a:solidFill>
+                <a:latin typeface="Amazon Ember"/>
+                <a:ea typeface="メイリオ"/>
+                <a:cs typeface="メイリオ"/>
+              </a:rPr>
+              <a:t>0</a:t>
+            </a:r>
+          </a:p>
+        </p:txBody>
+      </p:sp>
+      <p:sp>
+        <p:nvSpPr>
+          <p:cNvPr id="16" name="Rounded Rectangle 15"/>
+          <p:cNvSpPr/>
+          <p:nvPr/>
+        </p:nvSpPr>
+        <p:spPr>
+          <a:xfrm>
+            <a:off x="5476875" y="1619250"/>
+            <a:ext cx="857250" cy="476250"/>
+          </a:xfrm>
+          <a:prstGeom prst="roundRect">
+            <a:avLst>
+              <a:gd name="adj" fmla="val 8000"/>
+            </a:avLst>
+          </a:prstGeom>
+          <a:solidFill>
+            <a:srgbClr val="161A1E"/>
+          </a:solidFill>
+          <a:ln w="15875">
+            <a:solidFill>
+              <a:srgbClr val="464A50"/>
+            </a:solidFill>
+          </a:ln>
+          <a:effectLst/>
+        </p:spPr>
+        <p:style>
+          <a:lnRef idx="1">
+            <a:schemeClr val="accent1"/>
+          </a:lnRef>
+          <a:fillRef idx="3">
+            <a:schemeClr val="accent1"/>
+          </a:fillRef>
+          <a:effectRef idx="2">
+            <a:schemeClr val="accent1"/>
+          </a:effectRef>
+          <a:fontRef idx="minor">
+            <a:schemeClr val="lt1"/>
+          </a:fontRef>
+        </p:style>
+        <p:txBody>
+          <a:bodyPr rtlCol="0" anchor="ctr" wrap="square" lIns="19050" rIns="19050" tIns="19050" bIns="19050"/>
+          <a:lstStyle/>
+          <a:p>
+            <a:pPr algn="ctr">
+              <a:lnSpc>
+                <a:spcPct val="122000"/>
+              </a:lnSpc>
+            </a:pPr>
+            <a:r>
+              <a:rPr sz="1100" b="1">
+                <a:solidFill>
+                  <a:srgbClr val="96969E"/>
+                </a:solidFill>
+                <a:latin typeface="Amazon Ember"/>
+                <a:ea typeface="メイリオ"/>
+                <a:cs typeface="メイリオ"/>
+              </a:rPr>
+              <a:t>0</a:t>
+            </a:r>
+          </a:p>
+        </p:txBody>
+      </p:sp>
+      <p:sp>
+        <p:nvSpPr>
+          <p:cNvPr id="17" name="TextBox 16"/>
+          <p:cNvSpPr txBox="1"/>
+          <p:nvPr/>
+        </p:nvSpPr>
+        <p:spPr>
+          <a:xfrm>
+            <a:off x="447675" y="2114550"/>
+            <a:ext cx="476250" cy="514350"/>
+          </a:xfrm>
+          <a:prstGeom prst="rect">
+            <a:avLst/>
+          </a:prstGeom>
+          <a:noFill/>
+        </p:spPr>
+        <p:txBody>
+          <a:bodyPr wrap="square" lIns="0" rIns="0" tIns="0" bIns="0" anchor="ctr">
+            <a:spAutoFit/>
+          </a:bodyPr>
+          <a:lstStyle/>
+          <a:p>
+            <a:pPr algn="r">
+              <a:lnSpc>
+                <a:spcPct val="122000"/>
+              </a:lnSpc>
+            </a:pPr>
+            <a:r>
+              <a:rPr sz="1400" b="0">
+                <a:solidFill>
+                  <a:srgbClr val="96969E"/>
+                </a:solidFill>
+                <a:latin typeface="Amazon Ember"/>
+                <a:ea typeface="メイリオ"/>
+                <a:cs typeface="メイリオ"/>
+              </a:rPr>
+              <a:t>y2</a:t>
+            </a:r>
+          </a:p>
+        </p:txBody>
+      </p:sp>
+      <p:sp>
+        <p:nvSpPr>
+          <p:cNvPr id="18" name="Rounded Rectangle 17"/>
+          <p:cNvSpPr/>
+          <p:nvPr/>
+        </p:nvSpPr>
+        <p:spPr>
+          <a:xfrm>
+            <a:off x="1000125" y="2133600"/>
+            <a:ext cx="857250" cy="476250"/>
+          </a:xfrm>
+          <a:prstGeom prst="roundRect">
+            <a:avLst>
+              <a:gd name="adj" fmla="val 8000"/>
+            </a:avLst>
+          </a:prstGeom>
+          <a:solidFill>
+            <a:srgbClr val="124022"/>
+          </a:solidFill>
+          <a:ln w="15875">
+            <a:solidFill>
+              <a:srgbClr val="24A046"/>
+            </a:solidFill>
+          </a:ln>
+          <a:effectLst/>
+        </p:spPr>
+        <p:style>
+          <a:lnRef idx="1">
+            <a:schemeClr val="accent1"/>
+          </a:lnRef>
+          <a:fillRef idx="3">
+            <a:schemeClr val="accent1"/>
+          </a:fillRef>
+          <a:effectRef idx="2">
+            <a:schemeClr val="accent1"/>
+          </a:effectRef>
+          <a:fontRef idx="minor">
+            <a:schemeClr val="lt1"/>
+          </a:fontRef>
+        </p:style>
+        <p:txBody>
+          <a:bodyPr rtlCol="0" anchor="ctr" wrap="square" lIns="19050" rIns="19050" tIns="19050" bIns="19050"/>
+          <a:lstStyle/>
+          <a:p>
+            <a:pPr algn="ctr">
+              <a:lnSpc>
+                <a:spcPct val="122000"/>
+              </a:lnSpc>
+            </a:pPr>
+            <a:r>
+              <a:rPr sz="1100" b="1">
+                <a:solidFill>
+                  <a:srgbClr val="F5F5F8"/>
+                </a:solidFill>
+                <a:latin typeface="Amazon Ember"/>
+                <a:ea typeface="メイリオ"/>
+                <a:cs typeface="メイリオ"/>
+              </a:rPr>
+              <a:t>c2a2b1</a:t>
+            </a:r>
+          </a:p>
+        </p:txBody>
+      </p:sp>
+      <p:sp>
+        <p:nvSpPr>
+          <p:cNvPr id="19" name="Rounded Rectangle 18"/>
+          <p:cNvSpPr/>
+          <p:nvPr/>
+        </p:nvSpPr>
+        <p:spPr>
+          <a:xfrm>
+            <a:off x="1895475" y="2133600"/>
+            <a:ext cx="857250" cy="476250"/>
+          </a:xfrm>
+          <a:prstGeom prst="roundRect">
+            <a:avLst>
+              <a:gd name="adj" fmla="val 8000"/>
+            </a:avLst>
+          </a:prstGeom>
+          <a:solidFill>
+            <a:srgbClr val="124022"/>
+          </a:solidFill>
+          <a:ln w="15875">
+            <a:solidFill>
+              <a:srgbClr val="24A046"/>
+            </a:solidFill>
+          </a:ln>
+          <a:effectLst/>
+        </p:spPr>
+        <p:style>
+          <a:lnRef idx="1">
+            <a:schemeClr val="accent1"/>
+          </a:lnRef>
+          <a:fillRef idx="3">
+            <a:schemeClr val="accent1"/>
+          </a:fillRef>
+          <a:effectRef idx="2">
+            <a:schemeClr val="accent1"/>
+          </a:effectRef>
+          <a:fontRef idx="minor">
+            <a:schemeClr val="lt1"/>
+          </a:fontRef>
+        </p:style>
+        <p:txBody>
+          <a:bodyPr rtlCol="0" anchor="ctr" wrap="square" lIns="19050" rIns="19050" tIns="19050" bIns="19050"/>
+          <a:lstStyle/>
+          <a:p>
+            <a:pPr algn="ctr">
+              <a:lnSpc>
+                <a:spcPct val="122000"/>
+              </a:lnSpc>
+            </a:pPr>
+            <a:r>
+              <a:rPr sz="1100" b="1">
+                <a:solidFill>
+                  <a:srgbClr val="F5F5F8"/>
+                </a:solidFill>
+                <a:latin typeface="Amazon Ember"/>
+                <a:ea typeface="メイリオ"/>
+                <a:cs typeface="メイリオ"/>
+              </a:rPr>
+              <a:t>c2b2</a:t>
+            </a:r>
+          </a:p>
+        </p:txBody>
+      </p:sp>
+      <p:sp>
+        <p:nvSpPr>
+          <p:cNvPr id="20" name="Rounded Rectangle 19"/>
+          <p:cNvSpPr/>
+          <p:nvPr/>
+        </p:nvSpPr>
+        <p:spPr>
+          <a:xfrm>
+            <a:off x="2790825" y="2133600"/>
+            <a:ext cx="857250" cy="476250"/>
+          </a:xfrm>
+          <a:prstGeom prst="roundRect">
+            <a:avLst>
+              <a:gd name="adj" fmla="val 8000"/>
+            </a:avLst>
+          </a:prstGeom>
+          <a:solidFill>
+            <a:srgbClr val="161A1E"/>
+          </a:solidFill>
+          <a:ln w="15875">
+            <a:solidFill>
+              <a:srgbClr val="464A50"/>
+            </a:solidFill>
+          </a:ln>
+          <a:effectLst/>
+        </p:spPr>
+        <p:style>
+          <a:lnRef idx="1">
+            <a:schemeClr val="accent1"/>
+          </a:lnRef>
+          <a:fillRef idx="3">
+            <a:schemeClr val="accent1"/>
+          </a:fillRef>
+          <a:effectRef idx="2">
+            <a:schemeClr val="accent1"/>
+          </a:effectRef>
+          <a:fontRef idx="minor">
+            <a:schemeClr val="lt1"/>
+          </a:fontRef>
+        </p:style>
+        <p:txBody>
+          <a:bodyPr rtlCol="0" anchor="ctr" wrap="square" lIns="19050" rIns="19050" tIns="19050" bIns="19050"/>
+          <a:lstStyle/>
+          <a:p>
+            <a:pPr algn="ctr">
+              <a:lnSpc>
+                <a:spcPct val="122000"/>
+              </a:lnSpc>
+            </a:pPr>
+            <a:r>
+              <a:rPr sz="1100" b="1">
+                <a:solidFill>
+                  <a:srgbClr val="96969E"/>
+                </a:solidFill>
+                <a:latin typeface="Amazon Ember"/>
+                <a:ea typeface="メイリオ"/>
+                <a:cs typeface="メイリオ"/>
+              </a:rPr>
+              <a:t>0</a:t>
+            </a:r>
+          </a:p>
+        </p:txBody>
+      </p:sp>
+      <p:sp>
+        <p:nvSpPr>
+          <p:cNvPr id="21" name="Rounded Rectangle 20"/>
+          <p:cNvSpPr/>
+          <p:nvPr/>
+        </p:nvSpPr>
+        <p:spPr>
+          <a:xfrm>
+            <a:off x="3686175" y="2133600"/>
+            <a:ext cx="857250" cy="476250"/>
+          </a:xfrm>
+          <a:prstGeom prst="roundRect">
+            <a:avLst>
+              <a:gd name="adj" fmla="val 8000"/>
+            </a:avLst>
+          </a:prstGeom>
+          <a:solidFill>
+            <a:srgbClr val="161A1E"/>
+          </a:solidFill>
+          <a:ln w="15875">
+            <a:solidFill>
+              <a:srgbClr val="464A50"/>
+            </a:solidFill>
+          </a:ln>
+          <a:effectLst/>
+        </p:spPr>
+        <p:style>
+          <a:lnRef idx="1">
+            <a:schemeClr val="accent1"/>
+          </a:lnRef>
+          <a:fillRef idx="3">
+            <a:schemeClr val="accent1"/>
+          </a:fillRef>
+          <a:effectRef idx="2">
+            <a:schemeClr val="accent1"/>
+          </a:effectRef>
+          <a:fontRef idx="minor">
+            <a:schemeClr val="lt1"/>
+          </a:fontRef>
+        </p:style>
+        <p:txBody>
+          <a:bodyPr rtlCol="0" anchor="ctr" wrap="square" lIns="19050" rIns="19050" tIns="19050" bIns="19050"/>
+          <a:lstStyle/>
+          <a:p>
+            <a:pPr algn="ctr">
+              <a:lnSpc>
+                <a:spcPct val="122000"/>
+              </a:lnSpc>
+            </a:pPr>
+            <a:r>
+              <a:rPr sz="1100" b="1">
+                <a:solidFill>
+                  <a:srgbClr val="96969E"/>
+                </a:solidFill>
+                <a:latin typeface="Amazon Ember"/>
+                <a:ea typeface="メイリオ"/>
+                <a:cs typeface="メイリオ"/>
+              </a:rPr>
+              <a:t>0</a:t>
+            </a:r>
+          </a:p>
+        </p:txBody>
+      </p:sp>
+      <p:sp>
+        <p:nvSpPr>
+          <p:cNvPr id="22" name="Rounded Rectangle 21"/>
+          <p:cNvSpPr/>
+          <p:nvPr/>
+        </p:nvSpPr>
+        <p:spPr>
+          <a:xfrm>
+            <a:off x="4581525" y="2133600"/>
+            <a:ext cx="857250" cy="476250"/>
+          </a:xfrm>
+          <a:prstGeom prst="roundRect">
+            <a:avLst>
+              <a:gd name="adj" fmla="val 8000"/>
+            </a:avLst>
+          </a:prstGeom>
+          <a:solidFill>
+            <a:srgbClr val="161A1E"/>
+          </a:solidFill>
+          <a:ln w="15875">
+            <a:solidFill>
+              <a:srgbClr val="464A50"/>
+            </a:solidFill>
+          </a:ln>
+          <a:effectLst/>
+        </p:spPr>
+        <p:style>
+          <a:lnRef idx="1">
+            <a:schemeClr val="accent1"/>
+          </a:lnRef>
+          <a:fillRef idx="3">
+            <a:schemeClr val="accent1"/>
+          </a:fillRef>
+          <a:effectRef idx="2">
+            <a:schemeClr val="accent1"/>
+          </a:effectRef>
+          <a:fontRef idx="minor">
+            <a:schemeClr val="lt1"/>
+          </a:fontRef>
+        </p:style>
+        <p:txBody>
+          <a:bodyPr rtlCol="0" anchor="ctr" wrap="square" lIns="19050" rIns="19050" tIns="19050" bIns="19050"/>
+          <a:lstStyle/>
+          <a:p>
+            <a:pPr algn="ctr">
+              <a:lnSpc>
+                <a:spcPct val="122000"/>
+              </a:lnSpc>
+            </a:pPr>
+            <a:r>
+              <a:rPr sz="1100" b="1">
+                <a:solidFill>
+                  <a:srgbClr val="96969E"/>
+                </a:solidFill>
+                <a:latin typeface="Amazon Ember"/>
+                <a:ea typeface="メイリオ"/>
+                <a:cs typeface="メイリオ"/>
+              </a:rPr>
+              <a:t>0</a:t>
+            </a:r>
+          </a:p>
+        </p:txBody>
+      </p:sp>
+      <p:sp>
+        <p:nvSpPr>
+          <p:cNvPr id="23" name="Rounded Rectangle 22"/>
+          <p:cNvSpPr/>
+          <p:nvPr/>
+        </p:nvSpPr>
+        <p:spPr>
+          <a:xfrm>
+            <a:off x="5476875" y="2133600"/>
+            <a:ext cx="857250" cy="476250"/>
+          </a:xfrm>
+          <a:prstGeom prst="roundRect">
+            <a:avLst>
+              <a:gd name="adj" fmla="val 8000"/>
+            </a:avLst>
+          </a:prstGeom>
+          <a:solidFill>
+            <a:srgbClr val="161A1E"/>
+          </a:solidFill>
+          <a:ln w="15875">
+            <a:solidFill>
+              <a:srgbClr val="464A50"/>
+            </a:solidFill>
+          </a:ln>
+          <a:effectLst/>
+        </p:spPr>
+        <p:style>
+          <a:lnRef idx="1">
+            <a:schemeClr val="accent1"/>
+          </a:lnRef>
+          <a:fillRef idx="3">
+            <a:schemeClr val="accent1"/>
+          </a:fillRef>
+          <a:effectRef idx="2">
+            <a:schemeClr val="accent1"/>
+          </a:effectRef>
+          <a:fontRef idx="minor">
+            <a:schemeClr val="lt1"/>
+          </a:fontRef>
+        </p:style>
+        <p:txBody>
+          <a:bodyPr rtlCol="0" anchor="ctr" wrap="square" lIns="19050" rIns="19050" tIns="19050" bIns="19050"/>
+          <a:lstStyle/>
+          <a:p>
+            <a:pPr algn="ctr">
+              <a:lnSpc>
+                <a:spcPct val="122000"/>
+              </a:lnSpc>
+            </a:pPr>
+            <a:r>
+              <a:rPr sz="1100" b="1">
+                <a:solidFill>
+                  <a:srgbClr val="96969E"/>
+                </a:solidFill>
+                <a:latin typeface="Amazon Ember"/>
+                <a:ea typeface="メイリオ"/>
+                <a:cs typeface="メイリオ"/>
+              </a:rPr>
+              <a:t>0</a:t>
+            </a:r>
+          </a:p>
+        </p:txBody>
+      </p:sp>
+      <p:sp>
+        <p:nvSpPr>
+          <p:cNvPr id="24" name="TextBox 23"/>
+          <p:cNvSpPr txBox="1"/>
+          <p:nvPr/>
+        </p:nvSpPr>
+        <p:spPr>
+          <a:xfrm>
+            <a:off x="447675" y="2628900"/>
+            <a:ext cx="476250" cy="514350"/>
+          </a:xfrm>
+          <a:prstGeom prst="rect">
+            <a:avLst/>
+          </a:prstGeom>
+          <a:noFill/>
+        </p:spPr>
+        <p:txBody>
+          <a:bodyPr wrap="square" lIns="0" rIns="0" tIns="0" bIns="0" anchor="ctr">
+            <a:spAutoFit/>
+          </a:bodyPr>
+          <a:lstStyle/>
+          <a:p>
+            <a:pPr algn="r">
+              <a:lnSpc>
+                <a:spcPct val="122000"/>
+              </a:lnSpc>
+            </a:pPr>
+            <a:r>
+              <a:rPr sz="1400" b="0">
+                <a:solidFill>
+                  <a:srgbClr val="96969E"/>
+                </a:solidFill>
+                <a:latin typeface="Amazon Ember"/>
+                <a:ea typeface="メイリオ"/>
+                <a:cs typeface="メイリオ"/>
+              </a:rPr>
+              <a:t>y3</a:t>
+            </a:r>
+          </a:p>
+        </p:txBody>
+      </p:sp>
+      <p:sp>
+        <p:nvSpPr>
+          <p:cNvPr id="25" name="Rounded Rectangle 24"/>
+          <p:cNvSpPr/>
+          <p:nvPr/>
+        </p:nvSpPr>
+        <p:spPr>
+          <a:xfrm>
+            <a:off x="1000125" y="2647950"/>
+            <a:ext cx="857250" cy="476250"/>
+          </a:xfrm>
+          <a:prstGeom prst="roundRect">
+            <a:avLst>
+              <a:gd name="adj" fmla="val 8000"/>
+            </a:avLst>
+          </a:prstGeom>
+          <a:solidFill>
+            <a:srgbClr val="124022"/>
+          </a:solidFill>
+          <a:ln w="15875">
+            <a:solidFill>
+              <a:srgbClr val="24A046"/>
+            </a:solidFill>
+          </a:ln>
+          <a:effectLst/>
+        </p:spPr>
+        <p:style>
+          <a:lnRef idx="1">
+            <a:schemeClr val="accent1"/>
+          </a:lnRef>
+          <a:fillRef idx="3">
+            <a:schemeClr val="accent1"/>
+          </a:fillRef>
+          <a:effectRef idx="2">
+            <a:schemeClr val="accent1"/>
+          </a:effectRef>
+          <a:fontRef idx="minor">
+            <a:schemeClr val="lt1"/>
+          </a:fontRef>
+        </p:style>
+        <p:txBody>
+          <a:bodyPr rtlCol="0" anchor="ctr" wrap="square" lIns="19050" rIns="19050" tIns="19050" bIns="19050"/>
+          <a:lstStyle/>
+          <a:p>
+            <a:pPr algn="ctr">
+              <a:lnSpc>
+                <a:spcPct val="122000"/>
+              </a:lnSpc>
+            </a:pPr>
+            <a:r>
+              <a:rPr sz="1100" b="1">
+                <a:solidFill>
+                  <a:srgbClr val="F5F5F8"/>
+                </a:solidFill>
+                <a:latin typeface="Amazon Ember"/>
+                <a:ea typeface="メイリオ"/>
+                <a:cs typeface="メイリオ"/>
+              </a:rPr>
+              <a:t>c3a3a2b1</a:t>
+            </a:r>
+          </a:p>
+        </p:txBody>
+      </p:sp>
+      <p:sp>
+        <p:nvSpPr>
+          <p:cNvPr id="26" name="Rounded Rectangle 25"/>
+          <p:cNvSpPr/>
+          <p:nvPr/>
+        </p:nvSpPr>
+        <p:spPr>
+          <a:xfrm>
+            <a:off x="1895475" y="2647950"/>
+            <a:ext cx="857250" cy="476250"/>
+          </a:xfrm>
+          <a:prstGeom prst="roundRect">
+            <a:avLst>
+              <a:gd name="adj" fmla="val 8000"/>
+            </a:avLst>
+          </a:prstGeom>
+          <a:solidFill>
+            <a:srgbClr val="124022"/>
+          </a:solidFill>
+          <a:ln w="15875">
+            <a:solidFill>
+              <a:srgbClr val="24A046"/>
+            </a:solidFill>
+          </a:ln>
+          <a:effectLst/>
+        </p:spPr>
+        <p:style>
+          <a:lnRef idx="1">
+            <a:schemeClr val="accent1"/>
+          </a:lnRef>
+          <a:fillRef idx="3">
+            <a:schemeClr val="accent1"/>
+          </a:fillRef>
+          <a:effectRef idx="2">
+            <a:schemeClr val="accent1"/>
+          </a:effectRef>
+          <a:fontRef idx="minor">
+            <a:schemeClr val="lt1"/>
+          </a:fontRef>
+        </p:style>
+        <p:txBody>
+          <a:bodyPr rtlCol="0" anchor="ctr" wrap="square" lIns="19050" rIns="19050" tIns="19050" bIns="19050"/>
+          <a:lstStyle/>
+          <a:p>
+            <a:pPr algn="ctr">
+              <a:lnSpc>
+                <a:spcPct val="122000"/>
+              </a:lnSpc>
+            </a:pPr>
+            <a:r>
+              <a:rPr sz="1100" b="1">
+                <a:solidFill>
+                  <a:srgbClr val="F5F5F8"/>
+                </a:solidFill>
+                <a:latin typeface="Amazon Ember"/>
+                <a:ea typeface="メイリオ"/>
+                <a:cs typeface="メイリオ"/>
+              </a:rPr>
+              <a:t>c3a3b2</a:t>
+            </a:r>
+          </a:p>
+        </p:txBody>
+      </p:sp>
+      <p:sp>
+        <p:nvSpPr>
+          <p:cNvPr id="27" name="Rounded Rectangle 26"/>
+          <p:cNvSpPr/>
+          <p:nvPr/>
+        </p:nvSpPr>
+        <p:spPr>
+          <a:xfrm>
+            <a:off x="2790825" y="2647950"/>
+            <a:ext cx="857250" cy="476250"/>
+          </a:xfrm>
+          <a:prstGeom prst="roundRect">
+            <a:avLst>
+              <a:gd name="adj" fmla="val 8000"/>
+            </a:avLst>
+          </a:prstGeom>
+          <a:solidFill>
+            <a:srgbClr val="124022"/>
+          </a:solidFill>
+          <a:ln w="15875">
+            <a:solidFill>
+              <a:srgbClr val="24A046"/>
+            </a:solidFill>
+          </a:ln>
+          <a:effectLst/>
+        </p:spPr>
+        <p:style>
+          <a:lnRef idx="1">
+            <a:schemeClr val="accent1"/>
+          </a:lnRef>
+          <a:fillRef idx="3">
+            <a:schemeClr val="accent1"/>
+          </a:fillRef>
+          <a:effectRef idx="2">
+            <a:schemeClr val="accent1"/>
+          </a:effectRef>
+          <a:fontRef idx="minor">
+            <a:schemeClr val="lt1"/>
+          </a:fontRef>
+        </p:style>
+        <p:txBody>
+          <a:bodyPr rtlCol="0" anchor="ctr" wrap="square" lIns="19050" rIns="19050" tIns="19050" bIns="19050"/>
+          <a:lstStyle/>
+          <a:p>
+            <a:pPr algn="ctr">
+              <a:lnSpc>
+                <a:spcPct val="122000"/>
+              </a:lnSpc>
+            </a:pPr>
+            <a:r>
+              <a:rPr sz="1100" b="1">
+                <a:solidFill>
+                  <a:srgbClr val="F5F5F8"/>
+                </a:solidFill>
+                <a:latin typeface="Amazon Ember"/>
+                <a:ea typeface="メイリオ"/>
+                <a:cs typeface="メイリオ"/>
+              </a:rPr>
+              <a:t>c3b3</a:t>
+            </a:r>
+          </a:p>
+        </p:txBody>
+      </p:sp>
+      <p:sp>
+        <p:nvSpPr>
+          <p:cNvPr id="28" name="Rounded Rectangle 27"/>
+          <p:cNvSpPr/>
+          <p:nvPr/>
+        </p:nvSpPr>
+        <p:spPr>
+          <a:xfrm>
+            <a:off x="3686175" y="2647950"/>
+            <a:ext cx="857250" cy="476250"/>
+          </a:xfrm>
+          <a:prstGeom prst="roundRect">
+            <a:avLst>
+              <a:gd name="adj" fmla="val 8000"/>
+            </a:avLst>
+          </a:prstGeom>
+          <a:solidFill>
+            <a:srgbClr val="161A1E"/>
+          </a:solidFill>
+          <a:ln w="15875">
+            <a:solidFill>
+              <a:srgbClr val="464A50"/>
+            </a:solidFill>
+          </a:ln>
+          <a:effectLst/>
+        </p:spPr>
+        <p:style>
+          <a:lnRef idx="1">
+            <a:schemeClr val="accent1"/>
+          </a:lnRef>
+          <a:fillRef idx="3">
+            <a:schemeClr val="accent1"/>
+          </a:fillRef>
+          <a:effectRef idx="2">
+            <a:schemeClr val="accent1"/>
+          </a:effectRef>
+          <a:fontRef idx="minor">
+            <a:schemeClr val="lt1"/>
+          </a:fontRef>
+        </p:style>
+        <p:txBody>
+          <a:bodyPr rtlCol="0" anchor="ctr" wrap="square" lIns="19050" rIns="19050" tIns="19050" bIns="19050"/>
+          <a:lstStyle/>
+          <a:p>
+            <a:pPr algn="ctr">
+              <a:lnSpc>
+                <a:spcPct val="122000"/>
+              </a:lnSpc>
+            </a:pPr>
+            <a:r>
+              <a:rPr sz="1100" b="1">
+                <a:solidFill>
+                  <a:srgbClr val="96969E"/>
+                </a:solidFill>
+                <a:latin typeface="Amazon Ember"/>
+                <a:ea typeface="メイリオ"/>
+                <a:cs typeface="メイリオ"/>
+              </a:rPr>
+              <a:t>0</a:t>
+            </a:r>
+          </a:p>
+        </p:txBody>
+      </p:sp>
+      <p:sp>
+        <p:nvSpPr>
+          <p:cNvPr id="29" name="Rounded Rectangle 28"/>
+          <p:cNvSpPr/>
+          <p:nvPr/>
+        </p:nvSpPr>
+        <p:spPr>
+          <a:xfrm>
+            <a:off x="4581525" y="2647950"/>
+            <a:ext cx="857250" cy="476250"/>
+          </a:xfrm>
+          <a:prstGeom prst="roundRect">
+            <a:avLst>
+              <a:gd name="adj" fmla="val 8000"/>
+            </a:avLst>
+          </a:prstGeom>
+          <a:solidFill>
+            <a:srgbClr val="161A1E"/>
+          </a:solidFill>
+          <a:ln w="15875">
+            <a:solidFill>
+              <a:srgbClr val="464A50"/>
+            </a:solidFill>
+          </a:ln>
+          <a:effectLst/>
+        </p:spPr>
+        <p:style>
+          <a:lnRef idx="1">
+            <a:schemeClr val="accent1"/>
+          </a:lnRef>
+          <a:fillRef idx="3">
+            <a:schemeClr val="accent1"/>
+          </a:fillRef>
+          <a:effectRef idx="2">
+            <a:schemeClr val="accent1"/>
+          </a:effectRef>
+          <a:fontRef idx="minor">
+            <a:schemeClr val="lt1"/>
+          </a:fontRef>
+        </p:style>
+        <p:txBody>
+          <a:bodyPr rtlCol="0" anchor="ctr" wrap="square" lIns="19050" rIns="19050" tIns="19050" bIns="19050"/>
+          <a:lstStyle/>
+          <a:p>
+            <a:pPr algn="ctr">
+              <a:lnSpc>
+                <a:spcPct val="122000"/>
+              </a:lnSpc>
+            </a:pPr>
+            <a:r>
+              <a:rPr sz="1100" b="1">
+                <a:solidFill>
+                  <a:srgbClr val="96969E"/>
+                </a:solidFill>
+                <a:latin typeface="Amazon Ember"/>
+                <a:ea typeface="メイリオ"/>
+                <a:cs typeface="メイリオ"/>
+              </a:rPr>
+              <a:t>0</a:t>
+            </a:r>
+          </a:p>
+        </p:txBody>
+      </p:sp>
+      <p:sp>
+        <p:nvSpPr>
+          <p:cNvPr id="30" name="Rounded Rectangle 29"/>
+          <p:cNvSpPr/>
+          <p:nvPr/>
+        </p:nvSpPr>
+        <p:spPr>
+          <a:xfrm>
+            <a:off x="5476875" y="2647950"/>
+            <a:ext cx="857250" cy="476250"/>
+          </a:xfrm>
+          <a:prstGeom prst="roundRect">
+            <a:avLst>
+              <a:gd name="adj" fmla="val 8000"/>
+            </a:avLst>
+          </a:prstGeom>
+          <a:solidFill>
+            <a:srgbClr val="161A1E"/>
+          </a:solidFill>
+          <a:ln w="15875">
+            <a:solidFill>
+              <a:srgbClr val="464A50"/>
+            </a:solidFill>
+          </a:ln>
+          <a:effectLst/>
+        </p:spPr>
+        <p:style>
+          <a:lnRef idx="1">
+            <a:schemeClr val="accent1"/>
+          </a:lnRef>
+          <a:fillRef idx="3">
+            <a:schemeClr val="accent1"/>
+          </a:fillRef>
+          <a:effectRef idx="2">
+            <a:schemeClr val="accent1"/>
+          </a:effectRef>
+          <a:fontRef idx="minor">
+            <a:schemeClr val="lt1"/>
+          </a:fontRef>
+        </p:style>
+        <p:txBody>
+          <a:bodyPr rtlCol="0" anchor="ctr" wrap="square" lIns="19050" rIns="19050" tIns="19050" bIns="19050"/>
+          <a:lstStyle/>
+          <a:p>
+            <a:pPr algn="ctr">
+              <a:lnSpc>
+                <a:spcPct val="122000"/>
+              </a:lnSpc>
+            </a:pPr>
+            <a:r>
+              <a:rPr sz="1100" b="1">
+                <a:solidFill>
+                  <a:srgbClr val="96969E"/>
+                </a:solidFill>
+                <a:latin typeface="Amazon Ember"/>
+                <a:ea typeface="メイリオ"/>
+                <a:cs typeface="メイリオ"/>
+              </a:rPr>
+              <a:t>0</a:t>
+            </a:r>
+          </a:p>
+        </p:txBody>
+      </p:sp>
+      <p:sp>
+        <p:nvSpPr>
+          <p:cNvPr id="31" name="TextBox 30"/>
+          <p:cNvSpPr txBox="1"/>
+          <p:nvPr/>
+        </p:nvSpPr>
+        <p:spPr>
+          <a:xfrm>
+            <a:off x="447675" y="3143250"/>
+            <a:ext cx="476250" cy="514350"/>
+          </a:xfrm>
+          <a:prstGeom prst="rect">
+            <a:avLst/>
+          </a:prstGeom>
+          <a:noFill/>
+        </p:spPr>
+        <p:txBody>
+          <a:bodyPr wrap="square" lIns="0" rIns="0" tIns="0" bIns="0" anchor="ctr">
+            <a:spAutoFit/>
+          </a:bodyPr>
+          <a:lstStyle/>
+          <a:p>
+            <a:pPr algn="r">
+              <a:lnSpc>
+                <a:spcPct val="122000"/>
+              </a:lnSpc>
+            </a:pPr>
+            <a:r>
+              <a:rPr sz="1400" b="0">
+                <a:solidFill>
+                  <a:srgbClr val="96969E"/>
+                </a:solidFill>
+                <a:latin typeface="Amazon Ember"/>
+                <a:ea typeface="メイリオ"/>
+                <a:cs typeface="メイリオ"/>
+              </a:rPr>
+              <a:t>y4</a:t>
+            </a:r>
+          </a:p>
+        </p:txBody>
+      </p:sp>
+      <p:sp>
+        <p:nvSpPr>
+          <p:cNvPr id="32" name="Rounded Rectangle 31"/>
+          <p:cNvSpPr/>
+          <p:nvPr/>
+        </p:nvSpPr>
+        <p:spPr>
+          <a:xfrm>
+            <a:off x="1000125" y="3162300"/>
+            <a:ext cx="857250" cy="476250"/>
+          </a:xfrm>
+          <a:prstGeom prst="roundRect">
+            <a:avLst>
+              <a:gd name="adj" fmla="val 8000"/>
+            </a:avLst>
+          </a:prstGeom>
+          <a:solidFill>
+            <a:srgbClr val="102C48"/>
+          </a:solidFill>
+          <a:ln w="15875">
+            <a:solidFill>
+              <a:srgbClr val="2896F0"/>
+            </a:solidFill>
+          </a:ln>
+          <a:effectLst/>
+        </p:spPr>
+        <p:style>
+          <a:lnRef idx="1">
+            <a:schemeClr val="accent1"/>
+          </a:lnRef>
+          <a:fillRef idx="3">
+            <a:schemeClr val="accent1"/>
+          </a:fillRef>
+          <a:effectRef idx="2">
+            <a:schemeClr val="accent1"/>
+          </a:effectRef>
+          <a:fontRef idx="minor">
+            <a:schemeClr val="lt1"/>
+          </a:fontRef>
+        </p:style>
+        <p:txBody>
+          <a:bodyPr rtlCol="0" anchor="ctr" wrap="square" lIns="19050" rIns="19050" tIns="19050" bIns="19050"/>
+          <a:lstStyle/>
+          <a:p>
+            <a:pPr algn="ctr">
+              <a:lnSpc>
+                <a:spcPct val="122000"/>
+              </a:lnSpc>
+            </a:pPr>
+            <a:r>
+              <a:rPr sz="1100" b="1">
+                <a:solidFill>
+                  <a:srgbClr val="F5F5F8"/>
+                </a:solidFill>
+                <a:latin typeface="Amazon Ember"/>
+                <a:ea typeface="メイリオ"/>
+                <a:cs typeface="メイリオ"/>
+              </a:rPr>
+              <a:t>c4a4 ·</a:t>
+            </a:r>
+          </a:p>
+          <a:p>
+            <a:pPr algn="ctr">
+              <a:lnSpc>
+                <a:spcPct val="122000"/>
+              </a:lnSpc>
+            </a:pPr>
+            <a:r>
+              <a:rPr sz="1100" b="1">
+                <a:solidFill>
+                  <a:srgbClr val="F5F5F8"/>
+                </a:solidFill>
+                <a:latin typeface="Amazon Ember"/>
+                <a:ea typeface="メイリオ"/>
+                <a:cs typeface="メイリオ"/>
+              </a:rPr>
+              <a:t>a3a2b1</a:t>
+            </a:r>
+          </a:p>
+        </p:txBody>
+      </p:sp>
+      <p:sp>
+        <p:nvSpPr>
+          <p:cNvPr id="33" name="Rounded Rectangle 32"/>
+          <p:cNvSpPr/>
+          <p:nvPr/>
+        </p:nvSpPr>
+        <p:spPr>
+          <a:xfrm>
+            <a:off x="1895475" y="3162300"/>
+            <a:ext cx="857250" cy="476250"/>
+          </a:xfrm>
+          <a:prstGeom prst="roundRect">
+            <a:avLst>
+              <a:gd name="adj" fmla="val 8000"/>
+            </a:avLst>
+          </a:prstGeom>
+          <a:solidFill>
+            <a:srgbClr val="102C48"/>
+          </a:solidFill>
+          <a:ln w="15875">
+            <a:solidFill>
+              <a:srgbClr val="2896F0"/>
+            </a:solidFill>
+          </a:ln>
+          <a:effectLst/>
+        </p:spPr>
+        <p:style>
+          <a:lnRef idx="1">
+            <a:schemeClr val="accent1"/>
+          </a:lnRef>
+          <a:fillRef idx="3">
+            <a:schemeClr val="accent1"/>
+          </a:fillRef>
+          <a:effectRef idx="2">
+            <a:schemeClr val="accent1"/>
+          </a:effectRef>
+          <a:fontRef idx="minor">
+            <a:schemeClr val="lt1"/>
+          </a:fontRef>
+        </p:style>
+        <p:txBody>
+          <a:bodyPr rtlCol="0" anchor="ctr" wrap="square" lIns="19050" rIns="19050" tIns="19050" bIns="19050"/>
+          <a:lstStyle/>
+          <a:p>
+            <a:pPr algn="ctr">
+              <a:lnSpc>
+                <a:spcPct val="122000"/>
+              </a:lnSpc>
+            </a:pPr>
+            <a:r>
+              <a:rPr sz="1100" b="1">
+                <a:solidFill>
+                  <a:srgbClr val="F5F5F8"/>
+                </a:solidFill>
+                <a:latin typeface="Amazon Ember"/>
+                <a:ea typeface="メイリオ"/>
+                <a:cs typeface="メイリオ"/>
+              </a:rPr>
+              <a:t>c4a4 ·</a:t>
+            </a:r>
+          </a:p>
+          <a:p>
+            <a:pPr algn="ctr">
+              <a:lnSpc>
+                <a:spcPct val="122000"/>
+              </a:lnSpc>
+            </a:pPr>
+            <a:r>
+              <a:rPr sz="1100" b="1">
+                <a:solidFill>
+                  <a:srgbClr val="F5F5F8"/>
+                </a:solidFill>
+                <a:latin typeface="Amazon Ember"/>
+                <a:ea typeface="メイリオ"/>
+                <a:cs typeface="メイリオ"/>
+              </a:rPr>
+              <a:t>a3b2</a:t>
+            </a:r>
+          </a:p>
+        </p:txBody>
+      </p:sp>
+      <p:sp>
+        <p:nvSpPr>
+          <p:cNvPr id="34" name="Rounded Rectangle 33"/>
+          <p:cNvSpPr/>
+          <p:nvPr/>
+        </p:nvSpPr>
+        <p:spPr>
+          <a:xfrm>
+            <a:off x="2790825" y="3162300"/>
+            <a:ext cx="857250" cy="476250"/>
+          </a:xfrm>
+          <a:prstGeom prst="roundRect">
+            <a:avLst>
+              <a:gd name="adj" fmla="val 8000"/>
+            </a:avLst>
+          </a:prstGeom>
+          <a:solidFill>
+            <a:srgbClr val="102C48"/>
+          </a:solidFill>
+          <a:ln w="15875">
+            <a:solidFill>
+              <a:srgbClr val="2896F0"/>
+            </a:solidFill>
+          </a:ln>
+          <a:effectLst/>
+        </p:spPr>
+        <p:style>
+          <a:lnRef idx="1">
+            <a:schemeClr val="accent1"/>
+          </a:lnRef>
+          <a:fillRef idx="3">
+            <a:schemeClr val="accent1"/>
+          </a:fillRef>
+          <a:effectRef idx="2">
+            <a:schemeClr val="accent1"/>
+          </a:effectRef>
+          <a:fontRef idx="minor">
+            <a:schemeClr val="lt1"/>
+          </a:fontRef>
+        </p:style>
+        <p:txBody>
+          <a:bodyPr rtlCol="0" anchor="ctr" wrap="square" lIns="19050" rIns="19050" tIns="19050" bIns="19050"/>
+          <a:lstStyle/>
+          <a:p>
+            <a:pPr algn="ctr">
+              <a:lnSpc>
+                <a:spcPct val="122000"/>
+              </a:lnSpc>
+            </a:pPr>
+            <a:r>
+              <a:rPr sz="1100" b="1">
+                <a:solidFill>
+                  <a:srgbClr val="F5F5F8"/>
+                </a:solidFill>
+                <a:latin typeface="Amazon Ember"/>
+                <a:ea typeface="メイリオ"/>
+                <a:cs typeface="メイリオ"/>
+              </a:rPr>
+              <a:t>c4a4 ·</a:t>
+            </a:r>
+          </a:p>
+          <a:p>
+            <a:pPr algn="ctr">
+              <a:lnSpc>
+                <a:spcPct val="122000"/>
+              </a:lnSpc>
+            </a:pPr>
+            <a:r>
+              <a:rPr sz="1100" b="1">
+                <a:solidFill>
+                  <a:srgbClr val="F5F5F8"/>
+                </a:solidFill>
+                <a:latin typeface="Amazon Ember"/>
+                <a:ea typeface="メイリオ"/>
+                <a:cs typeface="メイリオ"/>
+              </a:rPr>
+              <a:t>b3</a:t>
+            </a:r>
+          </a:p>
+        </p:txBody>
+      </p:sp>
+      <p:sp>
+        <p:nvSpPr>
+          <p:cNvPr id="35" name="Rounded Rectangle 34"/>
+          <p:cNvSpPr/>
+          <p:nvPr/>
+        </p:nvSpPr>
+        <p:spPr>
+          <a:xfrm>
+            <a:off x="3686175" y="3162300"/>
+            <a:ext cx="857250" cy="476250"/>
+          </a:xfrm>
+          <a:prstGeom prst="roundRect">
+            <a:avLst>
+              <a:gd name="adj" fmla="val 8000"/>
+            </a:avLst>
+          </a:prstGeom>
+          <a:solidFill>
+            <a:srgbClr val="124022"/>
+          </a:solidFill>
+          <a:ln w="15875">
+            <a:solidFill>
+              <a:srgbClr val="24A046"/>
+            </a:solidFill>
+          </a:ln>
+          <a:effectLst/>
+        </p:spPr>
+        <p:style>
+          <a:lnRef idx="1">
+            <a:schemeClr val="accent1"/>
+          </a:lnRef>
+          <a:fillRef idx="3">
+            <a:schemeClr val="accent1"/>
+          </a:fillRef>
+          <a:effectRef idx="2">
+            <a:schemeClr val="accent1"/>
+          </a:effectRef>
+          <a:fontRef idx="minor">
+            <a:schemeClr val="lt1"/>
+          </a:fontRef>
+        </p:style>
+        <p:txBody>
+          <a:bodyPr rtlCol="0" anchor="ctr" wrap="square" lIns="19050" rIns="19050" tIns="19050" bIns="19050"/>
+          <a:lstStyle/>
+          <a:p>
+            <a:pPr algn="ctr">
+              <a:lnSpc>
+                <a:spcPct val="122000"/>
+              </a:lnSpc>
+            </a:pPr>
+            <a:r>
+              <a:rPr sz="1100" b="1">
+                <a:solidFill>
+                  <a:srgbClr val="F5F5F8"/>
+                </a:solidFill>
+                <a:latin typeface="Amazon Ember"/>
+                <a:ea typeface="メイリオ"/>
+                <a:cs typeface="メイリオ"/>
+              </a:rPr>
+              <a:t>c4b4</a:t>
+            </a:r>
+          </a:p>
+        </p:txBody>
+      </p:sp>
+      <p:sp>
+        <p:nvSpPr>
+          <p:cNvPr id="36" name="Rounded Rectangle 35"/>
+          <p:cNvSpPr/>
+          <p:nvPr/>
+        </p:nvSpPr>
+        <p:spPr>
+          <a:xfrm>
+            <a:off x="4581525" y="3162300"/>
+            <a:ext cx="857250" cy="476250"/>
+          </a:xfrm>
+          <a:prstGeom prst="roundRect">
+            <a:avLst>
+              <a:gd name="adj" fmla="val 8000"/>
+            </a:avLst>
+          </a:prstGeom>
+          <a:solidFill>
+            <a:srgbClr val="161A1E"/>
+          </a:solidFill>
+          <a:ln w="15875">
+            <a:solidFill>
+              <a:srgbClr val="464A50"/>
+            </a:solidFill>
+          </a:ln>
+          <a:effectLst/>
+        </p:spPr>
+        <p:style>
+          <a:lnRef idx="1">
+            <a:schemeClr val="accent1"/>
+          </a:lnRef>
+          <a:fillRef idx="3">
+            <a:schemeClr val="accent1"/>
+          </a:fillRef>
+          <a:effectRef idx="2">
+            <a:schemeClr val="accent1"/>
+          </a:effectRef>
+          <a:fontRef idx="minor">
+            <a:schemeClr val="lt1"/>
+          </a:fontRef>
+        </p:style>
+        <p:txBody>
+          <a:bodyPr rtlCol="0" anchor="ctr" wrap="square" lIns="19050" rIns="19050" tIns="19050" bIns="19050"/>
+          <a:lstStyle/>
+          <a:p>
+            <a:pPr algn="ctr">
+              <a:lnSpc>
+                <a:spcPct val="122000"/>
+              </a:lnSpc>
+            </a:pPr>
+            <a:r>
+              <a:rPr sz="1100" b="1">
+                <a:solidFill>
+                  <a:srgbClr val="96969E"/>
+                </a:solidFill>
+                <a:latin typeface="Amazon Ember"/>
+                <a:ea typeface="メイリオ"/>
+                <a:cs typeface="メイリオ"/>
+              </a:rPr>
+              <a:t>0</a:t>
+            </a:r>
+          </a:p>
+        </p:txBody>
+      </p:sp>
+      <p:sp>
+        <p:nvSpPr>
+          <p:cNvPr id="37" name="Rounded Rectangle 36"/>
+          <p:cNvSpPr/>
+          <p:nvPr/>
+        </p:nvSpPr>
+        <p:spPr>
+          <a:xfrm>
+            <a:off x="5476875" y="3162300"/>
+            <a:ext cx="857250" cy="476250"/>
+          </a:xfrm>
+          <a:prstGeom prst="roundRect">
+            <a:avLst>
+              <a:gd name="adj" fmla="val 8000"/>
+            </a:avLst>
+          </a:prstGeom>
+          <a:solidFill>
+            <a:srgbClr val="161A1E"/>
+          </a:solidFill>
+          <a:ln w="15875">
+            <a:solidFill>
+              <a:srgbClr val="464A50"/>
+            </a:solidFill>
+          </a:ln>
+          <a:effectLst/>
+        </p:spPr>
+        <p:style>
+          <a:lnRef idx="1">
+            <a:schemeClr val="accent1"/>
+          </a:lnRef>
+          <a:fillRef idx="3">
+            <a:schemeClr val="accent1"/>
+          </a:fillRef>
+          <a:effectRef idx="2">
+            <a:schemeClr val="accent1"/>
+          </a:effectRef>
+          <a:fontRef idx="minor">
+            <a:schemeClr val="lt1"/>
+          </a:fontRef>
+        </p:style>
+        <p:txBody>
+          <a:bodyPr rtlCol="0" anchor="ctr" wrap="square" lIns="19050" rIns="19050" tIns="19050" bIns="19050"/>
+          <a:lstStyle/>
+          <a:p>
+            <a:pPr algn="ctr">
+              <a:lnSpc>
+                <a:spcPct val="122000"/>
+              </a:lnSpc>
+            </a:pPr>
+            <a:r>
+              <a:rPr sz="1100" b="1">
+                <a:solidFill>
+                  <a:srgbClr val="96969E"/>
+                </a:solidFill>
+                <a:latin typeface="Amazon Ember"/>
+                <a:ea typeface="メイリオ"/>
+                <a:cs typeface="メイリオ"/>
+              </a:rPr>
+              <a:t>0</a:t>
+            </a:r>
+          </a:p>
+        </p:txBody>
+      </p:sp>
+      <p:sp>
+        <p:nvSpPr>
+          <p:cNvPr id="38" name="TextBox 37"/>
+          <p:cNvSpPr txBox="1"/>
+          <p:nvPr/>
+        </p:nvSpPr>
+        <p:spPr>
+          <a:xfrm>
+            <a:off x="447675" y="3657600"/>
+            <a:ext cx="476250" cy="514350"/>
+          </a:xfrm>
+          <a:prstGeom prst="rect">
+            <a:avLst/>
+          </a:prstGeom>
+          <a:noFill/>
+        </p:spPr>
+        <p:txBody>
+          <a:bodyPr wrap="square" lIns="0" rIns="0" tIns="0" bIns="0" anchor="ctr">
+            <a:spAutoFit/>
+          </a:bodyPr>
+          <a:lstStyle/>
+          <a:p>
+            <a:pPr algn="r">
+              <a:lnSpc>
+                <a:spcPct val="122000"/>
+              </a:lnSpc>
+            </a:pPr>
+            <a:r>
+              <a:rPr sz="1400" b="0">
+                <a:solidFill>
+                  <a:srgbClr val="96969E"/>
+                </a:solidFill>
+                <a:latin typeface="Amazon Ember"/>
+                <a:ea typeface="メイリオ"/>
+                <a:cs typeface="メイリオ"/>
+              </a:rPr>
+              <a:t>y5</a:t>
+            </a:r>
+          </a:p>
+        </p:txBody>
+      </p:sp>
+      <p:sp>
+        <p:nvSpPr>
+          <p:cNvPr id="39" name="Rounded Rectangle 38"/>
+          <p:cNvSpPr/>
+          <p:nvPr/>
+        </p:nvSpPr>
+        <p:spPr>
+          <a:xfrm>
+            <a:off x="1000125" y="3676650"/>
+            <a:ext cx="857250" cy="476250"/>
+          </a:xfrm>
+          <a:prstGeom prst="roundRect">
+            <a:avLst>
+              <a:gd name="adj" fmla="val 8000"/>
+            </a:avLst>
+          </a:prstGeom>
+          <a:solidFill>
+            <a:srgbClr val="102C48"/>
+          </a:solidFill>
+          <a:ln w="15875">
+            <a:solidFill>
+              <a:srgbClr val="2896F0"/>
+            </a:solidFill>
+          </a:ln>
+          <a:effectLst/>
+        </p:spPr>
+        <p:style>
+          <a:lnRef idx="1">
+            <a:schemeClr val="accent1"/>
+          </a:lnRef>
+          <a:fillRef idx="3">
+            <a:schemeClr val="accent1"/>
+          </a:fillRef>
+          <a:effectRef idx="2">
+            <a:schemeClr val="accent1"/>
+          </a:effectRef>
+          <a:fontRef idx="minor">
+            <a:schemeClr val="lt1"/>
+          </a:fontRef>
+        </p:style>
+        <p:txBody>
+          <a:bodyPr rtlCol="0" anchor="ctr" wrap="square" lIns="19050" rIns="19050" tIns="19050" bIns="19050"/>
+          <a:lstStyle/>
+          <a:p>
+            <a:pPr algn="ctr">
+              <a:lnSpc>
+                <a:spcPct val="122000"/>
+              </a:lnSpc>
+            </a:pPr>
+            <a:r>
+              <a:rPr sz="1100" b="1">
+                <a:solidFill>
+                  <a:srgbClr val="F5F5F8"/>
+                </a:solidFill>
+                <a:latin typeface="Amazon Ember"/>
+                <a:ea typeface="メイリオ"/>
+                <a:cs typeface="メイリオ"/>
+              </a:rPr>
+              <a:t>c5a5a4 ·</a:t>
+            </a:r>
+          </a:p>
+          <a:p>
+            <a:pPr algn="ctr">
+              <a:lnSpc>
+                <a:spcPct val="122000"/>
+              </a:lnSpc>
+            </a:pPr>
+            <a:r>
+              <a:rPr sz="1100" b="1">
+                <a:solidFill>
+                  <a:srgbClr val="F5F5F8"/>
+                </a:solidFill>
+                <a:latin typeface="Amazon Ember"/>
+                <a:ea typeface="メイリオ"/>
+                <a:cs typeface="メイリオ"/>
+              </a:rPr>
+              <a:t>a3a2b1</a:t>
+            </a:r>
+          </a:p>
+        </p:txBody>
+      </p:sp>
+      <p:sp>
+        <p:nvSpPr>
+          <p:cNvPr id="40" name="Rounded Rectangle 39"/>
+          <p:cNvSpPr/>
+          <p:nvPr/>
+        </p:nvSpPr>
+        <p:spPr>
+          <a:xfrm>
+            <a:off x="1895475" y="3676650"/>
+            <a:ext cx="857250" cy="476250"/>
+          </a:xfrm>
+          <a:prstGeom prst="roundRect">
+            <a:avLst>
+              <a:gd name="adj" fmla="val 8000"/>
+            </a:avLst>
+          </a:prstGeom>
+          <a:solidFill>
+            <a:srgbClr val="102C48"/>
+          </a:solidFill>
+          <a:ln w="15875">
+            <a:solidFill>
+              <a:srgbClr val="2896F0"/>
+            </a:solidFill>
+          </a:ln>
+          <a:effectLst/>
+        </p:spPr>
+        <p:style>
+          <a:lnRef idx="1">
+            <a:schemeClr val="accent1"/>
+          </a:lnRef>
+          <a:fillRef idx="3">
+            <a:schemeClr val="accent1"/>
+          </a:fillRef>
+          <a:effectRef idx="2">
+            <a:schemeClr val="accent1"/>
+          </a:effectRef>
+          <a:fontRef idx="minor">
+            <a:schemeClr val="lt1"/>
+          </a:fontRef>
+        </p:style>
+        <p:txBody>
+          <a:bodyPr rtlCol="0" anchor="ctr" wrap="square" lIns="19050" rIns="19050" tIns="19050" bIns="19050"/>
+          <a:lstStyle/>
+          <a:p>
+            <a:pPr algn="ctr">
+              <a:lnSpc>
+                <a:spcPct val="122000"/>
+              </a:lnSpc>
+            </a:pPr>
+            <a:r>
+              <a:rPr sz="1100" b="1">
+                <a:solidFill>
+                  <a:srgbClr val="F5F5F8"/>
+                </a:solidFill>
+                <a:latin typeface="Amazon Ember"/>
+                <a:ea typeface="メイリオ"/>
+                <a:cs typeface="メイリオ"/>
+              </a:rPr>
+              <a:t>c5a5a4 ·</a:t>
+            </a:r>
+          </a:p>
+          <a:p>
+            <a:pPr algn="ctr">
+              <a:lnSpc>
+                <a:spcPct val="122000"/>
+              </a:lnSpc>
+            </a:pPr>
+            <a:r>
+              <a:rPr sz="1100" b="1">
+                <a:solidFill>
+                  <a:srgbClr val="F5F5F8"/>
+                </a:solidFill>
+                <a:latin typeface="Amazon Ember"/>
+                <a:ea typeface="メイリオ"/>
+                <a:cs typeface="メイリオ"/>
+              </a:rPr>
+              <a:t>a3b2</a:t>
+            </a:r>
+          </a:p>
+        </p:txBody>
+      </p:sp>
+      <p:sp>
+        <p:nvSpPr>
+          <p:cNvPr id="41" name="Rounded Rectangle 40"/>
+          <p:cNvSpPr/>
+          <p:nvPr/>
+        </p:nvSpPr>
+        <p:spPr>
+          <a:xfrm>
+            <a:off x="2790825" y="3676650"/>
+            <a:ext cx="857250" cy="476250"/>
+          </a:xfrm>
+          <a:prstGeom prst="roundRect">
+            <a:avLst>
+              <a:gd name="adj" fmla="val 8000"/>
+            </a:avLst>
+          </a:prstGeom>
+          <a:solidFill>
+            <a:srgbClr val="102C48"/>
+          </a:solidFill>
+          <a:ln w="15875">
+            <a:solidFill>
+              <a:srgbClr val="2896F0"/>
+            </a:solidFill>
+          </a:ln>
+          <a:effectLst/>
+        </p:spPr>
+        <p:style>
+          <a:lnRef idx="1">
+            <a:schemeClr val="accent1"/>
+          </a:lnRef>
+          <a:fillRef idx="3">
+            <a:schemeClr val="accent1"/>
+          </a:fillRef>
+          <a:effectRef idx="2">
+            <a:schemeClr val="accent1"/>
+          </a:effectRef>
+          <a:fontRef idx="minor">
+            <a:schemeClr val="lt1"/>
+          </a:fontRef>
+        </p:style>
+        <p:txBody>
+          <a:bodyPr rtlCol="0" anchor="ctr" wrap="square" lIns="19050" rIns="19050" tIns="19050" bIns="19050"/>
+          <a:lstStyle/>
+          <a:p>
+            <a:pPr algn="ctr">
+              <a:lnSpc>
+                <a:spcPct val="122000"/>
+              </a:lnSpc>
+            </a:pPr>
+            <a:r>
+              <a:rPr sz="1100" b="1">
+                <a:solidFill>
+                  <a:srgbClr val="F5F5F8"/>
+                </a:solidFill>
+                <a:latin typeface="Amazon Ember"/>
+                <a:ea typeface="メイリオ"/>
+                <a:cs typeface="メイリオ"/>
+              </a:rPr>
+              <a:t>c5a5a4 ·</a:t>
+            </a:r>
+          </a:p>
+          <a:p>
+            <a:pPr algn="ctr">
+              <a:lnSpc>
+                <a:spcPct val="122000"/>
+              </a:lnSpc>
+            </a:pPr>
+            <a:r>
+              <a:rPr sz="1100" b="1">
+                <a:solidFill>
+                  <a:srgbClr val="F5F5F8"/>
+                </a:solidFill>
+                <a:latin typeface="Amazon Ember"/>
+                <a:ea typeface="メイリオ"/>
+                <a:cs typeface="メイリオ"/>
+              </a:rPr>
+              <a:t>b3</a:t>
+            </a:r>
+          </a:p>
+        </p:txBody>
+      </p:sp>
+      <p:sp>
+        <p:nvSpPr>
+          <p:cNvPr id="42" name="Rounded Rectangle 41"/>
+          <p:cNvSpPr/>
+          <p:nvPr/>
+        </p:nvSpPr>
+        <p:spPr>
+          <a:xfrm>
+            <a:off x="3686175" y="3676650"/>
+            <a:ext cx="857250" cy="476250"/>
+          </a:xfrm>
+          <a:prstGeom prst="roundRect">
+            <a:avLst>
+              <a:gd name="adj" fmla="val 8000"/>
+            </a:avLst>
+          </a:prstGeom>
+          <a:solidFill>
+            <a:srgbClr val="124022"/>
+          </a:solidFill>
+          <a:ln w="15875">
+            <a:solidFill>
+              <a:srgbClr val="24A046"/>
+            </a:solidFill>
+          </a:ln>
+          <a:effectLst/>
+        </p:spPr>
+        <p:style>
+          <a:lnRef idx="1">
+            <a:schemeClr val="accent1"/>
+          </a:lnRef>
+          <a:fillRef idx="3">
+            <a:schemeClr val="accent1"/>
+          </a:fillRef>
+          <a:effectRef idx="2">
+            <a:schemeClr val="accent1"/>
+          </a:effectRef>
+          <a:fontRef idx="minor">
+            <a:schemeClr val="lt1"/>
+          </a:fontRef>
+        </p:style>
+        <p:txBody>
+          <a:bodyPr rtlCol="0" anchor="ctr" wrap="square" lIns="19050" rIns="19050" tIns="19050" bIns="19050"/>
+          <a:lstStyle/>
+          <a:p>
+            <a:pPr algn="ctr">
+              <a:lnSpc>
+                <a:spcPct val="122000"/>
+              </a:lnSpc>
+            </a:pPr>
+            <a:r>
+              <a:rPr sz="1100" b="1">
+                <a:solidFill>
+                  <a:srgbClr val="F5F5F8"/>
+                </a:solidFill>
+                <a:latin typeface="Amazon Ember"/>
+                <a:ea typeface="メイリオ"/>
+                <a:cs typeface="メイリオ"/>
+              </a:rPr>
+              <a:t>c5a5b4</a:t>
+            </a:r>
+          </a:p>
+        </p:txBody>
+      </p:sp>
+      <p:sp>
+        <p:nvSpPr>
+          <p:cNvPr id="43" name="Rounded Rectangle 42"/>
+          <p:cNvSpPr/>
+          <p:nvPr/>
+        </p:nvSpPr>
+        <p:spPr>
+          <a:xfrm>
+            <a:off x="4581525" y="3676650"/>
+            <a:ext cx="857250" cy="476250"/>
+          </a:xfrm>
+          <a:prstGeom prst="roundRect">
+            <a:avLst>
+              <a:gd name="adj" fmla="val 8000"/>
+            </a:avLst>
+          </a:prstGeom>
+          <a:solidFill>
+            <a:srgbClr val="124022"/>
+          </a:solidFill>
+          <a:ln w="15875">
+            <a:solidFill>
+              <a:srgbClr val="24A046"/>
+            </a:solidFill>
+          </a:ln>
+          <a:effectLst/>
+        </p:spPr>
+        <p:style>
+          <a:lnRef idx="1">
+            <a:schemeClr val="accent1"/>
+          </a:lnRef>
+          <a:fillRef idx="3">
+            <a:schemeClr val="accent1"/>
+          </a:fillRef>
+          <a:effectRef idx="2">
+            <a:schemeClr val="accent1"/>
+          </a:effectRef>
+          <a:fontRef idx="minor">
+            <a:schemeClr val="lt1"/>
+          </a:fontRef>
+        </p:style>
+        <p:txBody>
+          <a:bodyPr rtlCol="0" anchor="ctr" wrap="square" lIns="19050" rIns="19050" tIns="19050" bIns="19050"/>
+          <a:lstStyle/>
+          <a:p>
+            <a:pPr algn="ctr">
+              <a:lnSpc>
+                <a:spcPct val="122000"/>
+              </a:lnSpc>
+            </a:pPr>
+            <a:r>
+              <a:rPr sz="1100" b="1">
+                <a:solidFill>
+                  <a:srgbClr val="F5F5F8"/>
+                </a:solidFill>
+                <a:latin typeface="Amazon Ember"/>
+                <a:ea typeface="メイリオ"/>
+                <a:cs typeface="メイリオ"/>
+              </a:rPr>
+              <a:t>c5b5</a:t>
+            </a:r>
+          </a:p>
+        </p:txBody>
+      </p:sp>
+      <p:sp>
+        <p:nvSpPr>
+          <p:cNvPr id="44" name="Rounded Rectangle 43"/>
+          <p:cNvSpPr/>
+          <p:nvPr/>
+        </p:nvSpPr>
+        <p:spPr>
+          <a:xfrm>
+            <a:off x="5476875" y="3676650"/>
+            <a:ext cx="857250" cy="476250"/>
+          </a:xfrm>
+          <a:prstGeom prst="roundRect">
+            <a:avLst>
+              <a:gd name="adj" fmla="val 8000"/>
+            </a:avLst>
+          </a:prstGeom>
+          <a:solidFill>
+            <a:srgbClr val="161A1E"/>
+          </a:solidFill>
+          <a:ln w="15875">
+            <a:solidFill>
+              <a:srgbClr val="464A50"/>
+            </a:solidFill>
+          </a:ln>
+          <a:effectLst/>
+        </p:spPr>
+        <p:style>
+          <a:lnRef idx="1">
+            <a:schemeClr val="accent1"/>
+          </a:lnRef>
+          <a:fillRef idx="3">
+            <a:schemeClr val="accent1"/>
+          </a:fillRef>
+          <a:effectRef idx="2">
+            <a:schemeClr val="accent1"/>
+          </a:effectRef>
+          <a:fontRef idx="minor">
+            <a:schemeClr val="lt1"/>
+          </a:fontRef>
+        </p:style>
+        <p:txBody>
+          <a:bodyPr rtlCol="0" anchor="ctr" wrap="square" lIns="19050" rIns="19050" tIns="19050" bIns="19050"/>
+          <a:lstStyle/>
+          <a:p>
+            <a:pPr algn="ctr">
+              <a:lnSpc>
+                <a:spcPct val="122000"/>
+              </a:lnSpc>
+            </a:pPr>
+            <a:r>
+              <a:rPr sz="1100" b="1">
+                <a:solidFill>
+                  <a:srgbClr val="96969E"/>
+                </a:solidFill>
+                <a:latin typeface="Amazon Ember"/>
+                <a:ea typeface="メイリオ"/>
+                <a:cs typeface="メイリオ"/>
+              </a:rPr>
+              <a:t>0</a:t>
+            </a:r>
+          </a:p>
+        </p:txBody>
+      </p:sp>
+      <p:sp>
+        <p:nvSpPr>
+          <p:cNvPr id="45" name="TextBox 44"/>
+          <p:cNvSpPr txBox="1"/>
+          <p:nvPr/>
+        </p:nvSpPr>
+        <p:spPr>
+          <a:xfrm>
+            <a:off x="447675" y="4171950"/>
+            <a:ext cx="476250" cy="514350"/>
+          </a:xfrm>
+          <a:prstGeom prst="rect">
+            <a:avLst/>
+          </a:prstGeom>
+          <a:noFill/>
+        </p:spPr>
+        <p:txBody>
+          <a:bodyPr wrap="square" lIns="0" rIns="0" tIns="0" bIns="0" anchor="ctr">
+            <a:spAutoFit/>
+          </a:bodyPr>
+          <a:lstStyle/>
+          <a:p>
+            <a:pPr algn="r">
+              <a:lnSpc>
+                <a:spcPct val="122000"/>
+              </a:lnSpc>
+            </a:pPr>
+            <a:r>
+              <a:rPr sz="1400" b="0">
+                <a:solidFill>
+                  <a:srgbClr val="96969E"/>
+                </a:solidFill>
+                <a:latin typeface="Amazon Ember"/>
+                <a:ea typeface="メイリオ"/>
+                <a:cs typeface="メイリオ"/>
+              </a:rPr>
+              <a:t>y6</a:t>
+            </a:r>
+          </a:p>
+        </p:txBody>
+      </p:sp>
+      <p:sp>
+        <p:nvSpPr>
+          <p:cNvPr id="46" name="Rounded Rectangle 45"/>
+          <p:cNvSpPr/>
+          <p:nvPr/>
+        </p:nvSpPr>
+        <p:spPr>
+          <a:xfrm>
+            <a:off x="1000125" y="4191000"/>
+            <a:ext cx="857250" cy="476250"/>
+          </a:xfrm>
+          <a:prstGeom prst="roundRect">
+            <a:avLst>
+              <a:gd name="adj" fmla="val 8000"/>
+            </a:avLst>
+          </a:prstGeom>
+          <a:solidFill>
+            <a:srgbClr val="102C48"/>
+          </a:solidFill>
+          <a:ln w="15875">
+            <a:solidFill>
+              <a:srgbClr val="2896F0"/>
+            </a:solidFill>
+          </a:ln>
+          <a:effectLst/>
+        </p:spPr>
+        <p:style>
+          <a:lnRef idx="1">
+            <a:schemeClr val="accent1"/>
+          </a:lnRef>
+          <a:fillRef idx="3">
+            <a:schemeClr val="accent1"/>
+          </a:fillRef>
+          <a:effectRef idx="2">
+            <a:schemeClr val="accent1"/>
+          </a:effectRef>
+          <a:fontRef idx="minor">
+            <a:schemeClr val="lt1"/>
+          </a:fontRef>
+        </p:style>
+        <p:txBody>
+          <a:bodyPr rtlCol="0" anchor="ctr" wrap="square" lIns="19050" rIns="19050" tIns="19050" bIns="19050"/>
+          <a:lstStyle/>
+          <a:p>
+            <a:pPr algn="ctr">
+              <a:lnSpc>
+                <a:spcPct val="122000"/>
+              </a:lnSpc>
+            </a:pPr>
+            <a:r>
+              <a:rPr sz="1100" b="1">
+                <a:solidFill>
+                  <a:srgbClr val="F5F5F8"/>
+                </a:solidFill>
+                <a:latin typeface="Amazon Ember"/>
+                <a:ea typeface="メイリオ"/>
+                <a:cs typeface="メイリオ"/>
+              </a:rPr>
+              <a:t>c6a6a5a4 ·</a:t>
+            </a:r>
+          </a:p>
+          <a:p>
+            <a:pPr algn="ctr">
+              <a:lnSpc>
+                <a:spcPct val="122000"/>
+              </a:lnSpc>
+            </a:pPr>
+            <a:r>
+              <a:rPr sz="1100" b="1">
+                <a:solidFill>
+                  <a:srgbClr val="F5F5F8"/>
+                </a:solidFill>
+                <a:latin typeface="Amazon Ember"/>
+                <a:ea typeface="メイリオ"/>
+                <a:cs typeface="メイリオ"/>
+              </a:rPr>
+              <a:t>a3a2b1</a:t>
+            </a:r>
+          </a:p>
+        </p:txBody>
+      </p:sp>
+      <p:sp>
+        <p:nvSpPr>
+          <p:cNvPr id="47" name="Rounded Rectangle 46"/>
+          <p:cNvSpPr/>
+          <p:nvPr/>
+        </p:nvSpPr>
+        <p:spPr>
+          <a:xfrm>
+            <a:off x="1895475" y="4191000"/>
+            <a:ext cx="857250" cy="476250"/>
+          </a:xfrm>
+          <a:prstGeom prst="roundRect">
+            <a:avLst>
+              <a:gd name="adj" fmla="val 8000"/>
+            </a:avLst>
+          </a:prstGeom>
+          <a:solidFill>
+            <a:srgbClr val="102C48"/>
+          </a:solidFill>
+          <a:ln w="15875">
+            <a:solidFill>
+              <a:srgbClr val="2896F0"/>
+            </a:solidFill>
+          </a:ln>
+          <a:effectLst/>
+        </p:spPr>
+        <p:style>
+          <a:lnRef idx="1">
+            <a:schemeClr val="accent1"/>
+          </a:lnRef>
+          <a:fillRef idx="3">
+            <a:schemeClr val="accent1"/>
+          </a:fillRef>
+          <a:effectRef idx="2">
+            <a:schemeClr val="accent1"/>
+          </a:effectRef>
+          <a:fontRef idx="minor">
+            <a:schemeClr val="lt1"/>
+          </a:fontRef>
+        </p:style>
+        <p:txBody>
+          <a:bodyPr rtlCol="0" anchor="ctr" wrap="square" lIns="19050" rIns="19050" tIns="19050" bIns="19050"/>
+          <a:lstStyle/>
+          <a:p>
+            <a:pPr algn="ctr">
+              <a:lnSpc>
+                <a:spcPct val="122000"/>
+              </a:lnSpc>
+            </a:pPr>
+            <a:r>
+              <a:rPr sz="1100" b="1">
+                <a:solidFill>
+                  <a:srgbClr val="F5F5F8"/>
+                </a:solidFill>
+                <a:latin typeface="Amazon Ember"/>
+                <a:ea typeface="メイリオ"/>
+                <a:cs typeface="メイリオ"/>
+              </a:rPr>
+              <a:t>c6a6a5a4 ·</a:t>
+            </a:r>
+          </a:p>
+          <a:p>
+            <a:pPr algn="ctr">
+              <a:lnSpc>
+                <a:spcPct val="122000"/>
+              </a:lnSpc>
+            </a:pPr>
+            <a:r>
+              <a:rPr sz="1100" b="1">
+                <a:solidFill>
+                  <a:srgbClr val="F5F5F8"/>
+                </a:solidFill>
+                <a:latin typeface="Amazon Ember"/>
+                <a:ea typeface="メイリオ"/>
+                <a:cs typeface="メイリオ"/>
+              </a:rPr>
+              <a:t>a3b2</a:t>
+            </a:r>
+          </a:p>
+        </p:txBody>
+      </p:sp>
+      <p:sp>
+        <p:nvSpPr>
+          <p:cNvPr id="48" name="Rounded Rectangle 47"/>
+          <p:cNvSpPr/>
+          <p:nvPr/>
+        </p:nvSpPr>
+        <p:spPr>
+          <a:xfrm>
+            <a:off x="2790825" y="4191000"/>
+            <a:ext cx="857250" cy="476250"/>
+          </a:xfrm>
+          <a:prstGeom prst="roundRect">
+            <a:avLst>
+              <a:gd name="adj" fmla="val 8000"/>
+            </a:avLst>
+          </a:prstGeom>
+          <a:solidFill>
+            <a:srgbClr val="102C48"/>
+          </a:solidFill>
+          <a:ln w="15875">
+            <a:solidFill>
+              <a:srgbClr val="2896F0"/>
+            </a:solidFill>
+          </a:ln>
+          <a:effectLst/>
+        </p:spPr>
+        <p:style>
+          <a:lnRef idx="1">
+            <a:schemeClr val="accent1"/>
+          </a:lnRef>
+          <a:fillRef idx="3">
+            <a:schemeClr val="accent1"/>
+          </a:fillRef>
+          <a:effectRef idx="2">
+            <a:schemeClr val="accent1"/>
+          </a:effectRef>
+          <a:fontRef idx="minor">
+            <a:schemeClr val="lt1"/>
+          </a:fontRef>
+        </p:style>
+        <p:txBody>
+          <a:bodyPr rtlCol="0" anchor="ctr" wrap="square" lIns="19050" rIns="19050" tIns="19050" bIns="19050"/>
+          <a:lstStyle/>
+          <a:p>
+            <a:pPr algn="ctr">
+              <a:lnSpc>
+                <a:spcPct val="122000"/>
+              </a:lnSpc>
+            </a:pPr>
+            <a:r>
+              <a:rPr sz="1100" b="1">
+                <a:solidFill>
+                  <a:srgbClr val="F5F5F8"/>
+                </a:solidFill>
+                <a:latin typeface="Amazon Ember"/>
+                <a:ea typeface="メイリオ"/>
+                <a:cs typeface="メイリオ"/>
+              </a:rPr>
+              <a:t>c6a6a5a4 ·</a:t>
+            </a:r>
+          </a:p>
+          <a:p>
+            <a:pPr algn="ctr">
+              <a:lnSpc>
+                <a:spcPct val="122000"/>
+              </a:lnSpc>
+            </a:pPr>
+            <a:r>
+              <a:rPr sz="1100" b="1">
+                <a:solidFill>
+                  <a:srgbClr val="F5F5F8"/>
+                </a:solidFill>
+                <a:latin typeface="Amazon Ember"/>
+                <a:ea typeface="メイリオ"/>
+                <a:cs typeface="メイリオ"/>
+              </a:rPr>
+              <a:t>b3</a:t>
+            </a:r>
+          </a:p>
+        </p:txBody>
+      </p:sp>
+      <p:sp>
+        <p:nvSpPr>
+          <p:cNvPr id="49" name="Rounded Rectangle 48"/>
+          <p:cNvSpPr/>
+          <p:nvPr/>
+        </p:nvSpPr>
+        <p:spPr>
+          <a:xfrm>
+            <a:off x="3686175" y="4191000"/>
+            <a:ext cx="857250" cy="476250"/>
+          </a:xfrm>
+          <a:prstGeom prst="roundRect">
+            <a:avLst>
+              <a:gd name="adj" fmla="val 8000"/>
+            </a:avLst>
+          </a:prstGeom>
+          <a:solidFill>
+            <a:srgbClr val="124022"/>
+          </a:solidFill>
+          <a:ln w="15875">
+            <a:solidFill>
+              <a:srgbClr val="24A046"/>
+            </a:solidFill>
+          </a:ln>
+          <a:effectLst/>
+        </p:spPr>
+        <p:style>
+          <a:lnRef idx="1">
+            <a:schemeClr val="accent1"/>
+          </a:lnRef>
+          <a:fillRef idx="3">
+            <a:schemeClr val="accent1"/>
+          </a:fillRef>
+          <a:effectRef idx="2">
+            <a:schemeClr val="accent1"/>
+          </a:effectRef>
+          <a:fontRef idx="minor">
+            <a:schemeClr val="lt1"/>
+          </a:fontRef>
+        </p:style>
+        <p:txBody>
+          <a:bodyPr rtlCol="0" anchor="ctr" wrap="square" lIns="19050" rIns="19050" tIns="19050" bIns="19050"/>
+          <a:lstStyle/>
+          <a:p>
+            <a:pPr algn="ctr">
+              <a:lnSpc>
+                <a:spcPct val="122000"/>
+              </a:lnSpc>
+            </a:pPr>
+            <a:r>
+              <a:rPr sz="1100" b="1">
+                <a:solidFill>
+                  <a:srgbClr val="F5F5F8"/>
+                </a:solidFill>
+                <a:latin typeface="Amazon Ember"/>
+                <a:ea typeface="メイリオ"/>
+                <a:cs typeface="メイリオ"/>
+              </a:rPr>
+              <a:t>c6a6a5b4</a:t>
+            </a:r>
+          </a:p>
+        </p:txBody>
+      </p:sp>
+      <p:sp>
+        <p:nvSpPr>
+          <p:cNvPr id="50" name="Rounded Rectangle 49"/>
+          <p:cNvSpPr/>
+          <p:nvPr/>
+        </p:nvSpPr>
+        <p:spPr>
+          <a:xfrm>
+            <a:off x="4581525" y="4191000"/>
+            <a:ext cx="857250" cy="476250"/>
+          </a:xfrm>
+          <a:prstGeom prst="roundRect">
+            <a:avLst>
+              <a:gd name="adj" fmla="val 8000"/>
+            </a:avLst>
+          </a:prstGeom>
+          <a:solidFill>
+            <a:srgbClr val="124022"/>
+          </a:solidFill>
+          <a:ln w="15875">
+            <a:solidFill>
+              <a:srgbClr val="24A046"/>
+            </a:solidFill>
+          </a:ln>
+          <a:effectLst/>
+        </p:spPr>
+        <p:style>
+          <a:lnRef idx="1">
+            <a:schemeClr val="accent1"/>
+          </a:lnRef>
+          <a:fillRef idx="3">
+            <a:schemeClr val="accent1"/>
+          </a:fillRef>
+          <a:effectRef idx="2">
+            <a:schemeClr val="accent1"/>
+          </a:effectRef>
+          <a:fontRef idx="minor">
+            <a:schemeClr val="lt1"/>
+          </a:fontRef>
+        </p:style>
+        <p:txBody>
+          <a:bodyPr rtlCol="0" anchor="ctr" wrap="square" lIns="19050" rIns="19050" tIns="19050" bIns="19050"/>
+          <a:lstStyle/>
+          <a:p>
+            <a:pPr algn="ctr">
+              <a:lnSpc>
+                <a:spcPct val="122000"/>
+              </a:lnSpc>
+            </a:pPr>
+            <a:r>
+              <a:rPr sz="1100" b="1">
+                <a:solidFill>
+                  <a:srgbClr val="F5F5F8"/>
+                </a:solidFill>
+                <a:latin typeface="Amazon Ember"/>
+                <a:ea typeface="メイリオ"/>
+                <a:cs typeface="メイリオ"/>
+              </a:rPr>
+              <a:t>c6a6b5</a:t>
+            </a:r>
+          </a:p>
+        </p:txBody>
+      </p:sp>
+      <p:sp>
+        <p:nvSpPr>
+          <p:cNvPr id="51" name="Rounded Rectangle 50"/>
+          <p:cNvSpPr/>
+          <p:nvPr/>
+        </p:nvSpPr>
+        <p:spPr>
+          <a:xfrm>
+            <a:off x="5476875" y="4191000"/>
+            <a:ext cx="857250" cy="476250"/>
+          </a:xfrm>
+          <a:prstGeom prst="roundRect">
+            <a:avLst>
+              <a:gd name="adj" fmla="val 8000"/>
+            </a:avLst>
+          </a:prstGeom>
+          <a:solidFill>
+            <a:srgbClr val="124022"/>
+          </a:solidFill>
+          <a:ln w="15875">
+            <a:solidFill>
+              <a:srgbClr val="24A046"/>
+            </a:solidFill>
+          </a:ln>
+          <a:effectLst/>
+        </p:spPr>
+        <p:style>
+          <a:lnRef idx="1">
+            <a:schemeClr val="accent1"/>
+          </a:lnRef>
+          <a:fillRef idx="3">
+            <a:schemeClr val="accent1"/>
+          </a:fillRef>
+          <a:effectRef idx="2">
+            <a:schemeClr val="accent1"/>
+          </a:effectRef>
+          <a:fontRef idx="minor">
+            <a:schemeClr val="lt1"/>
+          </a:fontRef>
+        </p:style>
+        <p:txBody>
+          <a:bodyPr rtlCol="0" anchor="ctr" wrap="square" lIns="19050" rIns="19050" tIns="19050" bIns="19050"/>
+          <a:lstStyle/>
+          <a:p>
+            <a:pPr algn="ctr">
+              <a:lnSpc>
+                <a:spcPct val="122000"/>
+              </a:lnSpc>
+            </a:pPr>
+            <a:r>
+              <a:rPr sz="1100" b="1">
+                <a:solidFill>
+                  <a:srgbClr val="F5F5F8"/>
+                </a:solidFill>
+                <a:latin typeface="Amazon Ember"/>
+                <a:ea typeface="メイリオ"/>
+                <a:cs typeface="メイリオ"/>
+              </a:rPr>
+              <a:t>c6b6</a:t>
+            </a:r>
+          </a:p>
+        </p:txBody>
+      </p:sp>
+      <p:sp>
+        <p:nvSpPr>
+          <p:cNvPr id="52" name="TextBox 51"/>
+          <p:cNvSpPr txBox="1"/>
+          <p:nvPr/>
+        </p:nvSpPr>
+        <p:spPr>
+          <a:xfrm>
+            <a:off x="981075" y="4724400"/>
+            <a:ext cx="5372100" cy="419100"/>
+          </a:xfrm>
+          <a:prstGeom prst="rect">
+            <a:avLst/>
+          </a:prstGeom>
+          <a:noFill/>
+        </p:spPr>
+        <p:txBody>
+          <a:bodyPr wrap="square" lIns="0" rIns="0" tIns="0" bIns="0" anchor="ctr">
+            <a:spAutoFit/>
+          </a:bodyPr>
+          <a:lstStyle/>
+          <a:p>
+            <a:pPr algn="ctr">
+              <a:lnSpc>
+                <a:spcPct val="122000"/>
+              </a:lnSpc>
+            </a:pPr>
+            <a:r>
+              <a:rPr sz="1300" b="0">
+                <a:solidFill>
+                  <a:srgbClr val="96969E"/>
+                </a:solidFill>
+                <a:latin typeface="Amazon Ember"/>
+                <a:ea typeface="メイリオ"/>
+                <a:cs typeface="メイリオ"/>
+              </a:rPr>
+              <a:t>row i, column j: how much x_j reaches y_i</a:t>
+            </a:r>
+          </a:p>
+          <a:p>
+            <a:pPr algn="ctr">
+              <a:lnSpc>
+                <a:spcPct val="122000"/>
+              </a:lnSpc>
+            </a:pPr>
+            <a:r>
+              <a:rPr sz="1300" b="0">
+                <a:solidFill>
+                  <a:srgbClr val="96969E"/>
+                </a:solidFill>
+                <a:latin typeface="Amazon Ember"/>
+                <a:ea typeface="メイリオ"/>
+                <a:cs typeface="メイリオ"/>
+              </a:rPr>
+              <a:t>blue cells: top line depends only on the row, bottom only on the column</a:t>
+            </a:r>
+          </a:p>
+        </p:txBody>
+      </p:sp>
+      <p:sp>
+        <p:nvSpPr>
+          <p:cNvPr id="53" name="Rounded Rectangle 52"/>
+          <p:cNvSpPr/>
+          <p:nvPr/>
+        </p:nvSpPr>
+        <p:spPr>
+          <a:xfrm>
+            <a:off x="6667500" y="1333500"/>
+            <a:ext cx="5114925" cy="876300"/>
+          </a:xfrm>
+          <a:prstGeom prst="roundRect">
+            <a:avLst>
+              <a:gd name="adj" fmla="val 8000"/>
+            </a:avLst>
+          </a:prstGeom>
+          <a:solidFill>
+            <a:srgbClr val="161A1E"/>
+          </a:solidFill>
+          <a:ln w="15875">
+            <a:solidFill>
+              <a:srgbClr val="464A50"/>
+            </a:solidFill>
+          </a:ln>
+          <a:effectLst/>
+        </p:spPr>
+        <p:style>
+          <a:lnRef idx="1">
+            <a:schemeClr val="accent1"/>
+          </a:lnRef>
+          <a:fillRef idx="3">
+            <a:schemeClr val="accent1"/>
+          </a:fillRef>
+          <a:effectRef idx="2">
+            <a:schemeClr val="accent1"/>
+          </a:effectRef>
+          <a:fontRef idx="minor">
+            <a:schemeClr val="lt1"/>
+          </a:fontRef>
+        </p:style>
+        <p:txBody>
+          <a:bodyPr rtlCol="0" anchor="ctr" wrap="square" lIns="19050" rIns="19050" tIns="19050" bIns="19050"/>
+          <a:lstStyle/>
+          <a:p>
+            <a:pPr algn="ctr">
+              <a:lnSpc>
+                <a:spcPct val="122000"/>
+              </a:lnSpc>
+            </a:pPr>
+            <a:r>
+              <a:rPr sz="1400" b="1">
+                <a:solidFill>
+                  <a:srgbClr val="F5F5F8"/>
+                </a:solidFill>
+                <a:latin typeface="Amazon Ember"/>
+                <a:ea typeface="メイリオ"/>
+                <a:cs typeface="メイリオ"/>
+              </a:rPr>
+              <a:t>entry = c_i · a_i ... a_(j+1) · b_j</a:t>
+            </a:r>
+          </a:p>
+          <a:p>
+            <a:pPr algn="ctr">
+              <a:lnSpc>
+                <a:spcPct val="122000"/>
+              </a:lnSpc>
+            </a:pPr>
+            <a:r>
+              <a:rPr sz="1400" b="1">
+                <a:solidFill>
+                  <a:srgbClr val="F5F5F8"/>
+                </a:solidFill>
+                <a:latin typeface="Amazon Ember"/>
+                <a:ea typeface="メイリオ"/>
+                <a:cs typeface="メイリオ"/>
+              </a:rPr>
+              <a:t>zero above the diagonal: the future never reaches the past</a:t>
+            </a:r>
+          </a:p>
+        </p:txBody>
+      </p:sp>
+      <p:sp>
+        <p:nvSpPr>
+          <p:cNvPr id="54" name="Rounded Rectangle 53"/>
+          <p:cNvSpPr/>
+          <p:nvPr/>
+        </p:nvSpPr>
+        <p:spPr>
+          <a:xfrm>
+            <a:off x="6667500" y="2324100"/>
+            <a:ext cx="5114925" cy="876300"/>
+          </a:xfrm>
+          <a:prstGeom prst="roundRect">
+            <a:avLst>
+              <a:gd name="adj" fmla="val 8000"/>
+            </a:avLst>
+          </a:prstGeom>
+          <a:solidFill>
+            <a:srgbClr val="124022"/>
+          </a:solidFill>
+          <a:ln w="15875">
+            <a:solidFill>
+              <a:srgbClr val="24A046"/>
+            </a:solidFill>
+          </a:ln>
+          <a:effectLst/>
+        </p:spPr>
+        <p:style>
+          <a:lnRef idx="1">
+            <a:schemeClr val="accent1"/>
+          </a:lnRef>
+          <a:fillRef idx="3">
+            <a:schemeClr val="accent1"/>
+          </a:fillRef>
+          <a:effectRef idx="2">
+            <a:schemeClr val="accent1"/>
+          </a:effectRef>
+          <a:fontRef idx="minor">
+            <a:schemeClr val="lt1"/>
+          </a:fontRef>
+        </p:style>
+        <p:txBody>
+          <a:bodyPr rtlCol="0" anchor="ctr" wrap="square" lIns="19050" rIns="19050" tIns="19050" bIns="19050"/>
+          <a:lstStyle/>
+          <a:p>
+            <a:pPr algn="ctr">
+              <a:lnSpc>
+                <a:spcPct val="122000"/>
+              </a:lnSpc>
+            </a:pPr>
+            <a:r>
+              <a:rPr sz="1400" b="1">
+                <a:solidFill>
+                  <a:srgbClr val="F5F5F8"/>
+                </a:solidFill>
+                <a:latin typeface="Amazon Ember"/>
+                <a:ea typeface="メイリオ"/>
+                <a:cs typeface="メイリオ"/>
+              </a:rPr>
+              <a:t>green, inside a chunk: built as a small</a:t>
+            </a:r>
+          </a:p>
+          <a:p>
+            <a:pPr algn="ctr">
+              <a:lnSpc>
+                <a:spcPct val="122000"/>
+              </a:lnSpc>
+            </a:pPr>
+            <a:r>
+              <a:rPr sz="1400" b="1">
+                <a:solidFill>
+                  <a:srgbClr val="F5F5F8"/>
+                </a:solidFill>
+                <a:latin typeface="Amazon Ember"/>
+                <a:ea typeface="メイリオ"/>
+                <a:cs typeface="メイリオ"/>
+              </a:rPr>
+              <a:t>triangle matrix, exactly as in way 2</a:t>
+            </a:r>
+          </a:p>
+        </p:txBody>
+      </p:sp>
+      <p:sp>
+        <p:nvSpPr>
+          <p:cNvPr id="55" name="Rounded Rectangle 54"/>
+          <p:cNvSpPr/>
+          <p:nvPr/>
+        </p:nvSpPr>
+        <p:spPr>
+          <a:xfrm>
+            <a:off x="6667500" y="3314700"/>
+            <a:ext cx="5114925" cy="1257300"/>
+          </a:xfrm>
+          <a:prstGeom prst="roundRect">
+            <a:avLst>
+              <a:gd name="adj" fmla="val 8000"/>
+            </a:avLst>
+          </a:prstGeom>
+          <a:solidFill>
+            <a:srgbClr val="102C48"/>
+          </a:solidFill>
+          <a:ln w="15875">
+            <a:solidFill>
+              <a:srgbClr val="2896F0"/>
+            </a:solidFill>
+          </a:ln>
+          <a:effectLst/>
+        </p:spPr>
+        <p:style>
+          <a:lnRef idx="1">
+            <a:schemeClr val="accent1"/>
+          </a:lnRef>
+          <a:fillRef idx="3">
+            <a:schemeClr val="accent1"/>
+          </a:fillRef>
+          <a:effectRef idx="2">
+            <a:schemeClr val="accent1"/>
+          </a:effectRef>
+          <a:fontRef idx="minor">
+            <a:schemeClr val="lt1"/>
+          </a:fontRef>
+        </p:style>
+        <p:txBody>
+          <a:bodyPr rtlCol="0" anchor="ctr" wrap="square" lIns="19050" rIns="19050" tIns="19050" bIns="19050"/>
+          <a:lstStyle/>
+          <a:p>
+            <a:pPr algn="ctr">
+              <a:lnSpc>
+                <a:spcPct val="122000"/>
+              </a:lnSpc>
+            </a:pPr>
+            <a:r>
+              <a:rPr sz="1300" b="1">
+                <a:solidFill>
+                  <a:srgbClr val="F5F5F8"/>
+                </a:solidFill>
+                <a:latin typeface="Amazon Ember"/>
+                <a:ea typeface="メイリオ"/>
+                <a:cs typeface="メイリオ"/>
+              </a:rPr>
+              <a:t>blue, across chunks: a blue row times x1..x3</a:t>
+            </a:r>
+          </a:p>
+          <a:p>
+            <a:pPr algn="ctr">
+              <a:lnSpc>
+                <a:spcPct val="122000"/>
+              </a:lnSpc>
+            </a:pPr>
+            <a:r>
+              <a:rPr sz="1300" b="1">
+                <a:solidFill>
+                  <a:srgbClr val="F5F5F8"/>
+                </a:solidFill>
+                <a:latin typeface="Amazon Ember"/>
+                <a:ea typeface="メイリオ"/>
+                <a:cs typeface="メイリオ"/>
+              </a:rPr>
+              <a:t>= (top line) · h3</a:t>
+            </a:r>
+          </a:p>
+          <a:p>
+            <a:pPr algn="ctr">
+              <a:lnSpc>
+                <a:spcPct val="122000"/>
+              </a:lnSpc>
+            </a:pPr>
+            <a:r>
+              <a:rPr sz="1300" b="1">
+                <a:solidFill>
+                  <a:srgbClr val="F5F5F8"/>
+                </a:solidFill>
+                <a:latin typeface="Amazon Ember"/>
+                <a:ea typeface="メイリオ"/>
+                <a:cs typeface="メイリオ"/>
+              </a:rPr>
+              <a:t>h3 = a3a2b1 x1 + a3b2 x2 + b3 x3 = state after chunk 1</a:t>
+            </a:r>
+          </a:p>
+          <a:p>
+            <a:pPr algn="ctr">
+              <a:lnSpc>
+                <a:spcPct val="122000"/>
+              </a:lnSpc>
+            </a:pPr>
+            <a:r>
+              <a:rPr sz="1300" b="1">
+                <a:solidFill>
+                  <a:srgbClr val="F5F5F8"/>
+                </a:solidFill>
+                <a:latin typeface="Amazon Ember"/>
+                <a:ea typeface="メイリオ"/>
+                <a:cs typeface="メイリオ"/>
+              </a:rPr>
+              <a:t>so the blue block is never built: chunk 2 starts from h3</a:t>
+            </a:r>
+          </a:p>
+        </p:txBody>
+      </p:sp>
+      <p:sp>
+        <p:nvSpPr>
+          <p:cNvPr id="56" name="Rounded Rectangle 55"/>
+          <p:cNvSpPr/>
+          <p:nvPr/>
+        </p:nvSpPr>
+        <p:spPr>
+          <a:xfrm>
+            <a:off x="6667500" y="4686300"/>
+            <a:ext cx="5114925" cy="666750"/>
+          </a:xfrm>
+          <a:prstGeom prst="roundRect">
+            <a:avLst>
+              <a:gd name="adj" fmla="val 8000"/>
+            </a:avLst>
+          </a:prstGeom>
+          <a:solidFill>
+            <a:srgbClr val="50420E"/>
+          </a:solidFill>
+          <a:ln w="15875">
+            <a:solidFill>
+              <a:srgbClr val="FBD332"/>
+            </a:solidFill>
+          </a:ln>
+          <a:effectLst/>
+        </p:spPr>
+        <p:style>
+          <a:lnRef idx="1">
+            <a:schemeClr val="accent1"/>
+          </a:lnRef>
+          <a:fillRef idx="3">
+            <a:schemeClr val="accent1"/>
+          </a:fillRef>
+          <a:effectRef idx="2">
+            <a:schemeClr val="accent1"/>
+          </a:effectRef>
+          <a:fontRef idx="minor">
+            <a:schemeClr val="lt1"/>
+          </a:fontRef>
+        </p:style>
+        <p:txBody>
+          <a:bodyPr rtlCol="0" anchor="ctr" wrap="square" lIns="19050" rIns="19050" tIns="19050" bIns="19050"/>
+          <a:lstStyle/>
+          <a:p>
+            <a:pPr algn="ctr">
+              <a:lnSpc>
+                <a:spcPct val="122000"/>
+              </a:lnSpc>
+            </a:pPr>
+            <a:r>
+              <a:rPr sz="1400" b="1">
+                <a:solidFill>
+                  <a:srgbClr val="F5F5F8"/>
+                </a:solidFill>
+                <a:latin typeface="Amazon Ember"/>
+                <a:ea typeface="メイリオ"/>
+                <a:cs typeface="メイリオ"/>
+              </a:rPr>
+              <a:t>way 2 builds L x L entries; way 3 builds L x 128</a:t>
+            </a:r>
+          </a:p>
+          <a:p>
+            <a:pPr algn="ctr">
+              <a:lnSpc>
+                <a:spcPct val="122000"/>
+              </a:lnSpc>
+            </a:pPr>
+            <a:r>
+              <a:rPr sz="1400" b="1">
+                <a:solidFill>
+                  <a:srgbClr val="F5F5F8"/>
+                </a:solidFill>
+                <a:latin typeface="Amazon Ember"/>
+                <a:ea typeface="メイリオ"/>
+                <a:cs typeface="メイリオ"/>
+              </a:rPr>
+              <a:t>plus one state per chunk</a:t>
+            </a:r>
+          </a:p>
+        </p:txBody>
+      </p:sp>
+      <p:sp>
+        <p:nvSpPr>
+          <p:cNvPr id="57" name="TextBox 56"/>
+          <p:cNvSpPr txBox="1"/>
+          <p:nvPr/>
+        </p:nvSpPr>
+        <p:spPr>
+          <a:xfrm>
+            <a:off x="409575" y="5619750"/>
+            <a:ext cx="11372850" cy="285750"/>
+          </a:xfrm>
+          <a:prstGeom prst="rect">
+            <a:avLst/>
+          </a:prstGeom>
+          <a:noFill/>
+        </p:spPr>
+        <p:txBody>
+          <a:bodyPr wrap="square" lIns="0" rIns="0" tIns="0" bIns="0" anchor="ctr">
+            <a:spAutoFit/>
+          </a:bodyPr>
+          <a:lstStyle/>
+          <a:p>
+            <a:pPr algn="ctr">
+              <a:lnSpc>
+                <a:spcPct val="122000"/>
+              </a:lnSpc>
+            </a:pPr>
+            <a:r>
+              <a:rPr sz="1300" b="0">
+                <a:solidFill>
+                  <a:srgbClr val="96969E"/>
+                </a:solidFill>
+                <a:latin typeface="Amazon Ember"/>
+                <a:ea typeface="メイリオ"/>
+                <a:cs typeface="メイリオ"/>
+              </a:rPr>
+              <a:t>In Mamba2: a = exp(dt · A) (between 0 and 1), b = dt · B, c = C; x and h are per head, the structure is the same</a:t>
             </a:r>
           </a:p>
         </p:txBody>

</xml_diff>